<commit_message>
Rename portfolio repository references
</commit_message>
<xml_diff>
--- a/Presentation/Pf_LeroyBrown_ITAI2373.pptx
+++ b/Presentation/Pf_LeroyBrown_ITAI2373.pptx
@@ -2,17 +2,17 @@
 <file path=ppt/presentation.xml><?xml version="1.0" encoding="utf-8"?>
 <p:presentation xmlns:p="http://schemas.openxmlformats.org/presentationml/2006/main">
   <p:sldMasterIdLst>
-    <p:sldMasterId xmlns:r="http://schemas.openxmlformats.org/officeDocument/2006/relationships" id="2147483648" r:id="R96fa1debd2b749c8"/>
+    <p:sldMasterId xmlns:r="http://schemas.openxmlformats.org/officeDocument/2006/relationships" id="2147483648" r:id="R5e095a60db424897"/>
   </p:sldMasterIdLst>
   <p:notesMasterIdLst>
-    <p:notesMasterId xmlns:r="http://schemas.openxmlformats.org/officeDocument/2006/relationships" r:id="Rb18fb4dc79984d13"/>
+    <p:notesMasterId xmlns:r="http://schemas.openxmlformats.org/officeDocument/2006/relationships" r:id="Red8ee7e14d5745a2"/>
   </p:notesMasterIdLst>
   <p:sldIdLst>
-    <p:sldId xmlns:r="http://schemas.openxmlformats.org/officeDocument/2006/relationships" id="256" r:id="Rf524b64c012c4054"/>
-    <p:sldId xmlns:r="http://schemas.openxmlformats.org/officeDocument/2006/relationships" id="257" r:id="Re6002b2c311241b0"/>
-    <p:sldId xmlns:r="http://schemas.openxmlformats.org/officeDocument/2006/relationships" id="258" r:id="R86e1392f614b469b"/>
-    <p:sldId xmlns:r="http://schemas.openxmlformats.org/officeDocument/2006/relationships" id="259" r:id="R88b3c0466b2644c3"/>
-    <p:sldId xmlns:r="http://schemas.openxmlformats.org/officeDocument/2006/relationships" id="260" r:id="R15e81c21e9244496"/>
+    <p:sldId xmlns:r="http://schemas.openxmlformats.org/officeDocument/2006/relationships" id="256" r:id="R4cce767d7cb7456c"/>
+    <p:sldId xmlns:r="http://schemas.openxmlformats.org/officeDocument/2006/relationships" id="257" r:id="R9812575cad504605"/>
+    <p:sldId xmlns:r="http://schemas.openxmlformats.org/officeDocument/2006/relationships" id="258" r:id="R28d26150b4ee486a"/>
+    <p:sldId xmlns:r="http://schemas.openxmlformats.org/officeDocument/2006/relationships" id="259" r:id="R7f755a3f1681413f"/>
+    <p:sldId xmlns:r="http://schemas.openxmlformats.org/officeDocument/2006/relationships" id="260" r:id="R9843b6b0b1604659"/>
   </p:sldIdLst>
   <p:sldSz cx="12192000" cy="6858000"/>
   <p:notesSz cx="6858000" cy="9144000"/>
@@ -325,7 +325,61 @@
           <a:effectLst>
             <a:outerShdw blurRad="57150" dist="19050" dir="5400000">
               <a:srgbClr val="000000">
-                <a:alpha val="63000"/>
+                <a:alpha val="16000"/>
+              </a:srgbClr>
+            </a:outerShdw>
+          </a:effectLst>
+        </a:effectStyle>
+        <a:effectStyle>
+          <a:effectLst>
+            <a:outerShdw blurRad="19050" dist="9525" dir="5400000">
+              <a:srgbClr val="000000">
+                <a:alpha val="6000"/>
+              </a:srgbClr>
+            </a:outerShdw>
+          </a:effectLst>
+        </a:effectStyle>
+        <a:effectStyle>
+          <a:effectLst>
+            <a:outerShdw blurRad="28575" dist="9525" dir="5400000">
+              <a:srgbClr val="000000">
+                <a:alpha val="8000"/>
+              </a:srgbClr>
+            </a:outerShdw>
+          </a:effectLst>
+        </a:effectStyle>
+        <a:effectStyle>
+          <a:effectLst>
+            <a:outerShdw blurRad="57150" dist="19050" dir="5400000">
+              <a:srgbClr val="000000">
+                <a:alpha val="10000"/>
+              </a:srgbClr>
+            </a:outerShdw>
+          </a:effectLst>
+        </a:effectStyle>
+        <a:effectStyle>
+          <a:effectLst>
+            <a:outerShdw blurRad="114300" dist="38100" dir="5400000">
+              <a:srgbClr val="000000">
+                <a:alpha val="12000"/>
+              </a:srgbClr>
+            </a:outerShdw>
+          </a:effectLst>
+        </a:effectStyle>
+        <a:effectStyle>
+          <a:effectLst>
+            <a:outerShdw blurRad="171450" dist="57150" dir="5400000">
+              <a:srgbClr val="000000">
+                <a:alpha val="16000"/>
+              </a:srgbClr>
+            </a:outerShdw>
+          </a:effectLst>
+        </a:effectStyle>
+        <a:effectStyle>
+          <a:effectLst>
+            <a:outerShdw blurRad="266700" dist="95250" dir="5400000">
+              <a:srgbClr val="000000">
+                <a:alpha val="24000"/>
               </a:srgbClr>
             </a:outerShdw>
           </a:effectLst>
@@ -716,163 +770,6 @@
       <p:grpSpPr>
         <a:xfrm xmlns:a="http://schemas.openxmlformats.org/drawingml/2006/main"/>
       </p:grpSpPr>
-      <p:sp>
-        <p:nvSpPr>
-          <p:cNvPr id="1" name="Title 1">
-            <a:extLst xmlns:a="http://schemas.openxmlformats.org/drawingml/2006/main">
-              <a:ext uri="{FF2B5EF4-FFF2-40B4-BE49-F238E27FC236}">
-                <a16:creationId xmlns:a16="http://schemas.microsoft.com/office/drawing/2014/main" id="{C30425A0-AD2C-4D0B-A071-D59F0CABBBCE}"/>
-              </a:ext>
-            </a:extLst>
-          </p:cNvPr>
-          <p:cNvSpPr/>
-          <p:nvPr>
-            <p:ph type="ctrTitle" idx="0"/>
-          </p:nvPr>
-        </p:nvSpPr>
-        <p:spPr>
-          <a:xfrm xmlns:a="http://schemas.openxmlformats.org/drawingml/2006/main">
-            <a:off x="1524000" y="1122363"/>
-            <a:ext cx="9144000" cy="2387600"/>
-          </a:xfrm>
-        </p:spPr>
-        <p:txBody>
-          <a:bodyPr xmlns:a="http://schemas.openxmlformats.org/drawingml/2006/main" anchor="b"/>
-          <a:lstStyle xmlns:a="http://schemas.openxmlformats.org/drawingml/2006/main">
-            <a:lvl1pPr algn="ctr">
-              <a:buNone/>
-              <a:defRPr sz="6000"/>
-            </a:lvl1pPr>
-          </a:lstStyle>
-          <a:p xmlns:a="http://schemas.openxmlformats.org/drawingml/2006/main"/>
-        </p:txBody>
-      </p:sp>
-      <p:sp>
-        <p:nvSpPr>
-          <p:cNvPr id="2" name="Subtitle 2">
-            <a:extLst xmlns:a="http://schemas.openxmlformats.org/drawingml/2006/main">
-              <a:ext uri="{FF2B5EF4-FFF2-40B4-BE49-F238E27FC236}">
-                <a16:creationId xmlns:a16="http://schemas.microsoft.com/office/drawing/2014/main" id="{B1A7C220-D8D7-4773-8B67-9F1133845925}"/>
-              </a:ext>
-            </a:extLst>
-          </p:cNvPr>
-          <p:cNvSpPr/>
-          <p:nvPr>
-            <p:ph type="subTitle" idx="1"/>
-          </p:nvPr>
-        </p:nvSpPr>
-        <p:spPr>
-          <a:xfrm xmlns:a="http://schemas.openxmlformats.org/drawingml/2006/main">
-            <a:off x="1524000" y="3602038"/>
-            <a:ext cx="9144000" cy="1655762"/>
-          </a:xfrm>
-        </p:spPr>
-        <p:txBody>
-          <a:bodyPr xmlns:a="http://schemas.openxmlformats.org/drawingml/2006/main"/>
-          <a:lstStyle xmlns:a="http://schemas.openxmlformats.org/drawingml/2006/main">
-            <a:lvl1pPr marL="0" indent="0" algn="ctr">
-              <a:buNone/>
-              <a:defRPr sz="2400"/>
-            </a:lvl1pPr>
-            <a:lvl2pPr marL="457200" indent="0" algn="ctr">
-              <a:buNone/>
-              <a:defRPr sz="2000"/>
-            </a:lvl2pPr>
-            <a:lvl3pPr marL="914400" indent="0" algn="ctr">
-              <a:buNone/>
-              <a:defRPr sz="1800"/>
-            </a:lvl3pPr>
-            <a:lvl4pPr marL="1371600" indent="0" algn="ctr">
-              <a:buNone/>
-              <a:defRPr sz="1600"/>
-            </a:lvl4pPr>
-            <a:lvl5pPr marL="1828800" indent="0" algn="ctr">
-              <a:buNone/>
-              <a:defRPr sz="1600"/>
-            </a:lvl5pPr>
-            <a:lvl6pPr marL="2286000" indent="0" algn="ctr">
-              <a:buNone/>
-              <a:defRPr sz="1600"/>
-            </a:lvl6pPr>
-            <a:lvl7pPr marL="2743200" indent="0" algn="ctr">
-              <a:buNone/>
-              <a:defRPr sz="1600"/>
-            </a:lvl7pPr>
-            <a:lvl8pPr marL="3200400" indent="0" algn="ctr">
-              <a:buNone/>
-              <a:defRPr sz="1600"/>
-            </a:lvl8pPr>
-            <a:lvl9pPr marL="3657600" indent="0" algn="ctr">
-              <a:buNone/>
-              <a:defRPr sz="1600"/>
-            </a:lvl9pPr>
-          </a:lstStyle>
-          <a:p xmlns:a="http://schemas.openxmlformats.org/drawingml/2006/main"/>
-        </p:txBody>
-      </p:sp>
-      <p:sp>
-        <p:nvSpPr>
-          <p:cNvPr id="3" name="Date Placeholder 3">
-            <a:extLst xmlns:a="http://schemas.openxmlformats.org/drawingml/2006/main">
-              <a:ext uri="{FF2B5EF4-FFF2-40B4-BE49-F238E27FC236}">
-                <a16:creationId xmlns:a16="http://schemas.microsoft.com/office/drawing/2014/main" id="{57148D2E-6660-4D1D-81F8-AF1804D19FEA}"/>
-              </a:ext>
-            </a:extLst>
-          </p:cNvPr>
-          <p:cNvSpPr/>
-          <p:nvPr>
-            <p:ph type="dt" idx="10"/>
-          </p:nvPr>
-        </p:nvSpPr>
-        <p:spPr/>
-        <p:txBody>
-          <a:bodyPr xmlns:a="http://schemas.openxmlformats.org/drawingml/2006/main"/>
-          <a:lstStyle xmlns:a="http://schemas.openxmlformats.org/drawingml/2006/main"/>
-          <a:p xmlns:a="http://schemas.openxmlformats.org/drawingml/2006/main"/>
-        </p:txBody>
-      </p:sp>
-      <p:sp>
-        <p:nvSpPr>
-          <p:cNvPr id="4" name="Footer Placeholder 4">
-            <a:extLst xmlns:a="http://schemas.openxmlformats.org/drawingml/2006/main">
-              <a:ext uri="{FF2B5EF4-FFF2-40B4-BE49-F238E27FC236}">
-                <a16:creationId xmlns:a16="http://schemas.microsoft.com/office/drawing/2014/main" id="{E4C44892-3C3A-46DE-8119-CC93FA05ED08}"/>
-              </a:ext>
-            </a:extLst>
-          </p:cNvPr>
-          <p:cNvSpPr/>
-          <p:nvPr>
-            <p:ph type="ftr" idx="11"/>
-          </p:nvPr>
-        </p:nvSpPr>
-        <p:spPr/>
-        <p:txBody>
-          <a:bodyPr xmlns:a="http://schemas.openxmlformats.org/drawingml/2006/main"/>
-          <a:lstStyle xmlns:a="http://schemas.openxmlformats.org/drawingml/2006/main"/>
-          <a:p xmlns:a="http://schemas.openxmlformats.org/drawingml/2006/main"/>
-        </p:txBody>
-      </p:sp>
-      <p:sp>
-        <p:nvSpPr>
-          <p:cNvPr id="5" name="Slide Number Placeholder 5">
-            <a:extLst xmlns:a="http://schemas.openxmlformats.org/drawingml/2006/main">
-              <a:ext uri="{FF2B5EF4-FFF2-40B4-BE49-F238E27FC236}">
-                <a16:creationId xmlns:a16="http://schemas.microsoft.com/office/drawing/2014/main" id="{B8270420-D236-4471-AE86-CB207C63A521}"/>
-              </a:ext>
-            </a:extLst>
-          </p:cNvPr>
-          <p:cNvSpPr/>
-          <p:nvPr>
-            <p:ph type="sldNum" idx="12"/>
-          </p:nvPr>
-        </p:nvSpPr>
-        <p:spPr/>
-        <p:txBody>
-          <a:bodyPr xmlns:a="http://schemas.openxmlformats.org/drawingml/2006/main"/>
-          <a:lstStyle xmlns:a="http://schemas.openxmlformats.org/drawingml/2006/main"/>
-          <a:p xmlns:a="http://schemas.openxmlformats.org/drawingml/2006/main"/>
-        </p:txBody>
-      </p:sp>
     </p:spTree>
   </p:cSld>
 </p:sldLayout>
@@ -895,51 +792,11 @@
       <p:grpSpPr>
         <a:xfrm xmlns:a="http://schemas.openxmlformats.org/drawingml/2006/main"/>
       </p:grpSpPr>
-      <p:sp>
-        <p:nvSpPr>
-          <p:cNvPr id="1" name="Slide Number Placeholder 5">
-            <a:extLst xmlns:a="http://schemas.openxmlformats.org/drawingml/2006/main">
-              <a:ext uri="{FF2B5EF4-FFF2-40B4-BE49-F238E27FC236}">
-                <a16:creationId xmlns:a16="http://schemas.microsoft.com/office/drawing/2014/main" id="{BBA9116B-ED95-4B2F-9DD2-80C7C12A3261}"/>
-              </a:ext>
-            </a:extLst>
-          </p:cNvPr>
-          <p:cNvSpPr/>
-          <p:nvPr>
-            <p:ph type="sldNum" idx="4"/>
-          </p:nvPr>
-        </p:nvSpPr>
-        <p:spPr>
-          <a:xfrm xmlns:a="http://schemas.openxmlformats.org/drawingml/2006/main">
-            <a:off x="8610600" y="6356350"/>
-            <a:ext cx="2743200" cy="365125"/>
-          </a:xfrm>
-          <a:prstGeom xmlns:a="http://schemas.openxmlformats.org/drawingml/2006/main" prst="rect">
-            <a:avLst/>
-          </a:prstGeom>
-        </p:spPr>
-        <p:txBody>
-          <a:bodyPr xmlns:a="http://schemas.openxmlformats.org/drawingml/2006/main" vert="horz" lIns="91440" tIns="45720" rIns="91440" bIns="45720" anchor="ctr"/>
-          <a:lstStyle xmlns:a="http://schemas.openxmlformats.org/drawingml/2006/main">
-            <a:lvl1pPr algn="r">
-              <a:buNone/>
-              <a:defRPr sz="1200">
-                <a:solidFill>
-                  <a:schemeClr val="tx1">
-                    <a:tint val="82000"/>
-                  </a:schemeClr>
-                </a:solidFill>
-              </a:defRPr>
-            </a:lvl1pPr>
-          </a:lstStyle>
-          <a:p xmlns:a="http://schemas.openxmlformats.org/drawingml/2006/main"/>
-        </p:txBody>
-      </p:sp>
     </p:spTree>
   </p:cSld>
   <p:clrMap bg1="lt1" tx1="dk1" bg2="lt2" tx2="dk2" accent1="accent1" accent2="accent2" accent3="accent3" accent4="accent4" accent5="accent5" accent6="accent6" hlink="hlink" folHlink="folHlink"/>
   <p:sldLayoutIdLst>
-    <p:sldLayoutId xmlns:r="http://schemas.openxmlformats.org/officeDocument/2006/relationships" id="2147483649" r:id="Rc84d5c42a4c24a83"/>
+    <p:sldLayoutId xmlns:r="http://schemas.openxmlformats.org/officeDocument/2006/relationships" id="2147483649" r:id="R10c1b509b5204495"/>
   </p:sldLayoutIdLst>
   <p:txStyles>
     <p:titleStyle>
@@ -1242,42 +1099,10 @@
       </p:grpSpPr>
       <p:sp>
         <p:nvSpPr>
-          <p:cNvPr id="1" name="Slide Number Placeholder 5">
-            <a:extLst xmlns:a="http://schemas.openxmlformats.org/drawingml/2006/main">
-              <a:ext uri="{FF2B5EF4-FFF2-40B4-BE49-F238E27FC236}">
-                <a16:creationId xmlns:a16="http://schemas.microsoft.com/office/drawing/2014/main" id="{B8270420-D236-4471-AE86-CB207C63A521}"/>
-              </a:ext>
-            </a:extLst>
-          </p:cNvPr>
-          <p:cNvSpPr>
-            <a:spLocks xmlns:a="http://schemas.openxmlformats.org/drawingml/2006/main" noGrp="1"/>
-          </p:cNvSpPr>
-          <p:nvPr>
-            <p:ph type="sldNum" idx="12"/>
-          </p:nvPr>
-        </p:nvSpPr>
-        <p:spPr>
-          <a:xfrm xmlns:a="http://schemas.openxmlformats.org/drawingml/2006/main">
-            <a:off x="1524000" y="1122363"/>
-            <a:ext cx="9144000" cy="2387600"/>
-          </a:xfrm>
-        </p:spPr>
-        <p:txBody>
-          <a:bodyPr xmlns:a="http://schemas.openxmlformats.org/drawingml/2006/main"/>
-          <a:lstStyle xmlns:a="http://schemas.openxmlformats.org/drawingml/2006/main"/>
-          <a:p xmlns:a="http://schemas.openxmlformats.org/drawingml/2006/main">
-            <a:r>
-              <a:t/>
-            </a:r>
-          </a:p>
-        </p:txBody>
-      </p:sp>
-      <p:sp>
-        <p:nvSpPr>
-          <p:cNvPr id="2" name="">
-            <a:extLst xmlns:a="http://schemas.openxmlformats.org/drawingml/2006/main">
-              <a:ext uri="{FF2B5EF4-FFF2-40B4-BE49-F238E27FC236}">
-                <a16:creationId xmlns:a16="http://schemas.microsoft.com/office/drawing/2014/main" id="{A6ED63EF-36D4-4B63-A97C-97CB7D03DD00}"/>
+          <p:cNvPr id="1" name="">
+            <a:extLst xmlns:a="http://schemas.openxmlformats.org/drawingml/2006/main">
+              <a:ext uri="{FF2B5EF4-FFF2-40B4-BE49-F238E27FC236}">
+                <a16:creationId xmlns:a16="http://schemas.microsoft.com/office/drawing/2014/main" id="{A8FDD4CA-AABB-42C1-9208-3376C1BD9D94}"/>
               </a:ext>
             </a:extLst>
           </p:cNvPr>
@@ -1306,10 +1131,10 @@
       </p:sp>
       <p:sp>
         <p:nvSpPr>
-          <p:cNvPr id="3" name="">
-            <a:extLst xmlns:a="http://schemas.openxmlformats.org/drawingml/2006/main">
-              <a:ext uri="{FF2B5EF4-FFF2-40B4-BE49-F238E27FC236}">
-                <a16:creationId xmlns:a16="http://schemas.microsoft.com/office/drawing/2014/main" id="{EFC28153-01F0-49FA-80B7-628557652AB7}"/>
+          <p:cNvPr id="2" name="">
+            <a:extLst xmlns:a="http://schemas.openxmlformats.org/drawingml/2006/main">
+              <a:ext uri="{FF2B5EF4-FFF2-40B4-BE49-F238E27FC236}">
+                <a16:creationId xmlns:a16="http://schemas.microsoft.com/office/drawing/2014/main" id="{6E33284C-CB08-47AC-8F9F-B7E2D5FE95A5}"/>
               </a:ext>
             </a:extLst>
           </p:cNvPr>
@@ -1338,10 +1163,10 @@
       </p:sp>
       <p:sp>
         <p:nvSpPr>
-          <p:cNvPr id="4" name="">
-            <a:extLst xmlns:a="http://schemas.openxmlformats.org/drawingml/2006/main">
-              <a:ext uri="{FF2B5EF4-FFF2-40B4-BE49-F238E27FC236}">
-                <a16:creationId xmlns:a16="http://schemas.microsoft.com/office/drawing/2014/main" id="{4E49750B-7546-4246-AB44-669A53D67954}"/>
+          <p:cNvPr id="3" name="">
+            <a:extLst xmlns:a="http://schemas.openxmlformats.org/drawingml/2006/main">
+              <a:ext uri="{FF2B5EF4-FFF2-40B4-BE49-F238E27FC236}">
+                <a16:creationId xmlns:a16="http://schemas.microsoft.com/office/drawing/2014/main" id="{2D6E6847-47FB-4E79-BB80-6B724907AF06}"/>
               </a:ext>
             </a:extLst>
           </p:cNvPr>
@@ -1370,10 +1195,10 @@
       </p:sp>
       <p:sp>
         <p:nvSpPr>
-          <p:cNvPr id="5" name="">
-            <a:extLst xmlns:a="http://schemas.openxmlformats.org/drawingml/2006/main">
-              <a:ext uri="{FF2B5EF4-FFF2-40B4-BE49-F238E27FC236}">
-                <a16:creationId xmlns:a16="http://schemas.microsoft.com/office/drawing/2014/main" id="{898B3356-581D-49C8-AC93-1DD38B5B95EF}"/>
+          <p:cNvPr id="4" name="">
+            <a:extLst xmlns:a="http://schemas.openxmlformats.org/drawingml/2006/main">
+              <a:ext uri="{FF2B5EF4-FFF2-40B4-BE49-F238E27FC236}">
+                <a16:creationId xmlns:a16="http://schemas.microsoft.com/office/drawing/2014/main" id="{1E89D764-8872-40F2-AA81-1E944E3FDE1D}"/>
               </a:ext>
             </a:extLst>
           </p:cNvPr>
@@ -1405,6 +1230,9 @@
                 <a:solidFill>
                   <a:srgbClr val="FFFFFF"/>
                 </a:solidFill>
+                <a:latin typeface="Poppins"/>
+                <a:ea typeface="Poppins"/>
+                <a:cs typeface="Poppins"/>
               </a:defRPr>
             </a:pPr>
             <a:r>
@@ -1412,6 +1240,9 @@
                 <a:solidFill>
                   <a:srgbClr val="FFFFFF"/>
                 </a:solidFill>
+                <a:latin typeface="Poppins"/>
+                <a:ea typeface="Poppins"/>
+                <a:cs typeface="Poppins"/>
               </a:rPr>
               <a:t>Leroy Brown</a:t>
             </a:r>
@@ -1420,10 +1251,10 @@
       </p:sp>
       <p:sp>
         <p:nvSpPr>
-          <p:cNvPr id="6" name="">
-            <a:extLst xmlns:a="http://schemas.openxmlformats.org/drawingml/2006/main">
-              <a:ext uri="{FF2B5EF4-FFF2-40B4-BE49-F238E27FC236}">
-                <a16:creationId xmlns:a16="http://schemas.microsoft.com/office/drawing/2014/main" id="{215112A0-960E-40CE-9CAE-71374643DA06}"/>
+          <p:cNvPr id="5" name="">
+            <a:extLst xmlns:a="http://schemas.openxmlformats.org/drawingml/2006/main">
+              <a:ext uri="{FF2B5EF4-FFF2-40B4-BE49-F238E27FC236}">
+                <a16:creationId xmlns:a16="http://schemas.microsoft.com/office/drawing/2014/main" id="{CC243015-1178-4818-AD2A-5F3213AE224B}"/>
               </a:ext>
             </a:extLst>
           </p:cNvPr>
@@ -1455,6 +1286,9 @@
                 <a:solidFill>
                   <a:srgbClr val="12A8C8"/>
                 </a:solidFill>
+                <a:latin typeface="Lato"/>
+                <a:ea typeface="Lato"/>
+                <a:cs typeface="Lato"/>
               </a:defRPr>
             </a:pPr>
             <a:r>
@@ -1462,6 +1296,9 @@
                 <a:solidFill>
                   <a:srgbClr val="12A8C8"/>
                 </a:solidFill>
+                <a:latin typeface="Lato"/>
+                <a:ea typeface="Lato"/>
+                <a:cs typeface="Lato"/>
               </a:rPr>
               <a:t>Applied AI &amp; Robotics</a:t>
             </a:r>
@@ -1470,10 +1307,10 @@
       </p:sp>
       <p:sp>
         <p:nvSpPr>
-          <p:cNvPr id="7" name="">
-            <a:extLst xmlns:a="http://schemas.openxmlformats.org/drawingml/2006/main">
-              <a:ext uri="{FF2B5EF4-FFF2-40B4-BE49-F238E27FC236}">
-                <a16:creationId xmlns:a16="http://schemas.microsoft.com/office/drawing/2014/main" id="{13CEDE71-7FE5-48FB-9D5B-47A5A9A0EC47}"/>
+          <p:cNvPr id="6" name="">
+            <a:extLst xmlns:a="http://schemas.openxmlformats.org/drawingml/2006/main">
+              <a:ext uri="{FF2B5EF4-FFF2-40B4-BE49-F238E27FC236}">
+                <a16:creationId xmlns:a16="http://schemas.microsoft.com/office/drawing/2014/main" id="{45A00024-E7BC-4861-8B21-77BDD681B5ED}"/>
               </a:ext>
             </a:extLst>
           </p:cNvPr>
@@ -1498,7 +1335,7 @@
         </p:spPr>
         <p:txBody>
           <a:bodyPr xmlns:a="http://schemas.openxmlformats.org/drawingml/2006/main" lIns="0" tIns="0" rIns="0" bIns="0" anchor="t">
-            <a:normAutofit fontScale="91584"/>
+            <a:normAutofit fontScale="91049"/>
           </a:bodyPr>
           <a:lstStyle xmlns:a="http://schemas.openxmlformats.org/drawingml/2006/main"/>
           <a:p xmlns:a="http://schemas.openxmlformats.org/drawingml/2006/main">
@@ -1507,6 +1344,9 @@
                 <a:solidFill>
                   <a:srgbClr val="EAF2FF"/>
                 </a:solidFill>
+                <a:latin typeface="Lato"/>
+                <a:ea typeface="Lato"/>
+                <a:cs typeface="Lato"/>
               </a:defRPr>
             </a:pPr>
             <a:r>
@@ -1514,6 +1354,9 @@
                 <a:solidFill>
                   <a:srgbClr val="EAF2FF"/>
                 </a:solidFill>
+                <a:latin typeface="Lato"/>
+                <a:ea typeface="Lato"/>
+                <a:cs typeface="Lato"/>
               </a:rPr>
               <a:t>Production AI systems, NLP intelligence, governance controls, and deployed software.</a:t>
             </a:r>
@@ -1522,10 +1365,10 @@
       </p:sp>
       <p:sp>
         <p:nvSpPr>
-          <p:cNvPr id="8" name="">
-            <a:extLst xmlns:a="http://schemas.openxmlformats.org/drawingml/2006/main">
-              <a:ext uri="{FF2B5EF4-FFF2-40B4-BE49-F238E27FC236}">
-                <a16:creationId xmlns:a16="http://schemas.microsoft.com/office/drawing/2014/main" id="{4FE15F5F-DBFF-4614-ADDD-470D860754CE}"/>
+          <p:cNvPr id="7" name="">
+            <a:extLst xmlns:a="http://schemas.openxmlformats.org/drawingml/2006/main">
+              <a:ext uri="{FF2B5EF4-FFF2-40B4-BE49-F238E27FC236}">
+                <a16:creationId xmlns:a16="http://schemas.microsoft.com/office/drawing/2014/main" id="{29E98E56-67E2-4703-BB6C-C550F1404052}"/>
               </a:ext>
             </a:extLst>
           </p:cNvPr>
@@ -1562,6 +1405,9 @@
                 <a:solidFill>
                   <a:srgbClr val="FFFFFF"/>
                 </a:solidFill>
+                <a:latin typeface="Lato"/>
+                <a:ea typeface="Lato"/>
+                <a:cs typeface="Lato"/>
               </a:defRPr>
             </a:pPr>
             <a:r>
@@ -1569,6 +1415,9 @@
                 <a:solidFill>
                   <a:srgbClr val="FFFFFF"/>
                 </a:solidFill>
+                <a:latin typeface="Lato"/>
+                <a:ea typeface="Lato"/>
+                <a:cs typeface="Lato"/>
               </a:rPr>
               <a:t>GitHub Portfolio</a:t>
             </a:r>
@@ -1577,10 +1426,10 @@
       </p:sp>
       <p:sp>
         <p:nvSpPr>
-          <p:cNvPr id="9" name="">
-            <a:extLst xmlns:a="http://schemas.openxmlformats.org/drawingml/2006/main">
-              <a:ext uri="{FF2B5EF4-FFF2-40B4-BE49-F238E27FC236}">
-                <a16:creationId xmlns:a16="http://schemas.microsoft.com/office/drawing/2014/main" id="{05772DA1-3460-461C-91C6-77E666FD3674}"/>
+          <p:cNvPr id="8" name="">
+            <a:extLst xmlns:a="http://schemas.openxmlformats.org/drawingml/2006/main">
+              <a:ext uri="{FF2B5EF4-FFF2-40B4-BE49-F238E27FC236}">
+                <a16:creationId xmlns:a16="http://schemas.microsoft.com/office/drawing/2014/main" id="{D08EC768-2203-4F9C-8A80-10833C763B9B}"/>
               </a:ext>
             </a:extLst>
           </p:cNvPr>
@@ -1614,6 +1463,9 @@
                 <a:solidFill>
                   <a:srgbClr val="FFFFFF"/>
                 </a:solidFill>
+                <a:latin typeface="Lato"/>
+                <a:ea typeface="Lato"/>
+                <a:cs typeface="Lato"/>
               </a:defRPr>
             </a:pPr>
             <a:r>
@@ -1621,18 +1473,21 @@
                 <a:solidFill>
                   <a:srgbClr val="FFFFFF"/>
                 </a:solidFill>
-              </a:rPr>
-              <a:t>github.com/icheftech/AI-Portfolio-Leroy-Brown</a:t>
-            </a:r>
-          </a:p>
-        </p:txBody>
-      </p:sp>
-      <p:sp>
-        <p:nvSpPr>
-          <p:cNvPr id="10" name="">
-            <a:extLst xmlns:a="http://schemas.openxmlformats.org/drawingml/2006/main">
-              <a:ext uri="{FF2B5EF4-FFF2-40B4-BE49-F238E27FC236}">
-                <a16:creationId xmlns:a16="http://schemas.microsoft.com/office/drawing/2014/main" id="{D3339D14-0337-4DC9-AD66-1B377F337074}"/>
+                <a:latin typeface="Lato"/>
+                <a:ea typeface="Lato"/>
+                <a:cs typeface="Lato"/>
+              </a:rPr>
+              <a:t>github.com/icheftech/Leroy-Brown-HCC-AI-Portfolio</a:t>
+            </a:r>
+          </a:p>
+        </p:txBody>
+      </p:sp>
+      <p:sp>
+        <p:nvSpPr>
+          <p:cNvPr id="9" name="">
+            <a:extLst xmlns:a="http://schemas.openxmlformats.org/drawingml/2006/main">
+              <a:ext uri="{FF2B5EF4-FFF2-40B4-BE49-F238E27FC236}">
+                <a16:creationId xmlns:a16="http://schemas.microsoft.com/office/drawing/2014/main" id="{79D20579-8ACB-4AEA-B64B-5D36114DA81F}"/>
               </a:ext>
             </a:extLst>
           </p:cNvPr>
@@ -1663,10 +1518,10 @@
       </p:sp>
       <p:sp>
         <p:nvSpPr>
-          <p:cNvPr id="11" name="">
-            <a:extLst xmlns:a="http://schemas.openxmlformats.org/drawingml/2006/main">
-              <a:ext uri="{FF2B5EF4-FFF2-40B4-BE49-F238E27FC236}">
-                <a16:creationId xmlns:a16="http://schemas.microsoft.com/office/drawing/2014/main" id="{5CCA2C40-86FE-444C-AADA-CAE965B0F39C}"/>
+          <p:cNvPr id="10" name="">
+            <a:extLst xmlns:a="http://schemas.openxmlformats.org/drawingml/2006/main">
+              <a:ext uri="{FF2B5EF4-FFF2-40B4-BE49-F238E27FC236}">
+                <a16:creationId xmlns:a16="http://schemas.microsoft.com/office/drawing/2014/main" id="{6AC839D3-558D-4E88-A2D4-ADA9E88AC536}"/>
               </a:ext>
             </a:extLst>
           </p:cNvPr>
@@ -1697,10 +1552,10 @@
       </p:sp>
       <p:sp>
         <p:nvSpPr>
-          <p:cNvPr id="12" name="">
-            <a:extLst xmlns:a="http://schemas.openxmlformats.org/drawingml/2006/main">
-              <a:ext uri="{FF2B5EF4-FFF2-40B4-BE49-F238E27FC236}">
-                <a16:creationId xmlns:a16="http://schemas.microsoft.com/office/drawing/2014/main" id="{05DA6F32-97E9-4023-876C-EF16BD717636}"/>
+          <p:cNvPr id="11" name="">
+            <a:extLst xmlns:a="http://schemas.openxmlformats.org/drawingml/2006/main">
+              <a:ext uri="{FF2B5EF4-FFF2-40B4-BE49-F238E27FC236}">
+                <a16:creationId xmlns:a16="http://schemas.microsoft.com/office/drawing/2014/main" id="{03FDA33F-31BC-4502-AAE6-B8F1E9C2EE28}"/>
               </a:ext>
             </a:extLst>
           </p:cNvPr>
@@ -1729,10 +1584,10 @@
       </p:sp>
       <p:sp>
         <p:nvSpPr>
-          <p:cNvPr id="13" name="">
-            <a:extLst xmlns:a="http://schemas.openxmlformats.org/drawingml/2006/main">
-              <a:ext uri="{FF2B5EF4-FFF2-40B4-BE49-F238E27FC236}">
-                <a16:creationId xmlns:a16="http://schemas.microsoft.com/office/drawing/2014/main" id="{7EBAE38F-B8C4-4AEF-AE8B-A44FB4533691}"/>
+          <p:cNvPr id="12" name="">
+            <a:extLst xmlns:a="http://schemas.openxmlformats.org/drawingml/2006/main">
+              <a:ext uri="{FF2B5EF4-FFF2-40B4-BE49-F238E27FC236}">
+                <a16:creationId xmlns:a16="http://schemas.microsoft.com/office/drawing/2014/main" id="{DF8BE61A-250A-415A-9DE3-CD06E4291835}"/>
               </a:ext>
             </a:extLst>
           </p:cNvPr>
@@ -1764,6 +1619,9 @@
                 <a:solidFill>
                   <a:srgbClr val="102033"/>
                 </a:solidFill>
+                <a:latin typeface="Lato"/>
+                <a:ea typeface="Lato"/>
+                <a:cs typeface="Lato"/>
               </a:defRPr>
             </a:pPr>
             <a:r>
@@ -1771,6 +1629,9 @@
                 <a:solidFill>
                   <a:srgbClr val="102033"/>
                 </a:solidFill>
+                <a:latin typeface="Lato"/>
+                <a:ea typeface="Lato"/>
+                <a:cs typeface="Lato"/>
               </a:rPr>
               <a:t>NLP Intelligence</a:t>
             </a:r>
@@ -1779,10 +1640,10 @@
       </p:sp>
       <p:sp>
         <p:nvSpPr>
-          <p:cNvPr id="14" name="">
-            <a:extLst xmlns:a="http://schemas.openxmlformats.org/drawingml/2006/main">
-              <a:ext uri="{FF2B5EF4-FFF2-40B4-BE49-F238E27FC236}">
-                <a16:creationId xmlns:a16="http://schemas.microsoft.com/office/drawing/2014/main" id="{76993888-BA54-457F-8CFC-3C0A32C22577}"/>
+          <p:cNvPr id="13" name="">
+            <a:extLst xmlns:a="http://schemas.openxmlformats.org/drawingml/2006/main">
+              <a:ext uri="{FF2B5EF4-FFF2-40B4-BE49-F238E27FC236}">
+                <a16:creationId xmlns:a16="http://schemas.microsoft.com/office/drawing/2014/main" id="{580B9AB8-CA06-452D-A90E-4BCF94463B26}"/>
               </a:ext>
             </a:extLst>
           </p:cNvPr>
@@ -1816,6 +1677,9 @@
                 <a:solidFill>
                   <a:srgbClr val="5A6678"/>
                 </a:solidFill>
+                <a:latin typeface="Lato"/>
+                <a:ea typeface="Lato"/>
+                <a:cs typeface="Lato"/>
               </a:defRPr>
             </a:pPr>
             <a:r>
@@ -1823,6 +1687,9 @@
                 <a:solidFill>
                   <a:srgbClr val="5A6678"/>
                 </a:solidFill>
+                <a:latin typeface="Lato"/>
+                <a:ea typeface="Lato"/>
+                <a:cs typeface="Lato"/>
               </a:rPr>
               <a:t>NewsBot: topics, summaries, embeddings, sentiment, interactive exploration.</a:t>
             </a:r>
@@ -1831,10 +1698,10 @@
       </p:sp>
       <p:sp>
         <p:nvSpPr>
-          <p:cNvPr id="15" name="">
-            <a:extLst xmlns:a="http://schemas.openxmlformats.org/drawingml/2006/main">
-              <a:ext uri="{FF2B5EF4-FFF2-40B4-BE49-F238E27FC236}">
-                <a16:creationId xmlns:a16="http://schemas.microsoft.com/office/drawing/2014/main" id="{ED523274-BF6F-4CA7-AF6A-ED0A42FF5EF7}"/>
+          <p:cNvPr id="14" name="">
+            <a:extLst xmlns:a="http://schemas.openxmlformats.org/drawingml/2006/main">
+              <a:ext uri="{FF2B5EF4-FFF2-40B4-BE49-F238E27FC236}">
+                <a16:creationId xmlns:a16="http://schemas.microsoft.com/office/drawing/2014/main" id="{21A3382C-9BC8-4359-AF92-6605B2072E35}"/>
               </a:ext>
             </a:extLst>
           </p:cNvPr>
@@ -1865,10 +1732,10 @@
       </p:sp>
       <p:sp>
         <p:nvSpPr>
-          <p:cNvPr id="16" name="">
-            <a:extLst xmlns:a="http://schemas.openxmlformats.org/drawingml/2006/main">
-              <a:ext uri="{FF2B5EF4-FFF2-40B4-BE49-F238E27FC236}">
-                <a16:creationId xmlns:a16="http://schemas.microsoft.com/office/drawing/2014/main" id="{30DAAF05-7CC1-4583-9F6B-C9DFA6C0D209}"/>
+          <p:cNvPr id="15" name="">
+            <a:extLst xmlns:a="http://schemas.openxmlformats.org/drawingml/2006/main">
+              <a:ext uri="{FF2B5EF4-FFF2-40B4-BE49-F238E27FC236}">
+                <a16:creationId xmlns:a16="http://schemas.microsoft.com/office/drawing/2014/main" id="{474B51A6-B406-493A-94E8-92249E0F13F8}"/>
               </a:ext>
             </a:extLst>
           </p:cNvPr>
@@ -1899,10 +1766,10 @@
       </p:sp>
       <p:sp>
         <p:nvSpPr>
-          <p:cNvPr id="17" name="">
-            <a:extLst xmlns:a="http://schemas.openxmlformats.org/drawingml/2006/main">
-              <a:ext uri="{FF2B5EF4-FFF2-40B4-BE49-F238E27FC236}">
-                <a16:creationId xmlns:a16="http://schemas.microsoft.com/office/drawing/2014/main" id="{97496B39-96EF-460D-9225-71AE799F12FC}"/>
+          <p:cNvPr id="16" name="">
+            <a:extLst xmlns:a="http://schemas.openxmlformats.org/drawingml/2006/main">
+              <a:ext uri="{FF2B5EF4-FFF2-40B4-BE49-F238E27FC236}">
+                <a16:creationId xmlns:a16="http://schemas.microsoft.com/office/drawing/2014/main" id="{55F040D5-A2FD-4DE6-8BEA-65EE8CCEA141}"/>
               </a:ext>
             </a:extLst>
           </p:cNvPr>
@@ -1931,10 +1798,10 @@
       </p:sp>
       <p:sp>
         <p:nvSpPr>
-          <p:cNvPr id="18" name="">
-            <a:extLst xmlns:a="http://schemas.openxmlformats.org/drawingml/2006/main">
-              <a:ext uri="{FF2B5EF4-FFF2-40B4-BE49-F238E27FC236}">
-                <a16:creationId xmlns:a16="http://schemas.microsoft.com/office/drawing/2014/main" id="{81F0703D-0A0B-4A72-9B01-687FDADCB0BF}"/>
+          <p:cNvPr id="17" name="">
+            <a:extLst xmlns:a="http://schemas.openxmlformats.org/drawingml/2006/main">
+              <a:ext uri="{FF2B5EF4-FFF2-40B4-BE49-F238E27FC236}">
+                <a16:creationId xmlns:a16="http://schemas.microsoft.com/office/drawing/2014/main" id="{8623278C-CA09-46C2-96AE-A0D0F3915AA1}"/>
               </a:ext>
             </a:extLst>
           </p:cNvPr>
@@ -1966,6 +1833,9 @@
                 <a:solidFill>
                   <a:srgbClr val="102033"/>
                 </a:solidFill>
+                <a:latin typeface="Lato"/>
+                <a:ea typeface="Lato"/>
+                <a:cs typeface="Lato"/>
               </a:defRPr>
             </a:pPr>
             <a:r>
@@ -1973,6 +1843,9 @@
                 <a:solidFill>
                   <a:srgbClr val="102033"/>
                 </a:solidFill>
+                <a:latin typeface="Lato"/>
+                <a:ea typeface="Lato"/>
+                <a:cs typeface="Lato"/>
               </a:rPr>
               <a:t>Governed AI</a:t>
             </a:r>
@@ -1981,10 +1854,10 @@
       </p:sp>
       <p:sp>
         <p:nvSpPr>
-          <p:cNvPr id="19" name="">
-            <a:extLst xmlns:a="http://schemas.openxmlformats.org/drawingml/2006/main">
-              <a:ext uri="{FF2B5EF4-FFF2-40B4-BE49-F238E27FC236}">
-                <a16:creationId xmlns:a16="http://schemas.microsoft.com/office/drawing/2014/main" id="{A95CA61A-4481-4B2D-9F1C-69BE25927275}"/>
+          <p:cNvPr id="18" name="">
+            <a:extLst xmlns:a="http://schemas.openxmlformats.org/drawingml/2006/main">
+              <a:ext uri="{FF2B5EF4-FFF2-40B4-BE49-F238E27FC236}">
+                <a16:creationId xmlns:a16="http://schemas.microsoft.com/office/drawing/2014/main" id="{D40F8461-F606-4823-85F4-6CCFCCE13888}"/>
               </a:ext>
             </a:extLst>
           </p:cNvPr>
@@ -2018,6 +1891,9 @@
                 <a:solidFill>
                   <a:srgbClr val="5A6678"/>
                 </a:solidFill>
+                <a:latin typeface="Lato"/>
+                <a:ea typeface="Lato"/>
+                <a:cs typeface="Lato"/>
               </a:defRPr>
             </a:pPr>
             <a:r>
@@ -2025,6 +1901,9 @@
                 <a:solidFill>
                   <a:srgbClr val="5A6678"/>
                 </a:solidFill>
+                <a:latin typeface="Lato"/>
+                <a:ea typeface="Lato"/>
+                <a:cs typeface="Lato"/>
               </a:rPr>
               <a:t>SSO control plane: policy gates, approvals, kill switches, audit chains.</a:t>
             </a:r>
@@ -2033,10 +1912,10 @@
       </p:sp>
       <p:sp>
         <p:nvSpPr>
-          <p:cNvPr id="20" name="">
-            <a:extLst xmlns:a="http://schemas.openxmlformats.org/drawingml/2006/main">
-              <a:ext uri="{FF2B5EF4-FFF2-40B4-BE49-F238E27FC236}">
-                <a16:creationId xmlns:a16="http://schemas.microsoft.com/office/drawing/2014/main" id="{EDAF7F87-3786-476E-9B21-EBC9170F7135}"/>
+          <p:cNvPr id="19" name="">
+            <a:extLst xmlns:a="http://schemas.openxmlformats.org/drawingml/2006/main">
+              <a:ext uri="{FF2B5EF4-FFF2-40B4-BE49-F238E27FC236}">
+                <a16:creationId xmlns:a16="http://schemas.microsoft.com/office/drawing/2014/main" id="{F673B423-9F37-42D2-A322-CE238BEB1895}"/>
               </a:ext>
             </a:extLst>
           </p:cNvPr>
@@ -2067,10 +1946,10 @@
       </p:sp>
       <p:sp>
         <p:nvSpPr>
-          <p:cNvPr id="21" name="">
-            <a:extLst xmlns:a="http://schemas.openxmlformats.org/drawingml/2006/main">
-              <a:ext uri="{FF2B5EF4-FFF2-40B4-BE49-F238E27FC236}">
-                <a16:creationId xmlns:a16="http://schemas.microsoft.com/office/drawing/2014/main" id="{D7D08E18-5D9D-4312-A267-A5540BDB66C6}"/>
+          <p:cNvPr id="20" name="">
+            <a:extLst xmlns:a="http://schemas.openxmlformats.org/drawingml/2006/main">
+              <a:ext uri="{FF2B5EF4-FFF2-40B4-BE49-F238E27FC236}">
+                <a16:creationId xmlns:a16="http://schemas.microsoft.com/office/drawing/2014/main" id="{E7C0007D-98E0-4157-8F82-8FA6FD96D3D3}"/>
               </a:ext>
             </a:extLst>
           </p:cNvPr>
@@ -2101,10 +1980,10 @@
       </p:sp>
       <p:sp>
         <p:nvSpPr>
-          <p:cNvPr id="22" name="">
-            <a:extLst xmlns:a="http://schemas.openxmlformats.org/drawingml/2006/main">
-              <a:ext uri="{FF2B5EF4-FFF2-40B4-BE49-F238E27FC236}">
-                <a16:creationId xmlns:a16="http://schemas.microsoft.com/office/drawing/2014/main" id="{52FD467A-71DA-4737-A9A3-CE8A2DB72C16}"/>
+          <p:cNvPr id="21" name="">
+            <a:extLst xmlns:a="http://schemas.openxmlformats.org/drawingml/2006/main">
+              <a:ext uri="{FF2B5EF4-FFF2-40B4-BE49-F238E27FC236}">
+                <a16:creationId xmlns:a16="http://schemas.microsoft.com/office/drawing/2014/main" id="{F06A90E5-7F8F-4796-964F-48D40AACAC5C}"/>
               </a:ext>
             </a:extLst>
           </p:cNvPr>
@@ -2133,10 +2012,10 @@
       </p:sp>
       <p:sp>
         <p:nvSpPr>
-          <p:cNvPr id="23" name="">
-            <a:extLst xmlns:a="http://schemas.openxmlformats.org/drawingml/2006/main">
-              <a:ext uri="{FF2B5EF4-FFF2-40B4-BE49-F238E27FC236}">
-                <a16:creationId xmlns:a16="http://schemas.microsoft.com/office/drawing/2014/main" id="{B77FE850-8BEB-4286-B23D-360EC901E51D}"/>
+          <p:cNvPr id="22" name="">
+            <a:extLst xmlns:a="http://schemas.openxmlformats.org/drawingml/2006/main">
+              <a:ext uri="{FF2B5EF4-FFF2-40B4-BE49-F238E27FC236}">
+                <a16:creationId xmlns:a16="http://schemas.microsoft.com/office/drawing/2014/main" id="{FB8100DF-5B5E-4159-94ED-440A5A1C6FE6}"/>
               </a:ext>
             </a:extLst>
           </p:cNvPr>
@@ -2168,6 +2047,9 @@
                 <a:solidFill>
                   <a:srgbClr val="102033"/>
                 </a:solidFill>
+                <a:latin typeface="Lato"/>
+                <a:ea typeface="Lato"/>
+                <a:cs typeface="Lato"/>
               </a:defRPr>
             </a:pPr>
             <a:r>
@@ -2175,6 +2057,9 @@
                 <a:solidFill>
                   <a:srgbClr val="102033"/>
                 </a:solidFill>
+                <a:latin typeface="Lato"/>
+                <a:ea typeface="Lato"/>
+                <a:cs typeface="Lato"/>
               </a:rPr>
               <a:t>Agentic Workflows</a:t>
             </a:r>
@@ -2183,10 +2068,10 @@
       </p:sp>
       <p:sp>
         <p:nvSpPr>
-          <p:cNvPr id="24" name="">
-            <a:extLst xmlns:a="http://schemas.openxmlformats.org/drawingml/2006/main">
-              <a:ext uri="{FF2B5EF4-FFF2-40B4-BE49-F238E27FC236}">
-                <a16:creationId xmlns:a16="http://schemas.microsoft.com/office/drawing/2014/main" id="{57D048F4-1905-4558-9E90-9C191EE60A4E}"/>
+          <p:cNvPr id="23" name="">
+            <a:extLst xmlns:a="http://schemas.openxmlformats.org/drawingml/2006/main">
+              <a:ext uri="{FF2B5EF4-FFF2-40B4-BE49-F238E27FC236}">
+                <a16:creationId xmlns:a16="http://schemas.microsoft.com/office/drawing/2014/main" id="{A20456A7-8E38-492F-BEDF-45142075640C}"/>
               </a:ext>
             </a:extLst>
           </p:cNvPr>
@@ -2220,6 +2105,9 @@
                 <a:solidFill>
                   <a:srgbClr val="5A6678"/>
                 </a:solidFill>
+                <a:latin typeface="Lato"/>
+                <a:ea typeface="Lato"/>
+                <a:cs typeface="Lato"/>
               </a:defRPr>
             </a:pPr>
             <a:r>
@@ -2227,6 +2115,9 @@
                 <a:solidFill>
                   <a:srgbClr val="5A6678"/>
                 </a:solidFill>
+                <a:latin typeface="Lato"/>
+                <a:ea typeface="Lato"/>
+                <a:cs typeface="Lato"/>
               </a:rPr>
               <a:t>LangGraph systems for bids, cloud operations, and household automation.</a:t>
             </a:r>
@@ -2235,10 +2126,10 @@
       </p:sp>
       <p:sp>
         <p:nvSpPr>
-          <p:cNvPr id="25" name="">
-            <a:extLst xmlns:a="http://schemas.openxmlformats.org/drawingml/2006/main">
-              <a:ext uri="{FF2B5EF4-FFF2-40B4-BE49-F238E27FC236}">
-                <a16:creationId xmlns:a16="http://schemas.microsoft.com/office/drawing/2014/main" id="{D8FF98D4-8A3C-4550-8731-B280BE82C9D3}"/>
+          <p:cNvPr id="24" name="">
+            <a:extLst xmlns:a="http://schemas.openxmlformats.org/drawingml/2006/main">
+              <a:ext uri="{FF2B5EF4-FFF2-40B4-BE49-F238E27FC236}">
+                <a16:creationId xmlns:a16="http://schemas.microsoft.com/office/drawing/2014/main" id="{F1D8516E-5591-4FE2-8D41-B5C826615E7A}"/>
               </a:ext>
             </a:extLst>
           </p:cNvPr>
@@ -2269,10 +2160,10 @@
       </p:sp>
       <p:sp>
         <p:nvSpPr>
-          <p:cNvPr id="26" name="">
-            <a:extLst xmlns:a="http://schemas.openxmlformats.org/drawingml/2006/main">
-              <a:ext uri="{FF2B5EF4-FFF2-40B4-BE49-F238E27FC236}">
-                <a16:creationId xmlns:a16="http://schemas.microsoft.com/office/drawing/2014/main" id="{9C26A19F-370F-43BB-B716-901D2B901FDD}"/>
+          <p:cNvPr id="25" name="">
+            <a:extLst xmlns:a="http://schemas.openxmlformats.org/drawingml/2006/main">
+              <a:ext uri="{FF2B5EF4-FFF2-40B4-BE49-F238E27FC236}">
+                <a16:creationId xmlns:a16="http://schemas.microsoft.com/office/drawing/2014/main" id="{794BB73B-82E7-476D-92B6-661CA724DE97}"/>
               </a:ext>
             </a:extLst>
           </p:cNvPr>
@@ -2303,10 +2194,10 @@
       </p:sp>
       <p:sp>
         <p:nvSpPr>
-          <p:cNvPr id="27" name="">
-            <a:extLst xmlns:a="http://schemas.openxmlformats.org/drawingml/2006/main">
-              <a:ext uri="{FF2B5EF4-FFF2-40B4-BE49-F238E27FC236}">
-                <a16:creationId xmlns:a16="http://schemas.microsoft.com/office/drawing/2014/main" id="{06B35303-606A-41B5-A114-F373C3CEB972}"/>
+          <p:cNvPr id="26" name="">
+            <a:extLst xmlns:a="http://schemas.openxmlformats.org/drawingml/2006/main">
+              <a:ext uri="{FF2B5EF4-FFF2-40B4-BE49-F238E27FC236}">
+                <a16:creationId xmlns:a16="http://schemas.microsoft.com/office/drawing/2014/main" id="{EBD89EE8-F152-4FF6-9958-671E354DC6A8}"/>
               </a:ext>
             </a:extLst>
           </p:cNvPr>
@@ -2335,10 +2226,10 @@
       </p:sp>
       <p:sp>
         <p:nvSpPr>
-          <p:cNvPr id="28" name="">
-            <a:extLst xmlns:a="http://schemas.openxmlformats.org/drawingml/2006/main">
-              <a:ext uri="{FF2B5EF4-FFF2-40B4-BE49-F238E27FC236}">
-                <a16:creationId xmlns:a16="http://schemas.microsoft.com/office/drawing/2014/main" id="{A6A963C9-5362-41AD-A3F9-9E2420F6C67F}"/>
+          <p:cNvPr id="27" name="">
+            <a:extLst xmlns:a="http://schemas.openxmlformats.org/drawingml/2006/main">
+              <a:ext uri="{FF2B5EF4-FFF2-40B4-BE49-F238E27FC236}">
+                <a16:creationId xmlns:a16="http://schemas.microsoft.com/office/drawing/2014/main" id="{3C51141B-7671-4488-9D50-3ABFBBB39460}"/>
               </a:ext>
             </a:extLst>
           </p:cNvPr>
@@ -2370,6 +2261,9 @@
                 <a:solidFill>
                   <a:srgbClr val="102033"/>
                 </a:solidFill>
+                <a:latin typeface="Lato"/>
+                <a:ea typeface="Lato"/>
+                <a:cs typeface="Lato"/>
               </a:defRPr>
             </a:pPr>
             <a:r>
@@ -2377,6 +2271,9 @@
                 <a:solidFill>
                   <a:srgbClr val="102033"/>
                 </a:solidFill>
+                <a:latin typeface="Lato"/>
+                <a:ea typeface="Lato"/>
+                <a:cs typeface="Lato"/>
               </a:rPr>
               <a:t>Full-Stack Delivery</a:t>
             </a:r>
@@ -2385,10 +2282,10 @@
       </p:sp>
       <p:sp>
         <p:nvSpPr>
-          <p:cNvPr id="29" name="">
-            <a:extLst xmlns:a="http://schemas.openxmlformats.org/drawingml/2006/main">
-              <a:ext uri="{FF2B5EF4-FFF2-40B4-BE49-F238E27FC236}">
-                <a16:creationId xmlns:a16="http://schemas.microsoft.com/office/drawing/2014/main" id="{76E946D8-5872-4446-A223-18B1B8E200F2}"/>
+          <p:cNvPr id="28" name="">
+            <a:extLst xmlns:a="http://schemas.openxmlformats.org/drawingml/2006/main">
+              <a:ext uri="{FF2B5EF4-FFF2-40B4-BE49-F238E27FC236}">
+                <a16:creationId xmlns:a16="http://schemas.microsoft.com/office/drawing/2014/main" id="{671969AC-4F7D-421C-A909-1ABA63531632}"/>
               </a:ext>
             </a:extLst>
           </p:cNvPr>
@@ -2413,7 +2310,7 @@
         </p:spPr>
         <p:txBody>
           <a:bodyPr xmlns:a="http://schemas.openxmlformats.org/drawingml/2006/main" lIns="0" tIns="0" rIns="0" bIns="0" anchor="t">
-            <a:normAutofit fontScale="79831"/>
+            <a:normAutofit fontScale="79365"/>
           </a:bodyPr>
           <a:lstStyle xmlns:a="http://schemas.openxmlformats.org/drawingml/2006/main"/>
           <a:p xmlns:a="http://schemas.openxmlformats.org/drawingml/2006/main">
@@ -2422,6 +2319,9 @@
                 <a:solidFill>
                   <a:srgbClr val="5A6678"/>
                 </a:solidFill>
+                <a:latin typeface="Lato"/>
+                <a:ea typeface="Lato"/>
+                <a:cs typeface="Lato"/>
               </a:defRPr>
             </a:pPr>
             <a:r>
@@ -2429,6 +2329,9 @@
                 <a:solidFill>
                   <a:srgbClr val="5A6678"/>
                 </a:solidFill>
+                <a:latin typeface="Lato"/>
+                <a:ea typeface="Lato"/>
+                <a:cs typeface="Lato"/>
               </a:rPr>
               <a:t>FastAPI, Next.js, PostgreSQL, deployment, documentation, and dashboards.</a:t>
             </a:r>
@@ -2437,10 +2340,10 @@
       </p:sp>
       <p:sp>
         <p:nvSpPr>
-          <p:cNvPr id="30" name="">
-            <a:extLst xmlns:a="http://schemas.openxmlformats.org/drawingml/2006/main">
-              <a:ext uri="{FF2B5EF4-FFF2-40B4-BE49-F238E27FC236}">
-                <a16:creationId xmlns:a16="http://schemas.microsoft.com/office/drawing/2014/main" id="{25EFF96E-FC81-4826-B0BF-BA3D9E4E8AED}"/>
+          <p:cNvPr id="29" name="">
+            <a:extLst xmlns:a="http://schemas.openxmlformats.org/drawingml/2006/main">
+              <a:ext uri="{FF2B5EF4-FFF2-40B4-BE49-F238E27FC236}">
+                <a16:creationId xmlns:a16="http://schemas.microsoft.com/office/drawing/2014/main" id="{CC8F920A-3E03-4161-B515-F383B5CE5266}"/>
               </a:ext>
             </a:extLst>
           </p:cNvPr>
@@ -2472,6 +2375,9 @@
                 <a:solidFill>
                   <a:srgbClr val="5A6678"/>
                 </a:solidFill>
+                <a:latin typeface="Lato"/>
+                <a:ea typeface="Lato"/>
+                <a:cs typeface="Lato"/>
               </a:defRPr>
             </a:pPr>
             <a:r>
@@ -2479,18 +2385,21 @@
                 <a:solidFill>
                   <a:srgbClr val="5A6678"/>
                 </a:solidFill>
-              </a:rPr>
-              <a:t>github.com/icheftech/AI-Portfolio-Leroy-Brown</a:t>
-            </a:r>
-          </a:p>
-        </p:txBody>
-      </p:sp>
-      <p:sp>
-        <p:nvSpPr>
-          <p:cNvPr id="31" name="">
-            <a:extLst xmlns:a="http://schemas.openxmlformats.org/drawingml/2006/main">
-              <a:ext uri="{FF2B5EF4-FFF2-40B4-BE49-F238E27FC236}">
-                <a16:creationId xmlns:a16="http://schemas.microsoft.com/office/drawing/2014/main" id="{DCC8873C-9507-432F-9C32-BC41D874BA26}"/>
+                <a:latin typeface="Lato"/>
+                <a:ea typeface="Lato"/>
+                <a:cs typeface="Lato"/>
+              </a:rPr>
+              <a:t>github.com/icheftech/Leroy-Brown-HCC-AI-Portfolio</a:t>
+            </a:r>
+          </a:p>
+        </p:txBody>
+      </p:sp>
+      <p:sp>
+        <p:nvSpPr>
+          <p:cNvPr id="30" name="">
+            <a:extLst xmlns:a="http://schemas.openxmlformats.org/drawingml/2006/main">
+              <a:ext uri="{FF2B5EF4-FFF2-40B4-BE49-F238E27FC236}">
+                <a16:creationId xmlns:a16="http://schemas.microsoft.com/office/drawing/2014/main" id="{6D24EE81-F3F8-48F4-ACCE-53FE3C0A1D4B}"/>
               </a:ext>
             </a:extLst>
           </p:cNvPr>
@@ -2522,6 +2431,9 @@
                 <a:solidFill>
                   <a:srgbClr val="5A6678"/>
                 </a:solidFill>
+                <a:latin typeface="Lato"/>
+                <a:ea typeface="Lato"/>
+                <a:cs typeface="Lato"/>
               </a:defRPr>
             </a:pPr>
             <a:r>
@@ -2529,6 +2441,9 @@
                 <a:solidFill>
                   <a:srgbClr val="5A6678"/>
                 </a:solidFill>
+                <a:latin typeface="Lato"/>
+                <a:ea typeface="Lato"/>
+                <a:cs typeface="Lato"/>
               </a:rPr>
               <a:t>Applied AI &amp; Robotics Portfolio</a:t>
             </a:r>
@@ -2538,7 +2453,7 @@
     </p:spTree>
     <p:extLst>
       <p:ext uri="{BB962C8B-B14F-4D97-AF65-F5344CB8AC3E}">
-        <p14:creationId xmlns:p14="http://schemas.microsoft.com/office/powerpoint/2010/main" val="1704247804"/>
+        <p14:creationId xmlns:p14="http://schemas.microsoft.com/office/powerpoint/2010/main" val="405570758"/>
       </p:ext>
     </p:extLst>
   </p:cSld>
@@ -2566,42 +2481,10 @@
       </p:grpSpPr>
       <p:sp>
         <p:nvSpPr>
-          <p:cNvPr id="1" name="Slide Number Placeholder 5">
-            <a:extLst xmlns:a="http://schemas.openxmlformats.org/drawingml/2006/main">
-              <a:ext uri="{FF2B5EF4-FFF2-40B4-BE49-F238E27FC236}">
-                <a16:creationId xmlns:a16="http://schemas.microsoft.com/office/drawing/2014/main" id="{B8270420-D236-4471-AE86-CB207C63A521}"/>
-              </a:ext>
-            </a:extLst>
-          </p:cNvPr>
-          <p:cNvSpPr>
-            <a:spLocks xmlns:a="http://schemas.openxmlformats.org/drawingml/2006/main" noGrp="1"/>
-          </p:cNvSpPr>
-          <p:nvPr>
-            <p:ph type="sldNum" idx="12"/>
-          </p:nvPr>
-        </p:nvSpPr>
-        <p:spPr>
-          <a:xfrm xmlns:a="http://schemas.openxmlformats.org/drawingml/2006/main">
-            <a:off x="1524000" y="1122363"/>
-            <a:ext cx="9144000" cy="2387600"/>
-          </a:xfrm>
-        </p:spPr>
-        <p:txBody>
-          <a:bodyPr xmlns:a="http://schemas.openxmlformats.org/drawingml/2006/main"/>
-          <a:lstStyle xmlns:a="http://schemas.openxmlformats.org/drawingml/2006/main"/>
-          <a:p xmlns:a="http://schemas.openxmlformats.org/drawingml/2006/main">
-            <a:r>
-              <a:t/>
-            </a:r>
-          </a:p>
-        </p:txBody>
-      </p:sp>
-      <p:sp>
-        <p:nvSpPr>
-          <p:cNvPr id="2" name="">
-            <a:extLst xmlns:a="http://schemas.openxmlformats.org/drawingml/2006/main">
-              <a:ext uri="{FF2B5EF4-FFF2-40B4-BE49-F238E27FC236}">
-                <a16:creationId xmlns:a16="http://schemas.microsoft.com/office/drawing/2014/main" id="{6F3DE407-64ED-413E-9405-88323E5752F5}"/>
+          <p:cNvPr id="1" name="">
+            <a:extLst xmlns:a="http://schemas.openxmlformats.org/drawingml/2006/main">
+              <a:ext uri="{FF2B5EF4-FFF2-40B4-BE49-F238E27FC236}">
+                <a16:creationId xmlns:a16="http://schemas.microsoft.com/office/drawing/2014/main" id="{5C8C78C1-C97E-4AEE-9AE0-F111DB95085A}"/>
               </a:ext>
             </a:extLst>
           </p:cNvPr>
@@ -2630,10 +2513,10 @@
       </p:sp>
       <p:sp>
         <p:nvSpPr>
-          <p:cNvPr id="3" name="">
-            <a:extLst xmlns:a="http://schemas.openxmlformats.org/drawingml/2006/main">
-              <a:ext uri="{FF2B5EF4-FFF2-40B4-BE49-F238E27FC236}">
-                <a16:creationId xmlns:a16="http://schemas.microsoft.com/office/drawing/2014/main" id="{D6B51BE8-CCD2-43D7-B1E4-74E60011B553}"/>
+          <p:cNvPr id="2" name="">
+            <a:extLst xmlns:a="http://schemas.openxmlformats.org/drawingml/2006/main">
+              <a:ext uri="{FF2B5EF4-FFF2-40B4-BE49-F238E27FC236}">
+                <a16:creationId xmlns:a16="http://schemas.microsoft.com/office/drawing/2014/main" id="{FC817750-016C-4950-B097-D532B41929B6}"/>
               </a:ext>
             </a:extLst>
           </p:cNvPr>
@@ -2662,10 +2545,10 @@
       </p:sp>
       <p:sp>
         <p:nvSpPr>
-          <p:cNvPr id="4" name="">
-            <a:extLst xmlns:a="http://schemas.openxmlformats.org/drawingml/2006/main">
-              <a:ext uri="{FF2B5EF4-FFF2-40B4-BE49-F238E27FC236}">
-                <a16:creationId xmlns:a16="http://schemas.microsoft.com/office/drawing/2014/main" id="{9A3EEA0E-F9A4-4019-8578-0A0517A38FD1}"/>
+          <p:cNvPr id="3" name="">
+            <a:extLst xmlns:a="http://schemas.openxmlformats.org/drawingml/2006/main">
+              <a:ext uri="{FF2B5EF4-FFF2-40B4-BE49-F238E27FC236}">
+                <a16:creationId xmlns:a16="http://schemas.microsoft.com/office/drawing/2014/main" id="{5DDCD901-8C85-46E6-9E03-EBA3F7ED7426}"/>
               </a:ext>
             </a:extLst>
           </p:cNvPr>
@@ -2697,6 +2580,9 @@
                 <a:solidFill>
                   <a:srgbClr val="102033"/>
                 </a:solidFill>
+                <a:latin typeface="Poppins"/>
+                <a:ea typeface="Poppins"/>
+                <a:cs typeface="Poppins"/>
               </a:defRPr>
             </a:pPr>
             <a:r>
@@ -2704,6 +2590,9 @@
                 <a:solidFill>
                   <a:srgbClr val="102033"/>
                 </a:solidFill>
+                <a:latin typeface="Poppins"/>
+                <a:ea typeface="Poppins"/>
+                <a:cs typeface="Poppins"/>
               </a:rPr>
               <a:t>Learning Journey</a:t>
             </a:r>
@@ -2712,10 +2601,10 @@
       </p:sp>
       <p:sp>
         <p:nvSpPr>
-          <p:cNvPr id="5" name="">
-            <a:extLst xmlns:a="http://schemas.openxmlformats.org/drawingml/2006/main">
-              <a:ext uri="{FF2B5EF4-FFF2-40B4-BE49-F238E27FC236}">
-                <a16:creationId xmlns:a16="http://schemas.microsoft.com/office/drawing/2014/main" id="{52E4F8F2-197A-4761-8CB0-E20BACF993F2}"/>
+          <p:cNvPr id="4" name="">
+            <a:extLst xmlns:a="http://schemas.openxmlformats.org/drawingml/2006/main">
+              <a:ext uri="{FF2B5EF4-FFF2-40B4-BE49-F238E27FC236}">
+                <a16:creationId xmlns:a16="http://schemas.microsoft.com/office/drawing/2014/main" id="{4DDA46AA-5574-40E0-89A4-71E4EC518BFE}"/>
               </a:ext>
             </a:extLst>
           </p:cNvPr>
@@ -2747,6 +2636,9 @@
                 <a:solidFill>
                   <a:srgbClr val="5A6678"/>
                 </a:solidFill>
+                <a:latin typeface="Lato"/>
+                <a:ea typeface="Lato"/>
+                <a:cs typeface="Lato"/>
               </a:defRPr>
             </a:pPr>
             <a:r>
@@ -2754,6 +2646,9 @@
                 <a:solidFill>
                   <a:srgbClr val="5A6678"/>
                 </a:solidFill>
+                <a:latin typeface="Lato"/>
+                <a:ea typeface="Lato"/>
+                <a:cs typeface="Lato"/>
               </a:rPr>
               <a:t>From NLP foundations to agentic systems and responsible AI architecture.</a:t>
             </a:r>
@@ -2762,10 +2657,10 @@
       </p:sp>
       <p:sp>
         <p:nvSpPr>
-          <p:cNvPr id="6" name="">
-            <a:extLst xmlns:a="http://schemas.openxmlformats.org/drawingml/2006/main">
-              <a:ext uri="{FF2B5EF4-FFF2-40B4-BE49-F238E27FC236}">
-                <a16:creationId xmlns:a16="http://schemas.microsoft.com/office/drawing/2014/main" id="{68694883-1967-4400-8C37-5C57D2841A75}"/>
+          <p:cNvPr id="5" name="">
+            <a:extLst xmlns:a="http://schemas.openxmlformats.org/drawingml/2006/main">
+              <a:ext uri="{FF2B5EF4-FFF2-40B4-BE49-F238E27FC236}">
+                <a16:creationId xmlns:a16="http://schemas.microsoft.com/office/drawing/2014/main" id="{C50FFAE2-BE13-42F1-819D-942720C11A70}"/>
               </a:ext>
             </a:extLst>
           </p:cNvPr>
@@ -2794,10 +2689,10 @@
       </p:sp>
       <p:sp>
         <p:nvSpPr>
-          <p:cNvPr id="7" name="">
-            <a:extLst xmlns:a="http://schemas.openxmlformats.org/drawingml/2006/main">
-              <a:ext uri="{FF2B5EF4-FFF2-40B4-BE49-F238E27FC236}">
-                <a16:creationId xmlns:a16="http://schemas.microsoft.com/office/drawing/2014/main" id="{13181E05-2BAB-4F16-9DA1-2B176646B7FE}"/>
+          <p:cNvPr id="6" name="">
+            <a:extLst xmlns:a="http://schemas.openxmlformats.org/drawingml/2006/main">
+              <a:ext uri="{FF2B5EF4-FFF2-40B4-BE49-F238E27FC236}">
+                <a16:creationId xmlns:a16="http://schemas.microsoft.com/office/drawing/2014/main" id="{AD509132-2722-47A4-80C2-726955BB54F1}"/>
               </a:ext>
             </a:extLst>
           </p:cNvPr>
@@ -2826,10 +2721,10 @@
       </p:sp>
       <p:sp>
         <p:nvSpPr>
-          <p:cNvPr id="8" name="">
-            <a:extLst xmlns:a="http://schemas.openxmlformats.org/drawingml/2006/main">
-              <a:ext uri="{FF2B5EF4-FFF2-40B4-BE49-F238E27FC236}">
-                <a16:creationId xmlns:a16="http://schemas.microsoft.com/office/drawing/2014/main" id="{06ECEBB7-A1B2-4313-B72B-16C42AABFD6F}"/>
+          <p:cNvPr id="7" name="">
+            <a:extLst xmlns:a="http://schemas.openxmlformats.org/drawingml/2006/main">
+              <a:ext uri="{FF2B5EF4-FFF2-40B4-BE49-F238E27FC236}">
+                <a16:creationId xmlns:a16="http://schemas.microsoft.com/office/drawing/2014/main" id="{E0F43C4E-BD51-4DC3-917C-465429A1DF56}"/>
               </a:ext>
             </a:extLst>
           </p:cNvPr>
@@ -2861,6 +2756,9 @@
                 <a:solidFill>
                   <a:srgbClr val="FFFFFF"/>
                 </a:solidFill>
+                <a:latin typeface="Lato"/>
+                <a:ea typeface="Lato"/>
+                <a:cs typeface="Lato"/>
               </a:defRPr>
             </a:pPr>
             <a:r>
@@ -2868,6 +2766,9 @@
                 <a:solidFill>
                   <a:srgbClr val="FFFFFF"/>
                 </a:solidFill>
+                <a:latin typeface="Lato"/>
+                <a:ea typeface="Lato"/>
+                <a:cs typeface="Lato"/>
               </a:rPr>
               <a:t>1</a:t>
             </a:r>
@@ -2876,10 +2777,10 @@
       </p:sp>
       <p:sp>
         <p:nvSpPr>
-          <p:cNvPr id="9" name="">
-            <a:extLst xmlns:a="http://schemas.openxmlformats.org/drawingml/2006/main">
-              <a:ext uri="{FF2B5EF4-FFF2-40B4-BE49-F238E27FC236}">
-                <a16:creationId xmlns:a16="http://schemas.microsoft.com/office/drawing/2014/main" id="{FC13CD95-592A-48B0-97B8-548B374735EA}"/>
+          <p:cNvPr id="8" name="">
+            <a:extLst xmlns:a="http://schemas.openxmlformats.org/drawingml/2006/main">
+              <a:ext uri="{FF2B5EF4-FFF2-40B4-BE49-F238E27FC236}">
+                <a16:creationId xmlns:a16="http://schemas.microsoft.com/office/drawing/2014/main" id="{15E0ECE8-3572-4744-9CD6-9C3C7A731AD5}"/>
               </a:ext>
             </a:extLst>
           </p:cNvPr>
@@ -2911,6 +2812,9 @@
                 <a:solidFill>
                   <a:srgbClr val="102033"/>
                 </a:solidFill>
+                <a:latin typeface="Lato"/>
+                <a:ea typeface="Lato"/>
+                <a:cs typeface="Lato"/>
               </a:defRPr>
             </a:pPr>
             <a:r>
@@ -2918,6 +2822,9 @@
                 <a:solidFill>
                   <a:srgbClr val="102033"/>
                 </a:solidFill>
+                <a:latin typeface="Lato"/>
+                <a:ea typeface="Lato"/>
+                <a:cs typeface="Lato"/>
               </a:rPr>
               <a:t>NLP Foundations</a:t>
             </a:r>
@@ -2926,10 +2833,10 @@
       </p:sp>
       <p:sp>
         <p:nvSpPr>
-          <p:cNvPr id="10" name="">
-            <a:extLst xmlns:a="http://schemas.openxmlformats.org/drawingml/2006/main">
-              <a:ext uri="{FF2B5EF4-FFF2-40B4-BE49-F238E27FC236}">
-                <a16:creationId xmlns:a16="http://schemas.microsoft.com/office/drawing/2014/main" id="{6529CF9B-4F9D-4512-8A4F-A547B90C4B50}"/>
+          <p:cNvPr id="9" name="">
+            <a:extLst xmlns:a="http://schemas.openxmlformats.org/drawingml/2006/main">
+              <a:ext uri="{FF2B5EF4-FFF2-40B4-BE49-F238E27FC236}">
+                <a16:creationId xmlns:a16="http://schemas.microsoft.com/office/drawing/2014/main" id="{6DAA6243-035A-4D50-999C-6738B2174823}"/>
               </a:ext>
             </a:extLst>
           </p:cNvPr>
@@ -2963,6 +2870,9 @@
                 <a:solidFill>
                   <a:srgbClr val="5A6678"/>
                 </a:solidFill>
+                <a:latin typeface="Lato"/>
+                <a:ea typeface="Lato"/>
+                <a:cs typeface="Lato"/>
               </a:defRPr>
             </a:pPr>
             <a:r>
@@ -2970,6 +2880,9 @@
                 <a:solidFill>
                   <a:srgbClr val="5A6678"/>
                 </a:solidFill>
+                <a:latin typeface="Lato"/>
+                <a:ea typeface="Lato"/>
+                <a:cs typeface="Lato"/>
               </a:rPr>
               <a:t>NewsBot pipeline: classify, summarize, embed, and explore news text.</a:t>
             </a:r>
@@ -2978,10 +2891,10 @@
       </p:sp>
       <p:sp>
         <p:nvSpPr>
-          <p:cNvPr id="11" name="">
-            <a:extLst xmlns:a="http://schemas.openxmlformats.org/drawingml/2006/main">
-              <a:ext uri="{FF2B5EF4-FFF2-40B4-BE49-F238E27FC236}">
-                <a16:creationId xmlns:a16="http://schemas.microsoft.com/office/drawing/2014/main" id="{3BC4E231-9B7D-4C89-9E43-07E29EA0E8A2}"/>
+          <p:cNvPr id="10" name="">
+            <a:extLst xmlns:a="http://schemas.openxmlformats.org/drawingml/2006/main">
+              <a:ext uri="{FF2B5EF4-FFF2-40B4-BE49-F238E27FC236}">
+                <a16:creationId xmlns:a16="http://schemas.microsoft.com/office/drawing/2014/main" id="{4590CF39-E87F-425A-9C19-91397FEA20E3}"/>
               </a:ext>
             </a:extLst>
           </p:cNvPr>
@@ -3010,10 +2923,10 @@
       </p:sp>
       <p:sp>
         <p:nvSpPr>
-          <p:cNvPr id="12" name="">
-            <a:extLst xmlns:a="http://schemas.openxmlformats.org/drawingml/2006/main">
-              <a:ext uri="{FF2B5EF4-FFF2-40B4-BE49-F238E27FC236}">
-                <a16:creationId xmlns:a16="http://schemas.microsoft.com/office/drawing/2014/main" id="{F58D18E0-B7B0-4E3C-A525-B16F4409DEEC}"/>
+          <p:cNvPr id="11" name="">
+            <a:extLst xmlns:a="http://schemas.openxmlformats.org/drawingml/2006/main">
+              <a:ext uri="{FF2B5EF4-FFF2-40B4-BE49-F238E27FC236}">
+                <a16:creationId xmlns:a16="http://schemas.microsoft.com/office/drawing/2014/main" id="{5116BB3F-A3AF-460F-A664-C15A234B506A}"/>
               </a:ext>
             </a:extLst>
           </p:cNvPr>
@@ -3045,6 +2958,9 @@
                 <a:solidFill>
                   <a:srgbClr val="FFFFFF"/>
                 </a:solidFill>
+                <a:latin typeface="Lato"/>
+                <a:ea typeface="Lato"/>
+                <a:cs typeface="Lato"/>
               </a:defRPr>
             </a:pPr>
             <a:r>
@@ -3052,6 +2968,9 @@
                 <a:solidFill>
                   <a:srgbClr val="FFFFFF"/>
                 </a:solidFill>
+                <a:latin typeface="Lato"/>
+                <a:ea typeface="Lato"/>
+                <a:cs typeface="Lato"/>
               </a:rPr>
               <a:t>2</a:t>
             </a:r>
@@ -3060,10 +2979,10 @@
       </p:sp>
       <p:sp>
         <p:nvSpPr>
-          <p:cNvPr id="13" name="">
-            <a:extLst xmlns:a="http://schemas.openxmlformats.org/drawingml/2006/main">
-              <a:ext uri="{FF2B5EF4-FFF2-40B4-BE49-F238E27FC236}">
-                <a16:creationId xmlns:a16="http://schemas.microsoft.com/office/drawing/2014/main" id="{F2F5D32D-BCF7-428A-A0DB-43103BCEAB48}"/>
+          <p:cNvPr id="12" name="">
+            <a:extLst xmlns:a="http://schemas.openxmlformats.org/drawingml/2006/main">
+              <a:ext uri="{FF2B5EF4-FFF2-40B4-BE49-F238E27FC236}">
+                <a16:creationId xmlns:a16="http://schemas.microsoft.com/office/drawing/2014/main" id="{973B9106-AE90-4DE7-804E-9F3709F0844A}"/>
               </a:ext>
             </a:extLst>
           </p:cNvPr>
@@ -3095,6 +3014,9 @@
                 <a:solidFill>
                   <a:srgbClr val="102033"/>
                 </a:solidFill>
+                <a:latin typeface="Lato"/>
+                <a:ea typeface="Lato"/>
+                <a:cs typeface="Lato"/>
               </a:defRPr>
             </a:pPr>
             <a:r>
@@ -3102,6 +3024,9 @@
                 <a:solidFill>
                   <a:srgbClr val="102033"/>
                 </a:solidFill>
+                <a:latin typeface="Lato"/>
+                <a:ea typeface="Lato"/>
+                <a:cs typeface="Lato"/>
               </a:rPr>
               <a:t>Applied AI Systems</a:t>
             </a:r>
@@ -3110,10 +3035,10 @@
       </p:sp>
       <p:sp>
         <p:nvSpPr>
-          <p:cNvPr id="14" name="">
-            <a:extLst xmlns:a="http://schemas.openxmlformats.org/drawingml/2006/main">
-              <a:ext uri="{FF2B5EF4-FFF2-40B4-BE49-F238E27FC236}">
-                <a16:creationId xmlns:a16="http://schemas.microsoft.com/office/drawing/2014/main" id="{6C2ACC26-D503-4AE7-8EC2-EB4AFD2BA5F3}"/>
+          <p:cNvPr id="13" name="">
+            <a:extLst xmlns:a="http://schemas.openxmlformats.org/drawingml/2006/main">
+              <a:ext uri="{FF2B5EF4-FFF2-40B4-BE49-F238E27FC236}">
+                <a16:creationId xmlns:a16="http://schemas.microsoft.com/office/drawing/2014/main" id="{F42FC058-276C-4219-8BB8-2BB713597548}"/>
               </a:ext>
             </a:extLst>
           </p:cNvPr>
@@ -3147,6 +3072,9 @@
                 <a:solidFill>
                   <a:srgbClr val="5A6678"/>
                 </a:solidFill>
+                <a:latin typeface="Lato"/>
+                <a:ea typeface="Lato"/>
+                <a:cs typeface="Lato"/>
               </a:defRPr>
             </a:pPr>
             <a:r>
@@ -3154,6 +3082,9 @@
                 <a:solidFill>
                   <a:srgbClr val="5A6678"/>
                 </a:solidFill>
+                <a:latin typeface="Lato"/>
+                <a:ea typeface="Lato"/>
+                <a:cs typeface="Lato"/>
               </a:rPr>
               <a:t>bidops and CloudArch connect agents to operational decisions.</a:t>
             </a:r>
@@ -3162,10 +3093,10 @@
       </p:sp>
       <p:sp>
         <p:nvSpPr>
-          <p:cNvPr id="15" name="">
-            <a:extLst xmlns:a="http://schemas.openxmlformats.org/drawingml/2006/main">
-              <a:ext uri="{FF2B5EF4-FFF2-40B4-BE49-F238E27FC236}">
-                <a16:creationId xmlns:a16="http://schemas.microsoft.com/office/drawing/2014/main" id="{2B2D185B-04E5-4023-8DF9-ADBA505AD7DC}"/>
+          <p:cNvPr id="14" name="">
+            <a:extLst xmlns:a="http://schemas.openxmlformats.org/drawingml/2006/main">
+              <a:ext uri="{FF2B5EF4-FFF2-40B4-BE49-F238E27FC236}">
+                <a16:creationId xmlns:a16="http://schemas.microsoft.com/office/drawing/2014/main" id="{FB206AFB-DFF5-422F-A0D4-DE62EDF66B33}"/>
               </a:ext>
             </a:extLst>
           </p:cNvPr>
@@ -3194,10 +3125,10 @@
       </p:sp>
       <p:sp>
         <p:nvSpPr>
-          <p:cNvPr id="16" name="">
-            <a:extLst xmlns:a="http://schemas.openxmlformats.org/drawingml/2006/main">
-              <a:ext uri="{FF2B5EF4-FFF2-40B4-BE49-F238E27FC236}">
-                <a16:creationId xmlns:a16="http://schemas.microsoft.com/office/drawing/2014/main" id="{020D5A0C-935E-45A5-8EB8-DB14F7ED22F6}"/>
+          <p:cNvPr id="15" name="">
+            <a:extLst xmlns:a="http://schemas.openxmlformats.org/drawingml/2006/main">
+              <a:ext uri="{FF2B5EF4-FFF2-40B4-BE49-F238E27FC236}">
+                <a16:creationId xmlns:a16="http://schemas.microsoft.com/office/drawing/2014/main" id="{FE1B7D65-775D-4BE3-8CA1-F4C3AC6079D7}"/>
               </a:ext>
             </a:extLst>
           </p:cNvPr>
@@ -3229,6 +3160,9 @@
                 <a:solidFill>
                   <a:srgbClr val="FFFFFF"/>
                 </a:solidFill>
+                <a:latin typeface="Lato"/>
+                <a:ea typeface="Lato"/>
+                <a:cs typeface="Lato"/>
               </a:defRPr>
             </a:pPr>
             <a:r>
@@ -3236,6 +3170,9 @@
                 <a:solidFill>
                   <a:srgbClr val="FFFFFF"/>
                 </a:solidFill>
+                <a:latin typeface="Lato"/>
+                <a:ea typeface="Lato"/>
+                <a:cs typeface="Lato"/>
               </a:rPr>
               <a:t>3</a:t>
             </a:r>
@@ -3244,10 +3181,10 @@
       </p:sp>
       <p:sp>
         <p:nvSpPr>
-          <p:cNvPr id="17" name="">
-            <a:extLst xmlns:a="http://schemas.openxmlformats.org/drawingml/2006/main">
-              <a:ext uri="{FF2B5EF4-FFF2-40B4-BE49-F238E27FC236}">
-                <a16:creationId xmlns:a16="http://schemas.microsoft.com/office/drawing/2014/main" id="{90E8B711-9AEA-488E-966F-A942A41AAC06}"/>
+          <p:cNvPr id="16" name="">
+            <a:extLst xmlns:a="http://schemas.openxmlformats.org/drawingml/2006/main">
+              <a:ext uri="{FF2B5EF4-FFF2-40B4-BE49-F238E27FC236}">
+                <a16:creationId xmlns:a16="http://schemas.microsoft.com/office/drawing/2014/main" id="{ED25FFA9-3C4A-4CC8-AC04-B2ACE15C3750}"/>
               </a:ext>
             </a:extLst>
           </p:cNvPr>
@@ -3279,6 +3216,9 @@
                 <a:solidFill>
                   <a:srgbClr val="102033"/>
                 </a:solidFill>
+                <a:latin typeface="Lato"/>
+                <a:ea typeface="Lato"/>
+                <a:cs typeface="Lato"/>
               </a:defRPr>
             </a:pPr>
             <a:r>
@@ -3286,6 +3226,9 @@
                 <a:solidFill>
                   <a:srgbClr val="102033"/>
                 </a:solidFill>
+                <a:latin typeface="Lato"/>
+                <a:ea typeface="Lato"/>
+                <a:cs typeface="Lato"/>
               </a:rPr>
               <a:t>Governance</a:t>
             </a:r>
@@ -3294,10 +3237,10 @@
       </p:sp>
       <p:sp>
         <p:nvSpPr>
-          <p:cNvPr id="18" name="">
-            <a:extLst xmlns:a="http://schemas.openxmlformats.org/drawingml/2006/main">
-              <a:ext uri="{FF2B5EF4-FFF2-40B4-BE49-F238E27FC236}">
-                <a16:creationId xmlns:a16="http://schemas.microsoft.com/office/drawing/2014/main" id="{58354F81-FCBC-4446-AA2C-C77186D16B79}"/>
+          <p:cNvPr id="17" name="">
+            <a:extLst xmlns:a="http://schemas.openxmlformats.org/drawingml/2006/main">
+              <a:ext uri="{FF2B5EF4-FFF2-40B4-BE49-F238E27FC236}">
+                <a16:creationId xmlns:a16="http://schemas.microsoft.com/office/drawing/2014/main" id="{6E745735-C7AD-4B0F-AB9E-2734BC07DEA3}"/>
               </a:ext>
             </a:extLst>
           </p:cNvPr>
@@ -3331,6 +3274,9 @@
                 <a:solidFill>
                   <a:srgbClr val="5A6678"/>
                 </a:solidFill>
+                <a:latin typeface="Lato"/>
+                <a:ea typeface="Lato"/>
+                <a:cs typeface="Lato"/>
               </a:defRPr>
             </a:pPr>
             <a:r>
@@ -3338,6 +3284,9 @@
                 <a:solidFill>
                   <a:srgbClr val="5A6678"/>
                 </a:solidFill>
+                <a:latin typeface="Lato"/>
+                <a:ea typeface="Lato"/>
+                <a:cs typeface="Lato"/>
               </a:rPr>
               <a:t>SSO Control Plane turns responsible AI into enforceable software controls.</a:t>
             </a:r>
@@ -3346,10 +3295,10 @@
       </p:sp>
       <p:sp>
         <p:nvSpPr>
-          <p:cNvPr id="19" name="">
-            <a:extLst xmlns:a="http://schemas.openxmlformats.org/drawingml/2006/main">
-              <a:ext uri="{FF2B5EF4-FFF2-40B4-BE49-F238E27FC236}">
-                <a16:creationId xmlns:a16="http://schemas.microsoft.com/office/drawing/2014/main" id="{D3160ED4-1493-48C5-B930-8E57D2D86997}"/>
+          <p:cNvPr id="18" name="">
+            <a:extLst xmlns:a="http://schemas.openxmlformats.org/drawingml/2006/main">
+              <a:ext uri="{FF2B5EF4-FFF2-40B4-BE49-F238E27FC236}">
+                <a16:creationId xmlns:a16="http://schemas.microsoft.com/office/drawing/2014/main" id="{1054E054-B738-43F9-99D0-387FC65A4AD3}"/>
               </a:ext>
             </a:extLst>
           </p:cNvPr>
@@ -3378,10 +3327,10 @@
       </p:sp>
       <p:sp>
         <p:nvSpPr>
-          <p:cNvPr id="20" name="">
-            <a:extLst xmlns:a="http://schemas.openxmlformats.org/drawingml/2006/main">
-              <a:ext uri="{FF2B5EF4-FFF2-40B4-BE49-F238E27FC236}">
-                <a16:creationId xmlns:a16="http://schemas.microsoft.com/office/drawing/2014/main" id="{35DC9563-811A-42D4-A964-9E4F966BD55C}"/>
+          <p:cNvPr id="19" name="">
+            <a:extLst xmlns:a="http://schemas.openxmlformats.org/drawingml/2006/main">
+              <a:ext uri="{FF2B5EF4-FFF2-40B4-BE49-F238E27FC236}">
+                <a16:creationId xmlns:a16="http://schemas.microsoft.com/office/drawing/2014/main" id="{77AD8F27-B893-402C-BDC2-8C7327EB41E8}"/>
               </a:ext>
             </a:extLst>
           </p:cNvPr>
@@ -3413,6 +3362,9 @@
                 <a:solidFill>
                   <a:srgbClr val="FFFFFF"/>
                 </a:solidFill>
+                <a:latin typeface="Lato"/>
+                <a:ea typeface="Lato"/>
+                <a:cs typeface="Lato"/>
               </a:defRPr>
             </a:pPr>
             <a:r>
@@ -3420,6 +3372,9 @@
                 <a:solidFill>
                   <a:srgbClr val="FFFFFF"/>
                 </a:solidFill>
+                <a:latin typeface="Lato"/>
+                <a:ea typeface="Lato"/>
+                <a:cs typeface="Lato"/>
               </a:rPr>
               <a:t>4</a:t>
             </a:r>
@@ -3428,10 +3383,10 @@
       </p:sp>
       <p:sp>
         <p:nvSpPr>
-          <p:cNvPr id="21" name="">
-            <a:extLst xmlns:a="http://schemas.openxmlformats.org/drawingml/2006/main">
-              <a:ext uri="{FF2B5EF4-FFF2-40B4-BE49-F238E27FC236}">
-                <a16:creationId xmlns:a16="http://schemas.microsoft.com/office/drawing/2014/main" id="{C57026CF-AC48-4549-8B0D-097CFC3FFCE0}"/>
+          <p:cNvPr id="20" name="">
+            <a:extLst xmlns:a="http://schemas.openxmlformats.org/drawingml/2006/main">
+              <a:ext uri="{FF2B5EF4-FFF2-40B4-BE49-F238E27FC236}">
+                <a16:creationId xmlns:a16="http://schemas.microsoft.com/office/drawing/2014/main" id="{4BF8D9D7-5B7D-451C-9D50-69658CE1DDC0}"/>
               </a:ext>
             </a:extLst>
           </p:cNvPr>
@@ -3463,6 +3418,9 @@
                 <a:solidFill>
                   <a:srgbClr val="102033"/>
                 </a:solidFill>
+                <a:latin typeface="Lato"/>
+                <a:ea typeface="Lato"/>
+                <a:cs typeface="Lato"/>
               </a:defRPr>
             </a:pPr>
             <a:r>
@@ -3470,6 +3428,9 @@
                 <a:solidFill>
                   <a:srgbClr val="102033"/>
                 </a:solidFill>
+                <a:latin typeface="Lato"/>
+                <a:ea typeface="Lato"/>
+                <a:cs typeface="Lato"/>
               </a:rPr>
               <a:t>Deployment</a:t>
             </a:r>
@@ -3478,10 +3439,10 @@
       </p:sp>
       <p:sp>
         <p:nvSpPr>
-          <p:cNvPr id="22" name="">
-            <a:extLst xmlns:a="http://schemas.openxmlformats.org/drawingml/2006/main">
-              <a:ext uri="{FF2B5EF4-FFF2-40B4-BE49-F238E27FC236}">
-                <a16:creationId xmlns:a16="http://schemas.microsoft.com/office/drawing/2014/main" id="{E9332B96-57A1-4865-99EC-AC3F479E063F}"/>
+          <p:cNvPr id="21" name="">
+            <a:extLst xmlns:a="http://schemas.openxmlformats.org/drawingml/2006/main">
+              <a:ext uri="{FF2B5EF4-FFF2-40B4-BE49-F238E27FC236}">
+                <a16:creationId xmlns:a16="http://schemas.microsoft.com/office/drawing/2014/main" id="{A43B9509-68D9-48FE-A8AA-6C07B46F8074}"/>
               </a:ext>
             </a:extLst>
           </p:cNvPr>
@@ -3515,6 +3476,9 @@
                 <a:solidFill>
                   <a:srgbClr val="5A6678"/>
                 </a:solidFill>
+                <a:latin typeface="Lato"/>
+                <a:ea typeface="Lato"/>
+                <a:cs typeface="Lato"/>
               </a:defRPr>
             </a:pPr>
             <a:r>
@@ -3522,6 +3486,9 @@
                 <a:solidFill>
                   <a:srgbClr val="5A6678"/>
                 </a:solidFill>
+                <a:latin typeface="Lato"/>
+                <a:ea typeface="Lato"/>
+                <a:cs typeface="Lato"/>
               </a:rPr>
               <a:t>PMBC Connect and intake services show practical full-stack delivery.</a:t>
             </a:r>
@@ -3530,10 +3497,10 @@
       </p:sp>
       <p:sp>
         <p:nvSpPr>
-          <p:cNvPr id="23" name="">
-            <a:extLst xmlns:a="http://schemas.openxmlformats.org/drawingml/2006/main">
-              <a:ext uri="{FF2B5EF4-FFF2-40B4-BE49-F238E27FC236}">
-                <a16:creationId xmlns:a16="http://schemas.microsoft.com/office/drawing/2014/main" id="{89CA462E-0026-41E8-B6DD-55DA988D462D}"/>
+          <p:cNvPr id="22" name="">
+            <a:extLst xmlns:a="http://schemas.openxmlformats.org/drawingml/2006/main">
+              <a:ext uri="{FF2B5EF4-FFF2-40B4-BE49-F238E27FC236}">
+                <a16:creationId xmlns:a16="http://schemas.microsoft.com/office/drawing/2014/main" id="{8DD3379E-1FD6-4B9F-A00C-EB7984ED5D85}"/>
               </a:ext>
             </a:extLst>
           </p:cNvPr>
@@ -3570,6 +3537,9 @@
                 <a:solidFill>
                   <a:srgbClr val="102033"/>
                 </a:solidFill>
+                <a:latin typeface="Lato"/>
+                <a:ea typeface="Lato"/>
+                <a:cs typeface="Lato"/>
               </a:defRPr>
             </a:pPr>
             <a:r>
@@ -3577,6 +3547,9 @@
                 <a:solidFill>
                   <a:srgbClr val="102033"/>
                 </a:solidFill>
+                <a:latin typeface="Lato"/>
+                <a:ea typeface="Lato"/>
+                <a:cs typeface="Lato"/>
               </a:rPr>
               <a:t>Python</a:t>
             </a:r>
@@ -3585,10 +3558,10 @@
       </p:sp>
       <p:sp>
         <p:nvSpPr>
-          <p:cNvPr id="24" name="">
-            <a:extLst xmlns:a="http://schemas.openxmlformats.org/drawingml/2006/main">
-              <a:ext uri="{FF2B5EF4-FFF2-40B4-BE49-F238E27FC236}">
-                <a16:creationId xmlns:a16="http://schemas.microsoft.com/office/drawing/2014/main" id="{34BCD405-1496-4790-853D-EA5819B997D7}"/>
+          <p:cNvPr id="23" name="">
+            <a:extLst xmlns:a="http://schemas.openxmlformats.org/drawingml/2006/main">
+              <a:ext uri="{FF2B5EF4-FFF2-40B4-BE49-F238E27FC236}">
+                <a16:creationId xmlns:a16="http://schemas.microsoft.com/office/drawing/2014/main" id="{2122E7A9-6FB6-43A5-B95E-014611C8C169}"/>
               </a:ext>
             </a:extLst>
           </p:cNvPr>
@@ -3625,6 +3598,9 @@
                 <a:solidFill>
                   <a:srgbClr val="102033"/>
                 </a:solidFill>
+                <a:latin typeface="Lato"/>
+                <a:ea typeface="Lato"/>
+                <a:cs typeface="Lato"/>
               </a:defRPr>
             </a:pPr>
             <a:r>
@@ -3632,6 +3608,9 @@
                 <a:solidFill>
                   <a:srgbClr val="102033"/>
                 </a:solidFill>
+                <a:latin typeface="Lato"/>
+                <a:ea typeface="Lato"/>
+                <a:cs typeface="Lato"/>
               </a:rPr>
               <a:t>FastAPI</a:t>
             </a:r>
@@ -3640,10 +3619,10 @@
       </p:sp>
       <p:sp>
         <p:nvSpPr>
-          <p:cNvPr id="25" name="">
-            <a:extLst xmlns:a="http://schemas.openxmlformats.org/drawingml/2006/main">
-              <a:ext uri="{FF2B5EF4-FFF2-40B4-BE49-F238E27FC236}">
-                <a16:creationId xmlns:a16="http://schemas.microsoft.com/office/drawing/2014/main" id="{6CADADF5-B686-42C1-B24E-1D3D6584311B}"/>
+          <p:cNvPr id="24" name="">
+            <a:extLst xmlns:a="http://schemas.openxmlformats.org/drawingml/2006/main">
+              <a:ext uri="{FF2B5EF4-FFF2-40B4-BE49-F238E27FC236}">
+                <a16:creationId xmlns:a16="http://schemas.microsoft.com/office/drawing/2014/main" id="{F7064182-257F-4491-AF3B-32B642098079}"/>
               </a:ext>
             </a:extLst>
           </p:cNvPr>
@@ -3680,6 +3659,9 @@
                 <a:solidFill>
                   <a:srgbClr val="102033"/>
                 </a:solidFill>
+                <a:latin typeface="Lato"/>
+                <a:ea typeface="Lato"/>
+                <a:cs typeface="Lato"/>
               </a:defRPr>
             </a:pPr>
             <a:r>
@@ -3687,6 +3669,9 @@
                 <a:solidFill>
                   <a:srgbClr val="102033"/>
                 </a:solidFill>
+                <a:latin typeface="Lato"/>
+                <a:ea typeface="Lato"/>
+                <a:cs typeface="Lato"/>
               </a:rPr>
               <a:t>LangGraph</a:t>
             </a:r>
@@ -3695,10 +3680,10 @@
       </p:sp>
       <p:sp>
         <p:nvSpPr>
-          <p:cNvPr id="26" name="">
-            <a:extLst xmlns:a="http://schemas.openxmlformats.org/drawingml/2006/main">
-              <a:ext uri="{FF2B5EF4-FFF2-40B4-BE49-F238E27FC236}">
-                <a16:creationId xmlns:a16="http://schemas.microsoft.com/office/drawing/2014/main" id="{A79AD2C9-EB2F-44BE-B72C-156228A8A1A3}"/>
+          <p:cNvPr id="25" name="">
+            <a:extLst xmlns:a="http://schemas.openxmlformats.org/drawingml/2006/main">
+              <a:ext uri="{FF2B5EF4-FFF2-40B4-BE49-F238E27FC236}">
+                <a16:creationId xmlns:a16="http://schemas.microsoft.com/office/drawing/2014/main" id="{33AEAB26-8136-4D6E-9116-ECD61EF2842C}"/>
               </a:ext>
             </a:extLst>
           </p:cNvPr>
@@ -3735,6 +3720,9 @@
                 <a:solidFill>
                   <a:srgbClr val="102033"/>
                 </a:solidFill>
+                <a:latin typeface="Lato"/>
+                <a:ea typeface="Lato"/>
+                <a:cs typeface="Lato"/>
               </a:defRPr>
             </a:pPr>
             <a:r>
@@ -3742,6 +3730,9 @@
                 <a:solidFill>
                   <a:srgbClr val="102033"/>
                 </a:solidFill>
+                <a:latin typeface="Lato"/>
+                <a:ea typeface="Lato"/>
+                <a:cs typeface="Lato"/>
               </a:rPr>
               <a:t>Next.js</a:t>
             </a:r>
@@ -3750,10 +3741,10 @@
       </p:sp>
       <p:sp>
         <p:nvSpPr>
-          <p:cNvPr id="27" name="">
-            <a:extLst xmlns:a="http://schemas.openxmlformats.org/drawingml/2006/main">
-              <a:ext uri="{FF2B5EF4-FFF2-40B4-BE49-F238E27FC236}">
-                <a16:creationId xmlns:a16="http://schemas.microsoft.com/office/drawing/2014/main" id="{36B689C2-6F2D-4EF0-9A34-B8D7342E9285}"/>
+          <p:cNvPr id="26" name="">
+            <a:extLst xmlns:a="http://schemas.openxmlformats.org/drawingml/2006/main">
+              <a:ext uri="{FF2B5EF4-FFF2-40B4-BE49-F238E27FC236}">
+                <a16:creationId xmlns:a16="http://schemas.microsoft.com/office/drawing/2014/main" id="{13091C0F-0B8F-4937-97FC-591EA9C91E99}"/>
               </a:ext>
             </a:extLst>
           </p:cNvPr>
@@ -3790,6 +3781,9 @@
                 <a:solidFill>
                   <a:srgbClr val="102033"/>
                 </a:solidFill>
+                <a:latin typeface="Lato"/>
+                <a:ea typeface="Lato"/>
+                <a:cs typeface="Lato"/>
               </a:defRPr>
             </a:pPr>
             <a:r>
@@ -3797,6 +3791,9 @@
                 <a:solidFill>
                   <a:srgbClr val="102033"/>
                 </a:solidFill>
+                <a:latin typeface="Lato"/>
+                <a:ea typeface="Lato"/>
+                <a:cs typeface="Lato"/>
               </a:rPr>
               <a:t>PostgreSQL</a:t>
             </a:r>
@@ -3805,10 +3802,10 @@
       </p:sp>
       <p:sp>
         <p:nvSpPr>
-          <p:cNvPr id="28" name="">
-            <a:extLst xmlns:a="http://schemas.openxmlformats.org/drawingml/2006/main">
-              <a:ext uri="{FF2B5EF4-FFF2-40B4-BE49-F238E27FC236}">
-                <a16:creationId xmlns:a16="http://schemas.microsoft.com/office/drawing/2014/main" id="{563FCD28-7F54-4503-80EC-A5CC4F7930C0}"/>
+          <p:cNvPr id="27" name="">
+            <a:extLst xmlns:a="http://schemas.openxmlformats.org/drawingml/2006/main">
+              <a:ext uri="{FF2B5EF4-FFF2-40B4-BE49-F238E27FC236}">
+                <a16:creationId xmlns:a16="http://schemas.microsoft.com/office/drawing/2014/main" id="{4D9521F7-D506-43FB-AA86-CB86CAC32C9A}"/>
               </a:ext>
             </a:extLst>
           </p:cNvPr>
@@ -3845,6 +3842,9 @@
                 <a:solidFill>
                   <a:srgbClr val="102033"/>
                 </a:solidFill>
+                <a:latin typeface="Lato"/>
+                <a:ea typeface="Lato"/>
+                <a:cs typeface="Lato"/>
               </a:defRPr>
             </a:pPr>
             <a:r>
@@ -3852,6 +3852,9 @@
                 <a:solidFill>
                   <a:srgbClr val="102033"/>
                 </a:solidFill>
+                <a:latin typeface="Lato"/>
+                <a:ea typeface="Lato"/>
+                <a:cs typeface="Lato"/>
               </a:rPr>
               <a:t>NIST AI RMF</a:t>
             </a:r>
@@ -3860,10 +3863,10 @@
       </p:sp>
       <p:sp>
         <p:nvSpPr>
-          <p:cNvPr id="29" name="">
-            <a:extLst xmlns:a="http://schemas.openxmlformats.org/drawingml/2006/main">
-              <a:ext uri="{FF2B5EF4-FFF2-40B4-BE49-F238E27FC236}">
-                <a16:creationId xmlns:a16="http://schemas.microsoft.com/office/drawing/2014/main" id="{55153714-5FF5-41D9-9609-383322D4E87B}"/>
+          <p:cNvPr id="28" name="">
+            <a:extLst xmlns:a="http://schemas.openxmlformats.org/drawingml/2006/main">
+              <a:ext uri="{FF2B5EF4-FFF2-40B4-BE49-F238E27FC236}">
+                <a16:creationId xmlns:a16="http://schemas.microsoft.com/office/drawing/2014/main" id="{D700CACA-620A-427C-A0C4-6C0831F6CFB6}"/>
               </a:ext>
             </a:extLst>
           </p:cNvPr>
@@ -3895,6 +3898,9 @@
                 <a:solidFill>
                   <a:srgbClr val="5A6678"/>
                 </a:solidFill>
+                <a:latin typeface="Lato"/>
+                <a:ea typeface="Lato"/>
+                <a:cs typeface="Lato"/>
               </a:defRPr>
             </a:pPr>
             <a:r>
@@ -3902,18 +3908,21 @@
                 <a:solidFill>
                   <a:srgbClr val="5A6678"/>
                 </a:solidFill>
-              </a:rPr>
-              <a:t>github.com/icheftech/AI-Portfolio-Leroy-Brown</a:t>
-            </a:r>
-          </a:p>
-        </p:txBody>
-      </p:sp>
-      <p:sp>
-        <p:nvSpPr>
-          <p:cNvPr id="30" name="">
-            <a:extLst xmlns:a="http://schemas.openxmlformats.org/drawingml/2006/main">
-              <a:ext uri="{FF2B5EF4-FFF2-40B4-BE49-F238E27FC236}">
-                <a16:creationId xmlns:a16="http://schemas.microsoft.com/office/drawing/2014/main" id="{C1CE9615-2586-446D-A520-D6B4DA699165}"/>
+                <a:latin typeface="Lato"/>
+                <a:ea typeface="Lato"/>
+                <a:cs typeface="Lato"/>
+              </a:rPr>
+              <a:t>github.com/icheftech/Leroy-Brown-HCC-AI-Portfolio</a:t>
+            </a:r>
+          </a:p>
+        </p:txBody>
+      </p:sp>
+      <p:sp>
+        <p:nvSpPr>
+          <p:cNvPr id="29" name="">
+            <a:extLst xmlns:a="http://schemas.openxmlformats.org/drawingml/2006/main">
+              <a:ext uri="{FF2B5EF4-FFF2-40B4-BE49-F238E27FC236}">
+                <a16:creationId xmlns:a16="http://schemas.microsoft.com/office/drawing/2014/main" id="{10077C91-D3CC-4598-91D7-0BEB22784D4A}"/>
               </a:ext>
             </a:extLst>
           </p:cNvPr>
@@ -3945,6 +3954,9 @@
                 <a:solidFill>
                   <a:srgbClr val="5A6678"/>
                 </a:solidFill>
+                <a:latin typeface="Lato"/>
+                <a:ea typeface="Lato"/>
+                <a:cs typeface="Lato"/>
               </a:defRPr>
             </a:pPr>
             <a:r>
@@ -3952,6 +3964,9 @@
                 <a:solidFill>
                   <a:srgbClr val="5A6678"/>
                 </a:solidFill>
+                <a:latin typeface="Lato"/>
+                <a:ea typeface="Lato"/>
+                <a:cs typeface="Lato"/>
               </a:rPr>
               <a:t>Applied AI &amp; Robotics Portfolio</a:t>
             </a:r>
@@ -3961,7 +3976,7 @@
     </p:spTree>
     <p:extLst>
       <p:ext uri="{BB962C8B-B14F-4D97-AF65-F5344CB8AC3E}">
-        <p14:creationId xmlns:p14="http://schemas.microsoft.com/office/powerpoint/2010/main" val="1293106019"/>
+        <p14:creationId xmlns:p14="http://schemas.microsoft.com/office/powerpoint/2010/main" val="2023821867"/>
       </p:ext>
     </p:extLst>
   </p:cSld>
@@ -3989,42 +4004,10 @@
       </p:grpSpPr>
       <p:sp>
         <p:nvSpPr>
-          <p:cNvPr id="1" name="Slide Number Placeholder 5">
-            <a:extLst xmlns:a="http://schemas.openxmlformats.org/drawingml/2006/main">
-              <a:ext uri="{FF2B5EF4-FFF2-40B4-BE49-F238E27FC236}">
-                <a16:creationId xmlns:a16="http://schemas.microsoft.com/office/drawing/2014/main" id="{B8270420-D236-4471-AE86-CB207C63A521}"/>
-              </a:ext>
-            </a:extLst>
-          </p:cNvPr>
-          <p:cNvSpPr>
-            <a:spLocks xmlns:a="http://schemas.openxmlformats.org/drawingml/2006/main" noGrp="1"/>
-          </p:cNvSpPr>
-          <p:nvPr>
-            <p:ph type="sldNum" idx="12"/>
-          </p:nvPr>
-        </p:nvSpPr>
-        <p:spPr>
-          <a:xfrm xmlns:a="http://schemas.openxmlformats.org/drawingml/2006/main">
-            <a:off x="1524000" y="1122363"/>
-            <a:ext cx="9144000" cy="2387600"/>
-          </a:xfrm>
-        </p:spPr>
-        <p:txBody>
-          <a:bodyPr xmlns:a="http://schemas.openxmlformats.org/drawingml/2006/main"/>
-          <a:lstStyle xmlns:a="http://schemas.openxmlformats.org/drawingml/2006/main"/>
-          <a:p xmlns:a="http://schemas.openxmlformats.org/drawingml/2006/main">
-            <a:r>
-              <a:t/>
-            </a:r>
-          </a:p>
-        </p:txBody>
-      </p:sp>
-      <p:sp>
-        <p:nvSpPr>
-          <p:cNvPr id="2" name="">
-            <a:extLst xmlns:a="http://schemas.openxmlformats.org/drawingml/2006/main">
-              <a:ext uri="{FF2B5EF4-FFF2-40B4-BE49-F238E27FC236}">
-                <a16:creationId xmlns:a16="http://schemas.microsoft.com/office/drawing/2014/main" id="{C2363C75-836B-4EAC-91C7-11E1A24CAC93}"/>
+          <p:cNvPr id="1" name="">
+            <a:extLst xmlns:a="http://schemas.openxmlformats.org/drawingml/2006/main">
+              <a:ext uri="{FF2B5EF4-FFF2-40B4-BE49-F238E27FC236}">
+                <a16:creationId xmlns:a16="http://schemas.microsoft.com/office/drawing/2014/main" id="{7EEA9B17-0731-4A6C-8AFC-C6794146A851}"/>
               </a:ext>
             </a:extLst>
           </p:cNvPr>
@@ -4053,10 +4036,10 @@
       </p:sp>
       <p:sp>
         <p:nvSpPr>
-          <p:cNvPr id="3" name="">
-            <a:extLst xmlns:a="http://schemas.openxmlformats.org/drawingml/2006/main">
-              <a:ext uri="{FF2B5EF4-FFF2-40B4-BE49-F238E27FC236}">
-                <a16:creationId xmlns:a16="http://schemas.microsoft.com/office/drawing/2014/main" id="{13CF0F2A-E9BF-4EE7-A6E7-3D99F6DAFF84}"/>
+          <p:cNvPr id="2" name="">
+            <a:extLst xmlns:a="http://schemas.openxmlformats.org/drawingml/2006/main">
+              <a:ext uri="{FF2B5EF4-FFF2-40B4-BE49-F238E27FC236}">
+                <a16:creationId xmlns:a16="http://schemas.microsoft.com/office/drawing/2014/main" id="{9BEE9483-BA64-41A9-A875-E3352D196374}"/>
               </a:ext>
             </a:extLst>
           </p:cNvPr>
@@ -4085,10 +4068,10 @@
       </p:sp>
       <p:sp>
         <p:nvSpPr>
-          <p:cNvPr id="4" name="">
-            <a:extLst xmlns:a="http://schemas.openxmlformats.org/drawingml/2006/main">
-              <a:ext uri="{FF2B5EF4-FFF2-40B4-BE49-F238E27FC236}">
-                <a16:creationId xmlns:a16="http://schemas.microsoft.com/office/drawing/2014/main" id="{6AF09ADC-2542-4C43-98EB-886D95FDBED5}"/>
+          <p:cNvPr id="3" name="">
+            <a:extLst xmlns:a="http://schemas.openxmlformats.org/drawingml/2006/main">
+              <a:ext uri="{FF2B5EF4-FFF2-40B4-BE49-F238E27FC236}">
+                <a16:creationId xmlns:a16="http://schemas.microsoft.com/office/drawing/2014/main" id="{31BC9681-ECCA-4999-9136-A930EBC48431}"/>
               </a:ext>
             </a:extLst>
           </p:cNvPr>
@@ -4120,6 +4103,9 @@
                 <a:solidFill>
                   <a:srgbClr val="102033"/>
                 </a:solidFill>
+                <a:latin typeface="Poppins"/>
+                <a:ea typeface="Poppins"/>
+                <a:cs typeface="Poppins"/>
               </a:defRPr>
             </a:pPr>
             <a:r>
@@ -4127,6 +4113,9 @@
                 <a:solidFill>
                   <a:srgbClr val="102033"/>
                 </a:solidFill>
+                <a:latin typeface="Poppins"/>
+                <a:ea typeface="Poppins"/>
+                <a:cs typeface="Poppins"/>
               </a:rPr>
               <a:t>Featured Projects</a:t>
             </a:r>
@@ -4135,10 +4124,10 @@
       </p:sp>
       <p:sp>
         <p:nvSpPr>
-          <p:cNvPr id="5" name="">
-            <a:extLst xmlns:a="http://schemas.openxmlformats.org/drawingml/2006/main">
-              <a:ext uri="{FF2B5EF4-FFF2-40B4-BE49-F238E27FC236}">
-                <a16:creationId xmlns:a16="http://schemas.microsoft.com/office/drawing/2014/main" id="{CB6103DE-C477-41F0-B5A5-A70F3AA7F933}"/>
+          <p:cNvPr id="4" name="">
+            <a:extLst xmlns:a="http://schemas.openxmlformats.org/drawingml/2006/main">
+              <a:ext uri="{FF2B5EF4-FFF2-40B4-BE49-F238E27FC236}">
+                <a16:creationId xmlns:a16="http://schemas.microsoft.com/office/drawing/2014/main" id="{1ED30812-C413-409E-B895-1F8E324A0D70}"/>
               </a:ext>
             </a:extLst>
           </p:cNvPr>
@@ -4170,6 +4159,9 @@
                 <a:solidFill>
                   <a:srgbClr val="5A6678"/>
                 </a:solidFill>
+                <a:latin typeface="Lato"/>
+                <a:ea typeface="Lato"/>
+                <a:cs typeface="Lato"/>
               </a:defRPr>
             </a:pPr>
             <a:r>
@@ -4177,6 +4169,9 @@
                 <a:solidFill>
                   <a:srgbClr val="5A6678"/>
                 </a:solidFill>
+                <a:latin typeface="Lato"/>
+                <a:ea typeface="Lato"/>
+                <a:cs typeface="Lato"/>
               </a:rPr>
               <a:t>Three examples show the portfolio range: NLP, governance, and business automation.</a:t>
             </a:r>
@@ -4185,10 +4180,10 @@
       </p:sp>
       <p:sp>
         <p:nvSpPr>
-          <p:cNvPr id="6" name="">
-            <a:extLst xmlns:a="http://schemas.openxmlformats.org/drawingml/2006/main">
-              <a:ext uri="{FF2B5EF4-FFF2-40B4-BE49-F238E27FC236}">
-                <a16:creationId xmlns:a16="http://schemas.microsoft.com/office/drawing/2014/main" id="{A171D669-6216-431D-ABF9-4D1BDA47C03B}"/>
+          <p:cNvPr id="5" name="">
+            <a:extLst xmlns:a="http://schemas.openxmlformats.org/drawingml/2006/main">
+              <a:ext uri="{FF2B5EF4-FFF2-40B4-BE49-F238E27FC236}">
+                <a16:creationId xmlns:a16="http://schemas.microsoft.com/office/drawing/2014/main" id="{1FBA2449-ED34-4845-9581-B1A37DBA295E}"/>
               </a:ext>
             </a:extLst>
           </p:cNvPr>
@@ -4219,10 +4214,10 @@
       </p:sp>
       <p:sp>
         <p:nvSpPr>
-          <p:cNvPr id="7" name="">
-            <a:extLst xmlns:a="http://schemas.openxmlformats.org/drawingml/2006/main">
-              <a:ext uri="{FF2B5EF4-FFF2-40B4-BE49-F238E27FC236}">
-                <a16:creationId xmlns:a16="http://schemas.microsoft.com/office/drawing/2014/main" id="{444B90F7-B531-4D8C-8C76-E789C7C96630}"/>
+          <p:cNvPr id="6" name="">
+            <a:extLst xmlns:a="http://schemas.openxmlformats.org/drawingml/2006/main">
+              <a:ext uri="{FF2B5EF4-FFF2-40B4-BE49-F238E27FC236}">
+                <a16:creationId xmlns:a16="http://schemas.microsoft.com/office/drawing/2014/main" id="{4E405854-D327-4A3C-82AC-0FA0134D7A06}"/>
               </a:ext>
             </a:extLst>
           </p:cNvPr>
@@ -4253,10 +4248,10 @@
       </p:sp>
       <p:sp>
         <p:nvSpPr>
-          <p:cNvPr id="8" name="">
-            <a:extLst xmlns:a="http://schemas.openxmlformats.org/drawingml/2006/main">
-              <a:ext uri="{FF2B5EF4-FFF2-40B4-BE49-F238E27FC236}">
-                <a16:creationId xmlns:a16="http://schemas.microsoft.com/office/drawing/2014/main" id="{3AB1BBAB-3CE5-4DD0-B23D-980B60395B36}"/>
+          <p:cNvPr id="7" name="">
+            <a:extLst xmlns:a="http://schemas.openxmlformats.org/drawingml/2006/main">
+              <a:ext uri="{FF2B5EF4-FFF2-40B4-BE49-F238E27FC236}">
+                <a16:creationId xmlns:a16="http://schemas.microsoft.com/office/drawing/2014/main" id="{0ACFDCE0-8252-4F50-A6F7-CC054CA85E9F}"/>
               </a:ext>
             </a:extLst>
           </p:cNvPr>
@@ -4285,10 +4280,10 @@
       </p:sp>
       <p:sp>
         <p:nvSpPr>
-          <p:cNvPr id="9" name="">
-            <a:extLst xmlns:a="http://schemas.openxmlformats.org/drawingml/2006/main">
-              <a:ext uri="{FF2B5EF4-FFF2-40B4-BE49-F238E27FC236}">
-                <a16:creationId xmlns:a16="http://schemas.microsoft.com/office/drawing/2014/main" id="{818E270F-9EA5-4A17-94DE-3CE74FB22274}"/>
+          <p:cNvPr id="8" name="">
+            <a:extLst xmlns:a="http://schemas.openxmlformats.org/drawingml/2006/main">
+              <a:ext uri="{FF2B5EF4-FFF2-40B4-BE49-F238E27FC236}">
+                <a16:creationId xmlns:a16="http://schemas.microsoft.com/office/drawing/2014/main" id="{D645B93B-AD14-4E74-9330-3867DA6377C2}"/>
               </a:ext>
             </a:extLst>
           </p:cNvPr>
@@ -4313,7 +4308,7 @@
         </p:spPr>
         <p:txBody>
           <a:bodyPr xmlns:a="http://schemas.openxmlformats.org/drawingml/2006/main" lIns="0" tIns="0" rIns="0" bIns="0" anchor="t">
-            <a:normAutofit fontScale="94033"/>
+            <a:normAutofit fontScale="95679"/>
           </a:bodyPr>
           <a:lstStyle xmlns:a="http://schemas.openxmlformats.org/drawingml/2006/main"/>
           <a:p xmlns:a="http://schemas.openxmlformats.org/drawingml/2006/main">
@@ -4322,6 +4317,9 @@
                 <a:solidFill>
                   <a:srgbClr val="102033"/>
                 </a:solidFill>
+                <a:latin typeface="Lato"/>
+                <a:ea typeface="Lato"/>
+                <a:cs typeface="Lato"/>
               </a:defRPr>
             </a:pPr>
             <a:r>
@@ -4329,6 +4327,9 @@
                 <a:solidFill>
                   <a:srgbClr val="102033"/>
                 </a:solidFill>
+                <a:latin typeface="Lato"/>
+                <a:ea typeface="Lato"/>
+                <a:cs typeface="Lato"/>
               </a:rPr>
               <a:t>NewsBot Intelligence Engine</a:t>
             </a:r>
@@ -4337,10 +4338,10 @@
       </p:sp>
       <p:sp>
         <p:nvSpPr>
-          <p:cNvPr id="10" name="">
-            <a:extLst xmlns:a="http://schemas.openxmlformats.org/drawingml/2006/main">
-              <a:ext uri="{FF2B5EF4-FFF2-40B4-BE49-F238E27FC236}">
-                <a16:creationId xmlns:a16="http://schemas.microsoft.com/office/drawing/2014/main" id="{28D6CABA-B213-4C20-AB81-313B0A9E1B0F}"/>
+          <p:cNvPr id="9" name="">
+            <a:extLst xmlns:a="http://schemas.openxmlformats.org/drawingml/2006/main">
+              <a:ext uri="{FF2B5EF4-FFF2-40B4-BE49-F238E27FC236}">
+                <a16:creationId xmlns:a16="http://schemas.microsoft.com/office/drawing/2014/main" id="{F0D79027-D906-4487-B77D-C61177957310}"/>
               </a:ext>
             </a:extLst>
           </p:cNvPr>
@@ -4374,6 +4375,9 @@
                 <a:solidFill>
                   <a:srgbClr val="5A6678"/>
                 </a:solidFill>
+                <a:latin typeface="Lato"/>
+                <a:ea typeface="Lato"/>
+                <a:cs typeface="Lato"/>
               </a:defRPr>
             </a:pPr>
             <a:r>
@@ -4381,6 +4385,9 @@
                 <a:solidFill>
                   <a:srgbClr val="5A6678"/>
                 </a:solidFill>
+                <a:latin typeface="Lato"/>
+                <a:ea typeface="Lato"/>
+                <a:cs typeface="Lato"/>
               </a:rPr>
               <a:t>Turns raw news into topics, summaries, sentiment, embeddings, and an interactive Gradio interface.</a:t>
             </a:r>
@@ -4389,10 +4396,10 @@
       </p:sp>
       <p:sp>
         <p:nvSpPr>
-          <p:cNvPr id="11" name="">
-            <a:extLst xmlns:a="http://schemas.openxmlformats.org/drawingml/2006/main">
-              <a:ext uri="{FF2B5EF4-FFF2-40B4-BE49-F238E27FC236}">
-                <a16:creationId xmlns:a16="http://schemas.microsoft.com/office/drawing/2014/main" id="{2E1284FA-34ED-4C9C-BF20-332C2C4771D5}"/>
+          <p:cNvPr id="10" name="">
+            <a:extLst xmlns:a="http://schemas.openxmlformats.org/drawingml/2006/main">
+              <a:ext uri="{FF2B5EF4-FFF2-40B4-BE49-F238E27FC236}">
+                <a16:creationId xmlns:a16="http://schemas.microsoft.com/office/drawing/2014/main" id="{768151A9-6997-465B-B389-6100FD2DB3E5}"/>
               </a:ext>
             </a:extLst>
           </p:cNvPr>
@@ -4417,7 +4424,7 @@
         </p:spPr>
         <p:txBody>
           <a:bodyPr xmlns:a="http://schemas.openxmlformats.org/drawingml/2006/main" lIns="0" tIns="0" rIns="0" bIns="0" anchor="t">
-            <a:normAutofit fontScale="95549"/>
+            <a:normAutofit fontScale="97222"/>
           </a:bodyPr>
           <a:lstStyle xmlns:a="http://schemas.openxmlformats.org/drawingml/2006/main"/>
           <a:p xmlns:a="http://schemas.openxmlformats.org/drawingml/2006/main">
@@ -4426,6 +4433,9 @@
                 <a:solidFill>
                   <a:srgbClr val="12A8C8"/>
                 </a:solidFill>
+                <a:latin typeface="Lato"/>
+                <a:ea typeface="Lato"/>
+                <a:cs typeface="Lato"/>
               </a:defRPr>
             </a:pPr>
             <a:r>
@@ -4433,6 +4443,9 @@
                 <a:solidFill>
                   <a:srgbClr val="12A8C8"/>
                 </a:solidFill>
+                <a:latin typeface="Lato"/>
+                <a:ea typeface="Lato"/>
+                <a:cs typeface="Lato"/>
               </a:rPr>
               <a:t>FastAPI | LDA | DistilBART | SentenceTransformers</a:t>
             </a:r>
@@ -4441,10 +4454,10 @@
       </p:sp>
       <p:sp>
         <p:nvSpPr>
-          <p:cNvPr id="12" name="">
-            <a:extLst xmlns:a="http://schemas.openxmlformats.org/drawingml/2006/main">
-              <a:ext uri="{FF2B5EF4-FFF2-40B4-BE49-F238E27FC236}">
-                <a16:creationId xmlns:a16="http://schemas.microsoft.com/office/drawing/2014/main" id="{3BE87CDD-2395-4C2B-8782-A906AF0FF2A4}"/>
+          <p:cNvPr id="11" name="">
+            <a:extLst xmlns:a="http://schemas.openxmlformats.org/drawingml/2006/main">
+              <a:ext uri="{FF2B5EF4-FFF2-40B4-BE49-F238E27FC236}">
+                <a16:creationId xmlns:a16="http://schemas.microsoft.com/office/drawing/2014/main" id="{B3339F8A-F8E1-44F1-B8B1-BA7534F899BF}"/>
               </a:ext>
             </a:extLst>
           </p:cNvPr>
@@ -4475,10 +4488,10 @@
       </p:sp>
       <p:sp>
         <p:nvSpPr>
-          <p:cNvPr id="13" name="">
-            <a:extLst xmlns:a="http://schemas.openxmlformats.org/drawingml/2006/main">
-              <a:ext uri="{FF2B5EF4-FFF2-40B4-BE49-F238E27FC236}">
-                <a16:creationId xmlns:a16="http://schemas.microsoft.com/office/drawing/2014/main" id="{431CDFB2-FE59-4DFF-B982-F712CA1DD777}"/>
+          <p:cNvPr id="12" name="">
+            <a:extLst xmlns:a="http://schemas.openxmlformats.org/drawingml/2006/main">
+              <a:ext uri="{FF2B5EF4-FFF2-40B4-BE49-F238E27FC236}">
+                <a16:creationId xmlns:a16="http://schemas.microsoft.com/office/drawing/2014/main" id="{88CA8BA7-CE48-4DDB-982A-D365BC3CA9F3}"/>
               </a:ext>
             </a:extLst>
           </p:cNvPr>
@@ -4509,10 +4522,10 @@
       </p:sp>
       <p:sp>
         <p:nvSpPr>
-          <p:cNvPr id="14" name="">
-            <a:extLst xmlns:a="http://schemas.openxmlformats.org/drawingml/2006/main">
-              <a:ext uri="{FF2B5EF4-FFF2-40B4-BE49-F238E27FC236}">
-                <a16:creationId xmlns:a16="http://schemas.microsoft.com/office/drawing/2014/main" id="{21CEF00B-6974-458C-9FA0-FD18D726B0B3}"/>
+          <p:cNvPr id="13" name="">
+            <a:extLst xmlns:a="http://schemas.openxmlformats.org/drawingml/2006/main">
+              <a:ext uri="{FF2B5EF4-FFF2-40B4-BE49-F238E27FC236}">
+                <a16:creationId xmlns:a16="http://schemas.microsoft.com/office/drawing/2014/main" id="{4C9EB5F3-BCA2-4845-930C-F0100F1E8F1E}"/>
               </a:ext>
             </a:extLst>
           </p:cNvPr>
@@ -4541,10 +4554,10 @@
       </p:sp>
       <p:sp>
         <p:nvSpPr>
-          <p:cNvPr id="15" name="">
-            <a:extLst xmlns:a="http://schemas.openxmlformats.org/drawingml/2006/main">
-              <a:ext uri="{FF2B5EF4-FFF2-40B4-BE49-F238E27FC236}">
-                <a16:creationId xmlns:a16="http://schemas.microsoft.com/office/drawing/2014/main" id="{DC30FB31-641C-4698-A167-23BA873E2A5A}"/>
+          <p:cNvPr id="14" name="">
+            <a:extLst xmlns:a="http://schemas.openxmlformats.org/drawingml/2006/main">
+              <a:ext uri="{FF2B5EF4-FFF2-40B4-BE49-F238E27FC236}">
+                <a16:creationId xmlns:a16="http://schemas.microsoft.com/office/drawing/2014/main" id="{EFF4415E-A943-4633-9FF4-21A40A00495B}"/>
               </a:ext>
             </a:extLst>
           </p:cNvPr>
@@ -4578,6 +4591,9 @@
                 <a:solidFill>
                   <a:srgbClr val="102033"/>
                 </a:solidFill>
+                <a:latin typeface="Lato"/>
+                <a:ea typeface="Lato"/>
+                <a:cs typeface="Lato"/>
               </a:defRPr>
             </a:pPr>
             <a:r>
@@ -4585,6 +4601,9 @@
                 <a:solidFill>
                   <a:srgbClr val="102033"/>
                 </a:solidFill>
+                <a:latin typeface="Lato"/>
+                <a:ea typeface="Lato"/>
+                <a:cs typeface="Lato"/>
               </a:rPr>
               <a:t>SSO Control Plane</a:t>
             </a:r>
@@ -4593,10 +4612,10 @@
       </p:sp>
       <p:sp>
         <p:nvSpPr>
-          <p:cNvPr id="16" name="">
-            <a:extLst xmlns:a="http://schemas.openxmlformats.org/drawingml/2006/main">
-              <a:ext uri="{FF2B5EF4-FFF2-40B4-BE49-F238E27FC236}">
-                <a16:creationId xmlns:a16="http://schemas.microsoft.com/office/drawing/2014/main" id="{A2C7B157-AA62-494C-AB85-74EF33E41673}"/>
+          <p:cNvPr id="15" name="">
+            <a:extLst xmlns:a="http://schemas.openxmlformats.org/drawingml/2006/main">
+              <a:ext uri="{FF2B5EF4-FFF2-40B4-BE49-F238E27FC236}">
+                <a16:creationId xmlns:a16="http://schemas.microsoft.com/office/drawing/2014/main" id="{97E59CDC-5353-40F3-A358-F4BC3465CFBD}"/>
               </a:ext>
             </a:extLst>
           </p:cNvPr>
@@ -4630,6 +4649,9 @@
                 <a:solidFill>
                   <a:srgbClr val="5A6678"/>
                 </a:solidFill>
+                <a:latin typeface="Lato"/>
+                <a:ea typeface="Lato"/>
+                <a:cs typeface="Lato"/>
               </a:defRPr>
             </a:pPr>
             <a:r>
@@ -4637,6 +4659,9 @@
                 <a:solidFill>
                   <a:srgbClr val="5A6678"/>
                 </a:solidFill>
+                <a:latin typeface="Lato"/>
+                <a:ea typeface="Lato"/>
+                <a:cs typeface="Lato"/>
               </a:rPr>
               <a:t>Governs AI workflows with NIST AI RMF alignment, policy gates, emergency stops, and cryptographic audit chains.</a:t>
             </a:r>
@@ -4645,10 +4670,10 @@
       </p:sp>
       <p:sp>
         <p:nvSpPr>
-          <p:cNvPr id="17" name="">
-            <a:extLst xmlns:a="http://schemas.openxmlformats.org/drawingml/2006/main">
-              <a:ext uri="{FF2B5EF4-FFF2-40B4-BE49-F238E27FC236}">
-                <a16:creationId xmlns:a16="http://schemas.microsoft.com/office/drawing/2014/main" id="{8C8E9791-B1A5-4BF9-9452-7FC9E5B6ABBC}"/>
+          <p:cNvPr id="16" name="">
+            <a:extLst xmlns:a="http://schemas.openxmlformats.org/drawingml/2006/main">
+              <a:ext uri="{FF2B5EF4-FFF2-40B4-BE49-F238E27FC236}">
+                <a16:creationId xmlns:a16="http://schemas.microsoft.com/office/drawing/2014/main" id="{4B0160C7-2B16-4EFA-AA7F-138894418644}"/>
               </a:ext>
             </a:extLst>
           </p:cNvPr>
@@ -4673,7 +4698,7 @@
         </p:spPr>
         <p:txBody>
           <a:bodyPr xmlns:a="http://schemas.openxmlformats.org/drawingml/2006/main" lIns="0" tIns="0" rIns="0" bIns="0" anchor="t">
-            <a:normAutofit fontScale="95549"/>
+            <a:normAutofit fontScale="97222"/>
           </a:bodyPr>
           <a:lstStyle xmlns:a="http://schemas.openxmlformats.org/drawingml/2006/main"/>
           <a:p xmlns:a="http://schemas.openxmlformats.org/drawingml/2006/main">
@@ -4682,6 +4707,9 @@
                 <a:solidFill>
                   <a:srgbClr val="D99A2B"/>
                 </a:solidFill>
+                <a:latin typeface="Lato"/>
+                <a:ea typeface="Lato"/>
+                <a:cs typeface="Lato"/>
               </a:defRPr>
             </a:pPr>
             <a:r>
@@ -4689,6 +4717,9 @@
                 <a:solidFill>
                   <a:srgbClr val="D99A2B"/>
                 </a:solidFill>
+                <a:latin typeface="Lato"/>
+                <a:ea typeface="Lato"/>
+                <a:cs typeface="Lato"/>
               </a:rPr>
               <a:t>Python | FastAPI | PostgreSQL | SQLAlchemy</a:t>
             </a:r>
@@ -4697,10 +4728,10 @@
       </p:sp>
       <p:sp>
         <p:nvSpPr>
-          <p:cNvPr id="18" name="">
-            <a:extLst xmlns:a="http://schemas.openxmlformats.org/drawingml/2006/main">
-              <a:ext uri="{FF2B5EF4-FFF2-40B4-BE49-F238E27FC236}">
-                <a16:creationId xmlns:a16="http://schemas.microsoft.com/office/drawing/2014/main" id="{7569A245-CECE-45A2-8BD8-DDBC36422D72}"/>
+          <p:cNvPr id="17" name="">
+            <a:extLst xmlns:a="http://schemas.openxmlformats.org/drawingml/2006/main">
+              <a:ext uri="{FF2B5EF4-FFF2-40B4-BE49-F238E27FC236}">
+                <a16:creationId xmlns:a16="http://schemas.microsoft.com/office/drawing/2014/main" id="{E54A735E-5E62-4C13-8FFE-59E24C151866}"/>
               </a:ext>
             </a:extLst>
           </p:cNvPr>
@@ -4731,10 +4762,10 @@
       </p:sp>
       <p:sp>
         <p:nvSpPr>
-          <p:cNvPr id="19" name="">
-            <a:extLst xmlns:a="http://schemas.openxmlformats.org/drawingml/2006/main">
-              <a:ext uri="{FF2B5EF4-FFF2-40B4-BE49-F238E27FC236}">
-                <a16:creationId xmlns:a16="http://schemas.microsoft.com/office/drawing/2014/main" id="{6C1EC70C-CCF2-4D40-9FA9-90149F18D3BE}"/>
+          <p:cNvPr id="18" name="">
+            <a:extLst xmlns:a="http://schemas.openxmlformats.org/drawingml/2006/main">
+              <a:ext uri="{FF2B5EF4-FFF2-40B4-BE49-F238E27FC236}">
+                <a16:creationId xmlns:a16="http://schemas.microsoft.com/office/drawing/2014/main" id="{57027ECD-DA1E-4742-93F1-E718A332A889}"/>
               </a:ext>
             </a:extLst>
           </p:cNvPr>
@@ -4765,10 +4796,10 @@
       </p:sp>
       <p:sp>
         <p:nvSpPr>
-          <p:cNvPr id="20" name="">
-            <a:extLst xmlns:a="http://schemas.openxmlformats.org/drawingml/2006/main">
-              <a:ext uri="{FF2B5EF4-FFF2-40B4-BE49-F238E27FC236}">
-                <a16:creationId xmlns:a16="http://schemas.microsoft.com/office/drawing/2014/main" id="{CC9B82FB-3351-41E1-87BA-899971F46244}"/>
+          <p:cNvPr id="19" name="">
+            <a:extLst xmlns:a="http://schemas.openxmlformats.org/drawingml/2006/main">
+              <a:ext uri="{FF2B5EF4-FFF2-40B4-BE49-F238E27FC236}">
+                <a16:creationId xmlns:a16="http://schemas.microsoft.com/office/drawing/2014/main" id="{316DF0AA-5561-4CC0-B6A9-11A407E94EC6}"/>
               </a:ext>
             </a:extLst>
           </p:cNvPr>
@@ -4797,10 +4828,10 @@
       </p:sp>
       <p:sp>
         <p:nvSpPr>
-          <p:cNvPr id="21" name="">
-            <a:extLst xmlns:a="http://schemas.openxmlformats.org/drawingml/2006/main">
-              <a:ext uri="{FF2B5EF4-FFF2-40B4-BE49-F238E27FC236}">
-                <a16:creationId xmlns:a16="http://schemas.microsoft.com/office/drawing/2014/main" id="{BAA5D04C-50B8-47B9-A230-5DF04EDF2FFA}"/>
+          <p:cNvPr id="20" name="">
+            <a:extLst xmlns:a="http://schemas.openxmlformats.org/drawingml/2006/main">
+              <a:ext uri="{FF2B5EF4-FFF2-40B4-BE49-F238E27FC236}">
+                <a16:creationId xmlns:a16="http://schemas.microsoft.com/office/drawing/2014/main" id="{82980B74-7A63-41FC-9005-D653AE3742FB}"/>
               </a:ext>
             </a:extLst>
           </p:cNvPr>
@@ -4834,6 +4865,9 @@
                 <a:solidFill>
                   <a:srgbClr val="102033"/>
                 </a:solidFill>
+                <a:latin typeface="Lato"/>
+                <a:ea typeface="Lato"/>
+                <a:cs typeface="Lato"/>
               </a:defRPr>
             </a:pPr>
             <a:r>
@@ -4841,6 +4875,9 @@
                 <a:solidFill>
                   <a:srgbClr val="102033"/>
                 </a:solidFill>
+                <a:latin typeface="Lato"/>
+                <a:ea typeface="Lato"/>
+                <a:cs typeface="Lato"/>
               </a:rPr>
               <a:t>bidops</a:t>
             </a:r>
@@ -4849,10 +4886,10 @@
       </p:sp>
       <p:sp>
         <p:nvSpPr>
-          <p:cNvPr id="22" name="">
-            <a:extLst xmlns:a="http://schemas.openxmlformats.org/drawingml/2006/main">
-              <a:ext uri="{FF2B5EF4-FFF2-40B4-BE49-F238E27FC236}">
-                <a16:creationId xmlns:a16="http://schemas.microsoft.com/office/drawing/2014/main" id="{46925B5F-FCF2-4E36-99BF-3919D46D3817}"/>
+          <p:cNvPr id="21" name="">
+            <a:extLst xmlns:a="http://schemas.openxmlformats.org/drawingml/2006/main">
+              <a:ext uri="{FF2B5EF4-FFF2-40B4-BE49-F238E27FC236}">
+                <a16:creationId xmlns:a16="http://schemas.microsoft.com/office/drawing/2014/main" id="{A4F99332-B69F-4926-A0DF-9C4B7568A1FC}"/>
               </a:ext>
             </a:extLst>
           </p:cNvPr>
@@ -4886,6 +4923,9 @@
                 <a:solidFill>
                   <a:srgbClr val="5A6678"/>
                 </a:solidFill>
+                <a:latin typeface="Lato"/>
+                <a:ea typeface="Lato"/>
+                <a:cs typeface="Lato"/>
               </a:defRPr>
             </a:pPr>
             <a:r>
@@ -4893,6 +4933,9 @@
                 <a:solidFill>
                   <a:srgbClr val="5A6678"/>
                 </a:solidFill>
+                <a:latin typeface="Lato"/>
+                <a:ea typeface="Lato"/>
+                <a:cs typeface="Lato"/>
               </a:rPr>
               <a:t>Scores and routes public contract opportunities using AI-native sourcing workflows and operational data.</a:t>
             </a:r>
@@ -4901,10 +4944,10 @@
       </p:sp>
       <p:sp>
         <p:nvSpPr>
-          <p:cNvPr id="23" name="">
-            <a:extLst xmlns:a="http://schemas.openxmlformats.org/drawingml/2006/main">
-              <a:ext uri="{FF2B5EF4-FFF2-40B4-BE49-F238E27FC236}">
-                <a16:creationId xmlns:a16="http://schemas.microsoft.com/office/drawing/2014/main" id="{254D3E35-B207-4B91-B318-831280ACDDE0}"/>
+          <p:cNvPr id="22" name="">
+            <a:extLst xmlns:a="http://schemas.openxmlformats.org/drawingml/2006/main">
+              <a:ext uri="{FF2B5EF4-FFF2-40B4-BE49-F238E27FC236}">
+                <a16:creationId xmlns:a16="http://schemas.microsoft.com/office/drawing/2014/main" id="{1B971136-DC8D-4DA5-B8AA-534AC312724C}"/>
               </a:ext>
             </a:extLst>
           </p:cNvPr>
@@ -4929,7 +4972,7 @@
         </p:spPr>
         <p:txBody>
           <a:bodyPr xmlns:a="http://schemas.openxmlformats.org/drawingml/2006/main" lIns="0" tIns="0" rIns="0" bIns="0" anchor="t">
-            <a:normAutofit fontScale="95549"/>
+            <a:normAutofit fontScale="97222"/>
           </a:bodyPr>
           <a:lstStyle xmlns:a="http://schemas.openxmlformats.org/drawingml/2006/main"/>
           <a:p xmlns:a="http://schemas.openxmlformats.org/drawingml/2006/main">
@@ -4938,6 +4981,9 @@
                 <a:solidFill>
                   <a:srgbClr val="22A06B"/>
                 </a:solidFill>
+                <a:latin typeface="Lato"/>
+                <a:ea typeface="Lato"/>
+                <a:cs typeface="Lato"/>
               </a:defRPr>
             </a:pPr>
             <a:r>
@@ -4945,6 +4991,9 @@
                 <a:solidFill>
                   <a:srgbClr val="22A06B"/>
                 </a:solidFill>
+                <a:latin typeface="Lato"/>
+                <a:ea typeface="Lato"/>
+                <a:cs typeface="Lato"/>
               </a:rPr>
               <a:t>Next.js | FastAPI | LangGraph | Railway Postgres</a:t>
             </a:r>
@@ -4953,10 +5002,10 @@
       </p:sp>
       <p:sp>
         <p:nvSpPr>
-          <p:cNvPr id="24" name="">
-            <a:extLst xmlns:a="http://schemas.openxmlformats.org/drawingml/2006/main">
-              <a:ext uri="{FF2B5EF4-FFF2-40B4-BE49-F238E27FC236}">
-                <a16:creationId xmlns:a16="http://schemas.microsoft.com/office/drawing/2014/main" id="{0118B15B-9D43-4400-BFF7-9191C0248075}"/>
+          <p:cNvPr id="23" name="">
+            <a:extLst xmlns:a="http://schemas.openxmlformats.org/drawingml/2006/main">
+              <a:ext uri="{FF2B5EF4-FFF2-40B4-BE49-F238E27FC236}">
+                <a16:creationId xmlns:a16="http://schemas.microsoft.com/office/drawing/2014/main" id="{C4189ECF-91D5-4199-9E5C-7DF4239C8502}"/>
               </a:ext>
             </a:extLst>
           </p:cNvPr>
@@ -4988,6 +5037,9 @@
                 <a:solidFill>
                   <a:srgbClr val="5A6678"/>
                 </a:solidFill>
+                <a:latin typeface="Lato"/>
+                <a:ea typeface="Lato"/>
+                <a:cs typeface="Lato"/>
               </a:defRPr>
             </a:pPr>
             <a:r>
@@ -4995,6 +5047,9 @@
                 <a:solidFill>
                   <a:srgbClr val="5A6678"/>
                 </a:solidFill>
+                <a:latin typeface="Lato"/>
+                <a:ea typeface="Lato"/>
+                <a:cs typeface="Lato"/>
               </a:rPr>
               <a:t>Project links are available from the main portfolio README.</a:t>
             </a:r>
@@ -5003,10 +5058,10 @@
       </p:sp>
       <p:sp>
         <p:nvSpPr>
-          <p:cNvPr id="25" name="">
-            <a:extLst xmlns:a="http://schemas.openxmlformats.org/drawingml/2006/main">
-              <a:ext uri="{FF2B5EF4-FFF2-40B4-BE49-F238E27FC236}">
-                <a16:creationId xmlns:a16="http://schemas.microsoft.com/office/drawing/2014/main" id="{8D39ED97-53DD-42A3-9E16-EDE6A0EDB201}"/>
+          <p:cNvPr id="24" name="">
+            <a:extLst xmlns:a="http://schemas.openxmlformats.org/drawingml/2006/main">
+              <a:ext uri="{FF2B5EF4-FFF2-40B4-BE49-F238E27FC236}">
+                <a16:creationId xmlns:a16="http://schemas.microsoft.com/office/drawing/2014/main" id="{950FCA1F-59C4-496F-B8AF-F04553CDF599}"/>
               </a:ext>
             </a:extLst>
           </p:cNvPr>
@@ -5038,6 +5093,9 @@
                 <a:solidFill>
                   <a:srgbClr val="5A6678"/>
                 </a:solidFill>
+                <a:latin typeface="Lato"/>
+                <a:ea typeface="Lato"/>
+                <a:cs typeface="Lato"/>
               </a:defRPr>
             </a:pPr>
             <a:r>
@@ -5045,18 +5103,21 @@
                 <a:solidFill>
                   <a:srgbClr val="5A6678"/>
                 </a:solidFill>
-              </a:rPr>
-              <a:t>github.com/icheftech/AI-Portfolio-Leroy-Brown</a:t>
-            </a:r>
-          </a:p>
-        </p:txBody>
-      </p:sp>
-      <p:sp>
-        <p:nvSpPr>
-          <p:cNvPr id="26" name="">
-            <a:extLst xmlns:a="http://schemas.openxmlformats.org/drawingml/2006/main">
-              <a:ext uri="{FF2B5EF4-FFF2-40B4-BE49-F238E27FC236}">
-                <a16:creationId xmlns:a16="http://schemas.microsoft.com/office/drawing/2014/main" id="{B5FBB24C-5A86-441E-A780-9DE63A7EFE7B}"/>
+                <a:latin typeface="Lato"/>
+                <a:ea typeface="Lato"/>
+                <a:cs typeface="Lato"/>
+              </a:rPr>
+              <a:t>github.com/icheftech/Leroy-Brown-HCC-AI-Portfolio</a:t>
+            </a:r>
+          </a:p>
+        </p:txBody>
+      </p:sp>
+      <p:sp>
+        <p:nvSpPr>
+          <p:cNvPr id="25" name="">
+            <a:extLst xmlns:a="http://schemas.openxmlformats.org/drawingml/2006/main">
+              <a:ext uri="{FF2B5EF4-FFF2-40B4-BE49-F238E27FC236}">
+                <a16:creationId xmlns:a16="http://schemas.microsoft.com/office/drawing/2014/main" id="{EEFA41C6-C06F-4427-B2CB-54BF9CACE29A}"/>
               </a:ext>
             </a:extLst>
           </p:cNvPr>
@@ -5088,6 +5149,9 @@
                 <a:solidFill>
                   <a:srgbClr val="5A6678"/>
                 </a:solidFill>
+                <a:latin typeface="Lato"/>
+                <a:ea typeface="Lato"/>
+                <a:cs typeface="Lato"/>
               </a:defRPr>
             </a:pPr>
             <a:r>
@@ -5095,6 +5159,9 @@
                 <a:solidFill>
                   <a:srgbClr val="5A6678"/>
                 </a:solidFill>
+                <a:latin typeface="Lato"/>
+                <a:ea typeface="Lato"/>
+                <a:cs typeface="Lato"/>
               </a:rPr>
               <a:t>Applied AI &amp; Robotics Portfolio</a:t>
             </a:r>
@@ -5104,7 +5171,7 @@
     </p:spTree>
     <p:extLst>
       <p:ext uri="{BB962C8B-B14F-4D97-AF65-F5344CB8AC3E}">
-        <p14:creationId xmlns:p14="http://schemas.microsoft.com/office/powerpoint/2010/main" val="786708748"/>
+        <p14:creationId xmlns:p14="http://schemas.microsoft.com/office/powerpoint/2010/main" val="1767059474"/>
       </p:ext>
     </p:extLst>
   </p:cSld>
@@ -5132,42 +5199,10 @@
       </p:grpSpPr>
       <p:sp>
         <p:nvSpPr>
-          <p:cNvPr id="1" name="Slide Number Placeholder 5">
-            <a:extLst xmlns:a="http://schemas.openxmlformats.org/drawingml/2006/main">
-              <a:ext uri="{FF2B5EF4-FFF2-40B4-BE49-F238E27FC236}">
-                <a16:creationId xmlns:a16="http://schemas.microsoft.com/office/drawing/2014/main" id="{B8270420-D236-4471-AE86-CB207C63A521}"/>
-              </a:ext>
-            </a:extLst>
-          </p:cNvPr>
-          <p:cNvSpPr>
-            <a:spLocks xmlns:a="http://schemas.openxmlformats.org/drawingml/2006/main" noGrp="1"/>
-          </p:cNvSpPr>
-          <p:nvPr>
-            <p:ph type="sldNum" idx="12"/>
-          </p:nvPr>
-        </p:nvSpPr>
-        <p:spPr>
-          <a:xfrm xmlns:a="http://schemas.openxmlformats.org/drawingml/2006/main">
-            <a:off x="1524000" y="1122363"/>
-            <a:ext cx="9144000" cy="2387600"/>
-          </a:xfrm>
-        </p:spPr>
-        <p:txBody>
-          <a:bodyPr xmlns:a="http://schemas.openxmlformats.org/drawingml/2006/main"/>
-          <a:lstStyle xmlns:a="http://schemas.openxmlformats.org/drawingml/2006/main"/>
-          <a:p xmlns:a="http://schemas.openxmlformats.org/drawingml/2006/main">
-            <a:r>
-              <a:t/>
-            </a:r>
-          </a:p>
-        </p:txBody>
-      </p:sp>
-      <p:sp>
-        <p:nvSpPr>
-          <p:cNvPr id="2" name="">
-            <a:extLst xmlns:a="http://schemas.openxmlformats.org/drawingml/2006/main">
-              <a:ext uri="{FF2B5EF4-FFF2-40B4-BE49-F238E27FC236}">
-                <a16:creationId xmlns:a16="http://schemas.microsoft.com/office/drawing/2014/main" id="{E3BE8159-1B70-409A-BF30-4EA4C44DBC2D}"/>
+          <p:cNvPr id="1" name="">
+            <a:extLst xmlns:a="http://schemas.openxmlformats.org/drawingml/2006/main">
+              <a:ext uri="{FF2B5EF4-FFF2-40B4-BE49-F238E27FC236}">
+                <a16:creationId xmlns:a16="http://schemas.microsoft.com/office/drawing/2014/main" id="{EB72160D-71BD-40BF-B2F0-B7C63A1C2961}"/>
               </a:ext>
             </a:extLst>
           </p:cNvPr>
@@ -5196,10 +5231,10 @@
       </p:sp>
       <p:sp>
         <p:nvSpPr>
-          <p:cNvPr id="3" name="">
-            <a:extLst xmlns:a="http://schemas.openxmlformats.org/drawingml/2006/main">
-              <a:ext uri="{FF2B5EF4-FFF2-40B4-BE49-F238E27FC236}">
-                <a16:creationId xmlns:a16="http://schemas.microsoft.com/office/drawing/2014/main" id="{D21DD263-032B-4E61-A1A4-C03E73B88B73}"/>
+          <p:cNvPr id="2" name="">
+            <a:extLst xmlns:a="http://schemas.openxmlformats.org/drawingml/2006/main">
+              <a:ext uri="{FF2B5EF4-FFF2-40B4-BE49-F238E27FC236}">
+                <a16:creationId xmlns:a16="http://schemas.microsoft.com/office/drawing/2014/main" id="{65749C79-48BF-40C8-987D-A09F3AB5B575}"/>
               </a:ext>
             </a:extLst>
           </p:cNvPr>
@@ -5228,10 +5263,10 @@
       </p:sp>
       <p:sp>
         <p:nvSpPr>
-          <p:cNvPr id="4" name="">
-            <a:extLst xmlns:a="http://schemas.openxmlformats.org/drawingml/2006/main">
-              <a:ext uri="{FF2B5EF4-FFF2-40B4-BE49-F238E27FC236}">
-                <a16:creationId xmlns:a16="http://schemas.microsoft.com/office/drawing/2014/main" id="{12705754-4296-4433-9B27-762A340D0B8E}"/>
+          <p:cNvPr id="3" name="">
+            <a:extLst xmlns:a="http://schemas.openxmlformats.org/drawingml/2006/main">
+              <a:ext uri="{FF2B5EF4-FFF2-40B4-BE49-F238E27FC236}">
+                <a16:creationId xmlns:a16="http://schemas.microsoft.com/office/drawing/2014/main" id="{5936DE6C-08FD-416F-B975-85F5F8D6F34B}"/>
               </a:ext>
             </a:extLst>
           </p:cNvPr>
@@ -5263,6 +5298,9 @@
                 <a:solidFill>
                   <a:srgbClr val="102033"/>
                 </a:solidFill>
+                <a:latin typeface="Poppins"/>
+                <a:ea typeface="Poppins"/>
+                <a:cs typeface="Poppins"/>
               </a:defRPr>
             </a:pPr>
             <a:r>
@@ -5270,6 +5308,9 @@
                 <a:solidFill>
                   <a:srgbClr val="102033"/>
                 </a:solidFill>
+                <a:latin typeface="Poppins"/>
+                <a:ea typeface="Poppins"/>
+                <a:cs typeface="Poppins"/>
               </a:rPr>
               <a:t>Technical Arsenal</a:t>
             </a:r>
@@ -5278,10 +5319,10 @@
       </p:sp>
       <p:sp>
         <p:nvSpPr>
-          <p:cNvPr id="5" name="">
-            <a:extLst xmlns:a="http://schemas.openxmlformats.org/drawingml/2006/main">
-              <a:ext uri="{FF2B5EF4-FFF2-40B4-BE49-F238E27FC236}">
-                <a16:creationId xmlns:a16="http://schemas.microsoft.com/office/drawing/2014/main" id="{11233D00-A68C-4DA2-A891-826B62C5672E}"/>
+          <p:cNvPr id="4" name="">
+            <a:extLst xmlns:a="http://schemas.openxmlformats.org/drawingml/2006/main">
+              <a:ext uri="{FF2B5EF4-FFF2-40B4-BE49-F238E27FC236}">
+                <a16:creationId xmlns:a16="http://schemas.microsoft.com/office/drawing/2014/main" id="{F593BF72-EB27-409E-BB9F-3C428B03BDB0}"/>
               </a:ext>
             </a:extLst>
           </p:cNvPr>
@@ -5313,6 +5354,9 @@
                 <a:solidFill>
                   <a:srgbClr val="5A6678"/>
                 </a:solidFill>
+                <a:latin typeface="Lato"/>
+                <a:ea typeface="Lato"/>
+                <a:cs typeface="Lato"/>
               </a:defRPr>
             </a:pPr>
             <a:r>
@@ -5320,6 +5364,9 @@
                 <a:solidFill>
                   <a:srgbClr val="5A6678"/>
                 </a:solidFill>
+                <a:latin typeface="Lato"/>
+                <a:ea typeface="Lato"/>
+                <a:cs typeface="Lato"/>
               </a:rPr>
               <a:t>A practical stack for building useful, reviewable, and deployable AI systems.</a:t>
             </a:r>
@@ -5328,10 +5375,10 @@
       </p:sp>
       <p:sp>
         <p:nvSpPr>
-          <p:cNvPr id="6" name="">
-            <a:extLst xmlns:a="http://schemas.openxmlformats.org/drawingml/2006/main">
-              <a:ext uri="{FF2B5EF4-FFF2-40B4-BE49-F238E27FC236}">
-                <a16:creationId xmlns:a16="http://schemas.microsoft.com/office/drawing/2014/main" id="{B5ECF3E9-950D-4A36-989A-6FDBE9790D77}"/>
+          <p:cNvPr id="5" name="">
+            <a:extLst xmlns:a="http://schemas.openxmlformats.org/drawingml/2006/main">
+              <a:ext uri="{FF2B5EF4-FFF2-40B4-BE49-F238E27FC236}">
+                <a16:creationId xmlns:a16="http://schemas.microsoft.com/office/drawing/2014/main" id="{0DF20BA6-94ED-41A5-BDD3-4E2C4338F69E}"/>
               </a:ext>
             </a:extLst>
           </p:cNvPr>
@@ -5363,6 +5410,9 @@
                 <a:solidFill>
                   <a:srgbClr val="102033"/>
                 </a:solidFill>
+                <a:latin typeface="Lato"/>
+                <a:ea typeface="Lato"/>
+                <a:cs typeface="Lato"/>
               </a:defRPr>
             </a:pPr>
             <a:r>
@@ -5370,6 +5420,9 @@
                 <a:solidFill>
                   <a:srgbClr val="102033"/>
                 </a:solidFill>
+                <a:latin typeface="Lato"/>
+                <a:ea typeface="Lato"/>
+                <a:cs typeface="Lato"/>
               </a:rPr>
               <a:t>AI/NLP</a:t>
             </a:r>
@@ -5378,10 +5431,10 @@
       </p:sp>
       <p:sp>
         <p:nvSpPr>
-          <p:cNvPr id="7" name="">
-            <a:extLst xmlns:a="http://schemas.openxmlformats.org/drawingml/2006/main">
-              <a:ext uri="{FF2B5EF4-FFF2-40B4-BE49-F238E27FC236}">
-                <a16:creationId xmlns:a16="http://schemas.microsoft.com/office/drawing/2014/main" id="{24D846C1-A924-4DE4-95FF-A75863458F74}"/>
+          <p:cNvPr id="6" name="">
+            <a:extLst xmlns:a="http://schemas.openxmlformats.org/drawingml/2006/main">
+              <a:ext uri="{FF2B5EF4-FFF2-40B4-BE49-F238E27FC236}">
+                <a16:creationId xmlns:a16="http://schemas.microsoft.com/office/drawing/2014/main" id="{4C8E2566-A620-49CF-904C-E7DF14796A64}"/>
               </a:ext>
             </a:extLst>
           </p:cNvPr>
@@ -5415,6 +5468,9 @@
                 <a:solidFill>
                   <a:srgbClr val="5A6678"/>
                 </a:solidFill>
+                <a:latin typeface="Lato"/>
+                <a:ea typeface="Lato"/>
+                <a:cs typeface="Lato"/>
               </a:defRPr>
             </a:pPr>
             <a:r>
@@ -5422,6 +5478,9 @@
                 <a:solidFill>
                   <a:srgbClr val="5A6678"/>
                 </a:solidFill>
+                <a:latin typeface="Lato"/>
+                <a:ea typeface="Lato"/>
+                <a:cs typeface="Lato"/>
               </a:rPr>
               <a:t>Topic modeling, summarization, embeddings, sentiment, NER</a:t>
             </a:r>
@@ -5430,10 +5489,10 @@
       </p:sp>
       <p:sp>
         <p:nvSpPr>
-          <p:cNvPr id="8" name="">
-            <a:extLst xmlns:a="http://schemas.openxmlformats.org/drawingml/2006/main">
-              <a:ext uri="{FF2B5EF4-FFF2-40B4-BE49-F238E27FC236}">
-                <a16:creationId xmlns:a16="http://schemas.microsoft.com/office/drawing/2014/main" id="{D7D0E6F8-61E0-4CD9-87DE-BAA3CB4E8E41}"/>
+          <p:cNvPr id="7" name="">
+            <a:extLst xmlns:a="http://schemas.openxmlformats.org/drawingml/2006/main">
+              <a:ext uri="{FF2B5EF4-FFF2-40B4-BE49-F238E27FC236}">
+                <a16:creationId xmlns:a16="http://schemas.microsoft.com/office/drawing/2014/main" id="{02139160-B158-4EEB-A3E9-32DA593D796A}"/>
               </a:ext>
             </a:extLst>
           </p:cNvPr>
@@ -5464,10 +5523,10 @@
       </p:sp>
       <p:sp>
         <p:nvSpPr>
-          <p:cNvPr id="9" name="">
-            <a:extLst xmlns:a="http://schemas.openxmlformats.org/drawingml/2006/main">
-              <a:ext uri="{FF2B5EF4-FFF2-40B4-BE49-F238E27FC236}">
-                <a16:creationId xmlns:a16="http://schemas.microsoft.com/office/drawing/2014/main" id="{AF2745D0-64AB-457C-9962-8C505A1F3D48}"/>
+          <p:cNvPr id="8" name="">
+            <a:extLst xmlns:a="http://schemas.openxmlformats.org/drawingml/2006/main">
+              <a:ext uri="{FF2B5EF4-FFF2-40B4-BE49-F238E27FC236}">
+                <a16:creationId xmlns:a16="http://schemas.microsoft.com/office/drawing/2014/main" id="{DEBFD710-6D5D-4D61-9ACF-45BA2EA73296}"/>
               </a:ext>
             </a:extLst>
           </p:cNvPr>
@@ -5498,10 +5557,10 @@
       </p:sp>
       <p:sp>
         <p:nvSpPr>
-          <p:cNvPr id="10" name="">
-            <a:extLst xmlns:a="http://schemas.openxmlformats.org/drawingml/2006/main">
-              <a:ext uri="{FF2B5EF4-FFF2-40B4-BE49-F238E27FC236}">
-                <a16:creationId xmlns:a16="http://schemas.microsoft.com/office/drawing/2014/main" id="{386BA676-1CEB-4E67-B299-721AE9ADE13F}"/>
+          <p:cNvPr id="9" name="">
+            <a:extLst xmlns:a="http://schemas.openxmlformats.org/drawingml/2006/main">
+              <a:ext uri="{FF2B5EF4-FFF2-40B4-BE49-F238E27FC236}">
+                <a16:creationId xmlns:a16="http://schemas.microsoft.com/office/drawing/2014/main" id="{EF1D1DE0-9640-4F7B-91B9-3E1AA06D175E}"/>
               </a:ext>
             </a:extLst>
           </p:cNvPr>
@@ -5533,6 +5592,9 @@
                 <a:solidFill>
                   <a:srgbClr val="102033"/>
                 </a:solidFill>
+                <a:latin typeface="Lato"/>
+                <a:ea typeface="Lato"/>
+                <a:cs typeface="Lato"/>
               </a:defRPr>
             </a:pPr>
             <a:r>
@@ -5540,6 +5602,9 @@
                 <a:solidFill>
                   <a:srgbClr val="102033"/>
                 </a:solidFill>
+                <a:latin typeface="Lato"/>
+                <a:ea typeface="Lato"/>
+                <a:cs typeface="Lato"/>
               </a:rPr>
               <a:t>Agents</a:t>
             </a:r>
@@ -5548,10 +5613,10 @@
       </p:sp>
       <p:sp>
         <p:nvSpPr>
-          <p:cNvPr id="11" name="">
-            <a:extLst xmlns:a="http://schemas.openxmlformats.org/drawingml/2006/main">
-              <a:ext uri="{FF2B5EF4-FFF2-40B4-BE49-F238E27FC236}">
-                <a16:creationId xmlns:a16="http://schemas.microsoft.com/office/drawing/2014/main" id="{B214BF4B-A4D3-4A15-8F46-FF5B1F76B6DC}"/>
+          <p:cNvPr id="10" name="">
+            <a:extLst xmlns:a="http://schemas.openxmlformats.org/drawingml/2006/main">
+              <a:ext uri="{FF2B5EF4-FFF2-40B4-BE49-F238E27FC236}">
+                <a16:creationId xmlns:a16="http://schemas.microsoft.com/office/drawing/2014/main" id="{8D53243A-25EF-41BF-BFB0-0416F7954433}"/>
               </a:ext>
             </a:extLst>
           </p:cNvPr>
@@ -5585,6 +5650,9 @@
                 <a:solidFill>
                   <a:srgbClr val="5A6678"/>
                 </a:solidFill>
+                <a:latin typeface="Lato"/>
+                <a:ea typeface="Lato"/>
+                <a:cs typeface="Lato"/>
               </a:defRPr>
             </a:pPr>
             <a:r>
@@ -5592,6 +5660,9 @@
                 <a:solidFill>
                   <a:srgbClr val="5A6678"/>
                 </a:solidFill>
+                <a:latin typeface="Lato"/>
+                <a:ea typeface="Lato"/>
+                <a:cs typeface="Lato"/>
               </a:rPr>
               <a:t>LangGraph workflows, routing, tool orchestration, human approval</a:t>
             </a:r>
@@ -5600,10 +5671,10 @@
       </p:sp>
       <p:sp>
         <p:nvSpPr>
-          <p:cNvPr id="12" name="">
-            <a:extLst xmlns:a="http://schemas.openxmlformats.org/drawingml/2006/main">
-              <a:ext uri="{FF2B5EF4-FFF2-40B4-BE49-F238E27FC236}">
-                <a16:creationId xmlns:a16="http://schemas.microsoft.com/office/drawing/2014/main" id="{5C98E337-7760-4BDD-B106-D88689A63E5C}"/>
+          <p:cNvPr id="11" name="">
+            <a:extLst xmlns:a="http://schemas.openxmlformats.org/drawingml/2006/main">
+              <a:ext uri="{FF2B5EF4-FFF2-40B4-BE49-F238E27FC236}">
+                <a16:creationId xmlns:a16="http://schemas.microsoft.com/office/drawing/2014/main" id="{88805B4B-A27F-48F2-9653-F1DA4CD6C9C4}"/>
               </a:ext>
             </a:extLst>
           </p:cNvPr>
@@ -5634,10 +5705,10 @@
       </p:sp>
       <p:sp>
         <p:nvSpPr>
-          <p:cNvPr id="13" name="">
-            <a:extLst xmlns:a="http://schemas.openxmlformats.org/drawingml/2006/main">
-              <a:ext uri="{FF2B5EF4-FFF2-40B4-BE49-F238E27FC236}">
-                <a16:creationId xmlns:a16="http://schemas.microsoft.com/office/drawing/2014/main" id="{0F69A1AC-AA7D-40B0-97D5-477EE243FB51}"/>
+          <p:cNvPr id="12" name="">
+            <a:extLst xmlns:a="http://schemas.openxmlformats.org/drawingml/2006/main">
+              <a:ext uri="{FF2B5EF4-FFF2-40B4-BE49-F238E27FC236}">
+                <a16:creationId xmlns:a16="http://schemas.microsoft.com/office/drawing/2014/main" id="{19491E0B-5374-4C51-93AA-2E4713B4EC5C}"/>
               </a:ext>
             </a:extLst>
           </p:cNvPr>
@@ -5668,10 +5739,10 @@
       </p:sp>
       <p:sp>
         <p:nvSpPr>
-          <p:cNvPr id="14" name="">
-            <a:extLst xmlns:a="http://schemas.openxmlformats.org/drawingml/2006/main">
-              <a:ext uri="{FF2B5EF4-FFF2-40B4-BE49-F238E27FC236}">
-                <a16:creationId xmlns:a16="http://schemas.microsoft.com/office/drawing/2014/main" id="{A1206855-14DD-4B0C-A685-7105585A51F4}"/>
+          <p:cNvPr id="13" name="">
+            <a:extLst xmlns:a="http://schemas.openxmlformats.org/drawingml/2006/main">
+              <a:ext uri="{FF2B5EF4-FFF2-40B4-BE49-F238E27FC236}">
+                <a16:creationId xmlns:a16="http://schemas.microsoft.com/office/drawing/2014/main" id="{3EE7923C-C077-4032-805F-44C166E93B24}"/>
               </a:ext>
             </a:extLst>
           </p:cNvPr>
@@ -5703,6 +5774,9 @@
                 <a:solidFill>
                   <a:srgbClr val="102033"/>
                 </a:solidFill>
+                <a:latin typeface="Lato"/>
+                <a:ea typeface="Lato"/>
+                <a:cs typeface="Lato"/>
               </a:defRPr>
             </a:pPr>
             <a:r>
@@ -5710,6 +5784,9 @@
                 <a:solidFill>
                   <a:srgbClr val="102033"/>
                 </a:solidFill>
+                <a:latin typeface="Lato"/>
+                <a:ea typeface="Lato"/>
+                <a:cs typeface="Lato"/>
               </a:rPr>
               <a:t>Backend</a:t>
             </a:r>
@@ -5718,10 +5795,10 @@
       </p:sp>
       <p:sp>
         <p:nvSpPr>
-          <p:cNvPr id="15" name="">
-            <a:extLst xmlns:a="http://schemas.openxmlformats.org/drawingml/2006/main">
-              <a:ext uri="{FF2B5EF4-FFF2-40B4-BE49-F238E27FC236}">
-                <a16:creationId xmlns:a16="http://schemas.microsoft.com/office/drawing/2014/main" id="{2DA92455-0B3E-4843-9197-FECA8F0F7F81}"/>
+          <p:cNvPr id="14" name="">
+            <a:extLst xmlns:a="http://schemas.openxmlformats.org/drawingml/2006/main">
+              <a:ext uri="{FF2B5EF4-FFF2-40B4-BE49-F238E27FC236}">
+                <a16:creationId xmlns:a16="http://schemas.microsoft.com/office/drawing/2014/main" id="{00A314D7-76BD-409C-AC5B-17F58F1431BB}"/>
               </a:ext>
             </a:extLst>
           </p:cNvPr>
@@ -5755,6 +5832,9 @@
                 <a:solidFill>
                   <a:srgbClr val="5A6678"/>
                 </a:solidFill>
+                <a:latin typeface="Lato"/>
+                <a:ea typeface="Lato"/>
+                <a:cs typeface="Lato"/>
               </a:defRPr>
             </a:pPr>
             <a:r>
@@ -5762,6 +5842,9 @@
                 <a:solidFill>
                   <a:srgbClr val="5A6678"/>
                 </a:solidFill>
+                <a:latin typeface="Lato"/>
+                <a:ea typeface="Lato"/>
+                <a:cs typeface="Lato"/>
               </a:rPr>
               <a:t>FastAPI, Python, REST APIs, Postgres, Alembic, Supabase</a:t>
             </a:r>
@@ -5770,10 +5853,10 @@
       </p:sp>
       <p:sp>
         <p:nvSpPr>
-          <p:cNvPr id="16" name="">
-            <a:extLst xmlns:a="http://schemas.openxmlformats.org/drawingml/2006/main">
-              <a:ext uri="{FF2B5EF4-FFF2-40B4-BE49-F238E27FC236}">
-                <a16:creationId xmlns:a16="http://schemas.microsoft.com/office/drawing/2014/main" id="{1094481C-02EF-4B8D-91FC-89A8E14CAEFC}"/>
+          <p:cNvPr id="15" name="">
+            <a:extLst xmlns:a="http://schemas.openxmlformats.org/drawingml/2006/main">
+              <a:ext uri="{FF2B5EF4-FFF2-40B4-BE49-F238E27FC236}">
+                <a16:creationId xmlns:a16="http://schemas.microsoft.com/office/drawing/2014/main" id="{94DB9C4F-9514-4943-AEBD-08FC152929F4}"/>
               </a:ext>
             </a:extLst>
           </p:cNvPr>
@@ -5804,10 +5887,10 @@
       </p:sp>
       <p:sp>
         <p:nvSpPr>
-          <p:cNvPr id="17" name="">
-            <a:extLst xmlns:a="http://schemas.openxmlformats.org/drawingml/2006/main">
-              <a:ext uri="{FF2B5EF4-FFF2-40B4-BE49-F238E27FC236}">
-                <a16:creationId xmlns:a16="http://schemas.microsoft.com/office/drawing/2014/main" id="{3706A2BF-44A3-46FE-8E4A-6B59A053F409}"/>
+          <p:cNvPr id="16" name="">
+            <a:extLst xmlns:a="http://schemas.openxmlformats.org/drawingml/2006/main">
+              <a:ext uri="{FF2B5EF4-FFF2-40B4-BE49-F238E27FC236}">
+                <a16:creationId xmlns:a16="http://schemas.microsoft.com/office/drawing/2014/main" id="{7C5EAD89-99F8-46F5-9F24-CBB3887F89E8}"/>
               </a:ext>
             </a:extLst>
           </p:cNvPr>
@@ -5838,10 +5921,10 @@
       </p:sp>
       <p:sp>
         <p:nvSpPr>
-          <p:cNvPr id="18" name="">
-            <a:extLst xmlns:a="http://schemas.openxmlformats.org/drawingml/2006/main">
-              <a:ext uri="{FF2B5EF4-FFF2-40B4-BE49-F238E27FC236}">
-                <a16:creationId xmlns:a16="http://schemas.microsoft.com/office/drawing/2014/main" id="{2FA93F25-EEFD-4D18-8021-6A075236966D}"/>
+          <p:cNvPr id="17" name="">
+            <a:extLst xmlns:a="http://schemas.openxmlformats.org/drawingml/2006/main">
+              <a:ext uri="{FF2B5EF4-FFF2-40B4-BE49-F238E27FC236}">
+                <a16:creationId xmlns:a16="http://schemas.microsoft.com/office/drawing/2014/main" id="{786D664D-1BEF-4C80-AD24-F49ECC9E0042}"/>
               </a:ext>
             </a:extLst>
           </p:cNvPr>
@@ -5873,6 +5956,9 @@
                 <a:solidFill>
                   <a:srgbClr val="102033"/>
                 </a:solidFill>
+                <a:latin typeface="Lato"/>
+                <a:ea typeface="Lato"/>
+                <a:cs typeface="Lato"/>
               </a:defRPr>
             </a:pPr>
             <a:r>
@@ -5880,6 +5966,9 @@
                 <a:solidFill>
                   <a:srgbClr val="102033"/>
                 </a:solidFill>
+                <a:latin typeface="Lato"/>
+                <a:ea typeface="Lato"/>
+                <a:cs typeface="Lato"/>
               </a:rPr>
               <a:t>Frontend</a:t>
             </a:r>
@@ -5888,10 +5977,10 @@
       </p:sp>
       <p:sp>
         <p:nvSpPr>
-          <p:cNvPr id="19" name="">
-            <a:extLst xmlns:a="http://schemas.openxmlformats.org/drawingml/2006/main">
-              <a:ext uri="{FF2B5EF4-FFF2-40B4-BE49-F238E27FC236}">
-                <a16:creationId xmlns:a16="http://schemas.microsoft.com/office/drawing/2014/main" id="{F6070031-F928-4AF9-8F27-CBD3D58F906C}"/>
+          <p:cNvPr id="18" name="">
+            <a:extLst xmlns:a="http://schemas.openxmlformats.org/drawingml/2006/main">
+              <a:ext uri="{FF2B5EF4-FFF2-40B4-BE49-F238E27FC236}">
+                <a16:creationId xmlns:a16="http://schemas.microsoft.com/office/drawing/2014/main" id="{43FE9EED-F90F-4E3F-B75D-015C2DB9FA4D}"/>
               </a:ext>
             </a:extLst>
           </p:cNvPr>
@@ -5925,6 +6014,9 @@
                 <a:solidFill>
                   <a:srgbClr val="5A6678"/>
                 </a:solidFill>
+                <a:latin typeface="Lato"/>
+                <a:ea typeface="Lato"/>
+                <a:cs typeface="Lato"/>
               </a:defRPr>
             </a:pPr>
             <a:r>
@@ -5932,6 +6024,9 @@
                 <a:solidFill>
                   <a:srgbClr val="5A6678"/>
                 </a:solidFill>
+                <a:latin typeface="Lato"/>
+                <a:ea typeface="Lato"/>
+                <a:cs typeface="Lato"/>
               </a:rPr>
               <a:t>Next.js, TypeScript, React dashboards, deployed interfaces</a:t>
             </a:r>
@@ -5940,10 +6035,10 @@
       </p:sp>
       <p:sp>
         <p:nvSpPr>
-          <p:cNvPr id="20" name="">
-            <a:extLst xmlns:a="http://schemas.openxmlformats.org/drawingml/2006/main">
-              <a:ext uri="{FF2B5EF4-FFF2-40B4-BE49-F238E27FC236}">
-                <a16:creationId xmlns:a16="http://schemas.microsoft.com/office/drawing/2014/main" id="{6CB2FB62-CA88-4006-AA44-E0D63CD2408E}"/>
+          <p:cNvPr id="19" name="">
+            <a:extLst xmlns:a="http://schemas.openxmlformats.org/drawingml/2006/main">
+              <a:ext uri="{FF2B5EF4-FFF2-40B4-BE49-F238E27FC236}">
+                <a16:creationId xmlns:a16="http://schemas.microsoft.com/office/drawing/2014/main" id="{EC152BCE-897D-40D2-AECE-44805FE65114}"/>
               </a:ext>
             </a:extLst>
           </p:cNvPr>
@@ -5974,10 +6069,10 @@
       </p:sp>
       <p:sp>
         <p:nvSpPr>
-          <p:cNvPr id="21" name="">
-            <a:extLst xmlns:a="http://schemas.openxmlformats.org/drawingml/2006/main">
-              <a:ext uri="{FF2B5EF4-FFF2-40B4-BE49-F238E27FC236}">
-                <a16:creationId xmlns:a16="http://schemas.microsoft.com/office/drawing/2014/main" id="{93226664-BB9E-46A9-990B-E0F533D18606}"/>
+          <p:cNvPr id="20" name="">
+            <a:extLst xmlns:a="http://schemas.openxmlformats.org/drawingml/2006/main">
+              <a:ext uri="{FF2B5EF4-FFF2-40B4-BE49-F238E27FC236}">
+                <a16:creationId xmlns:a16="http://schemas.microsoft.com/office/drawing/2014/main" id="{131E69DE-8F30-43C2-8532-686F6314E9E6}"/>
               </a:ext>
             </a:extLst>
           </p:cNvPr>
@@ -6008,10 +6103,10 @@
       </p:sp>
       <p:sp>
         <p:nvSpPr>
-          <p:cNvPr id="22" name="">
-            <a:extLst xmlns:a="http://schemas.openxmlformats.org/drawingml/2006/main">
-              <a:ext uri="{FF2B5EF4-FFF2-40B4-BE49-F238E27FC236}">
-                <a16:creationId xmlns:a16="http://schemas.microsoft.com/office/drawing/2014/main" id="{3ACF0AA3-1446-4C87-8B3D-FD8B9D21E2BC}"/>
+          <p:cNvPr id="21" name="">
+            <a:extLst xmlns:a="http://schemas.openxmlformats.org/drawingml/2006/main">
+              <a:ext uri="{FF2B5EF4-FFF2-40B4-BE49-F238E27FC236}">
+                <a16:creationId xmlns:a16="http://schemas.microsoft.com/office/drawing/2014/main" id="{889B6ED1-85A3-4B4C-A247-33683D1DD776}"/>
               </a:ext>
             </a:extLst>
           </p:cNvPr>
@@ -6043,6 +6138,9 @@
                 <a:solidFill>
                   <a:srgbClr val="102033"/>
                 </a:solidFill>
+                <a:latin typeface="Lato"/>
+                <a:ea typeface="Lato"/>
+                <a:cs typeface="Lato"/>
               </a:defRPr>
             </a:pPr>
             <a:r>
@@ -6050,6 +6148,9 @@
                 <a:solidFill>
                   <a:srgbClr val="102033"/>
                 </a:solidFill>
+                <a:latin typeface="Lato"/>
+                <a:ea typeface="Lato"/>
+                <a:cs typeface="Lato"/>
               </a:rPr>
               <a:t>Governance</a:t>
             </a:r>
@@ -6058,10 +6159,10 @@
       </p:sp>
       <p:sp>
         <p:nvSpPr>
-          <p:cNvPr id="23" name="">
-            <a:extLst xmlns:a="http://schemas.openxmlformats.org/drawingml/2006/main">
-              <a:ext uri="{FF2B5EF4-FFF2-40B4-BE49-F238E27FC236}">
-                <a16:creationId xmlns:a16="http://schemas.microsoft.com/office/drawing/2014/main" id="{4B4B2E04-211B-4EE3-989C-5695644CC9E4}"/>
+          <p:cNvPr id="22" name="">
+            <a:extLst xmlns:a="http://schemas.openxmlformats.org/drawingml/2006/main">
+              <a:ext uri="{FF2B5EF4-FFF2-40B4-BE49-F238E27FC236}">
+                <a16:creationId xmlns:a16="http://schemas.microsoft.com/office/drawing/2014/main" id="{A6E21EF2-9EB0-439F-8C37-A7E7303F603D}"/>
               </a:ext>
             </a:extLst>
           </p:cNvPr>
@@ -6095,6 +6196,9 @@
                 <a:solidFill>
                   <a:srgbClr val="5A6678"/>
                 </a:solidFill>
+                <a:latin typeface="Lato"/>
+                <a:ea typeface="Lato"/>
+                <a:cs typeface="Lato"/>
               </a:defRPr>
             </a:pPr>
             <a:r>
@@ -6102,6 +6206,9 @@
                 <a:solidFill>
                   <a:srgbClr val="5A6678"/>
                 </a:solidFill>
+                <a:latin typeface="Lato"/>
+                <a:ea typeface="Lato"/>
+                <a:cs typeface="Lato"/>
               </a:rPr>
               <a:t>NIST AI RMF, audit chains, control policies, PHI/PII practices</a:t>
             </a:r>
@@ -6110,10 +6217,10 @@
       </p:sp>
       <p:sp>
         <p:nvSpPr>
-          <p:cNvPr id="24" name="">
-            <a:extLst xmlns:a="http://schemas.openxmlformats.org/drawingml/2006/main">
-              <a:ext uri="{FF2B5EF4-FFF2-40B4-BE49-F238E27FC236}">
-                <a16:creationId xmlns:a16="http://schemas.microsoft.com/office/drawing/2014/main" id="{CDE0B96C-7225-487E-969E-140A1373C646}"/>
+          <p:cNvPr id="23" name="">
+            <a:extLst xmlns:a="http://schemas.openxmlformats.org/drawingml/2006/main">
+              <a:ext uri="{FF2B5EF4-FFF2-40B4-BE49-F238E27FC236}">
+                <a16:creationId xmlns:a16="http://schemas.microsoft.com/office/drawing/2014/main" id="{3FC8534B-C99D-4D92-926B-DCEDA0C4F250}"/>
               </a:ext>
             </a:extLst>
           </p:cNvPr>
@@ -6144,10 +6251,10 @@
       </p:sp>
       <p:sp>
         <p:nvSpPr>
-          <p:cNvPr id="25" name="">
-            <a:extLst xmlns:a="http://schemas.openxmlformats.org/drawingml/2006/main">
-              <a:ext uri="{FF2B5EF4-FFF2-40B4-BE49-F238E27FC236}">
-                <a16:creationId xmlns:a16="http://schemas.microsoft.com/office/drawing/2014/main" id="{D216944C-ADE6-4C3F-95BF-B9F9824813D4}"/>
+          <p:cNvPr id="24" name="">
+            <a:extLst xmlns:a="http://schemas.openxmlformats.org/drawingml/2006/main">
+              <a:ext uri="{FF2B5EF4-FFF2-40B4-BE49-F238E27FC236}">
+                <a16:creationId xmlns:a16="http://schemas.microsoft.com/office/drawing/2014/main" id="{CC8CD895-6121-4BB8-AF45-FE834EB12296}"/>
               </a:ext>
             </a:extLst>
           </p:cNvPr>
@@ -6178,10 +6285,10 @@
       </p:sp>
       <p:sp>
         <p:nvSpPr>
-          <p:cNvPr id="26" name="">
-            <a:extLst xmlns:a="http://schemas.openxmlformats.org/drawingml/2006/main">
-              <a:ext uri="{FF2B5EF4-FFF2-40B4-BE49-F238E27FC236}">
-                <a16:creationId xmlns:a16="http://schemas.microsoft.com/office/drawing/2014/main" id="{7D44F07A-A9D6-40B8-92B7-60A268AA2F09}"/>
+          <p:cNvPr id="25" name="">
+            <a:extLst xmlns:a="http://schemas.openxmlformats.org/drawingml/2006/main">
+              <a:ext uri="{FF2B5EF4-FFF2-40B4-BE49-F238E27FC236}">
+                <a16:creationId xmlns:a16="http://schemas.microsoft.com/office/drawing/2014/main" id="{94C124D9-F4FC-4B0F-8144-5C576C4F36A2}"/>
               </a:ext>
             </a:extLst>
           </p:cNvPr>
@@ -6213,6 +6320,9 @@
                 <a:solidFill>
                   <a:srgbClr val="5A6678"/>
                 </a:solidFill>
+                <a:latin typeface="Lato"/>
+                <a:ea typeface="Lato"/>
+                <a:cs typeface="Lato"/>
               </a:defRPr>
             </a:pPr>
             <a:r>
@@ -6220,18 +6330,21 @@
                 <a:solidFill>
                   <a:srgbClr val="5A6678"/>
                 </a:solidFill>
-              </a:rPr>
-              <a:t>github.com/icheftech/AI-Portfolio-Leroy-Brown</a:t>
-            </a:r>
-          </a:p>
-        </p:txBody>
-      </p:sp>
-      <p:sp>
-        <p:nvSpPr>
-          <p:cNvPr id="27" name="">
-            <a:extLst xmlns:a="http://schemas.openxmlformats.org/drawingml/2006/main">
-              <a:ext uri="{FF2B5EF4-FFF2-40B4-BE49-F238E27FC236}">
-                <a16:creationId xmlns:a16="http://schemas.microsoft.com/office/drawing/2014/main" id="{FD4229C0-0323-410B-9D93-20F82D0896C1}"/>
+                <a:latin typeface="Lato"/>
+                <a:ea typeface="Lato"/>
+                <a:cs typeface="Lato"/>
+              </a:rPr>
+              <a:t>github.com/icheftech/Leroy-Brown-HCC-AI-Portfolio</a:t>
+            </a:r>
+          </a:p>
+        </p:txBody>
+      </p:sp>
+      <p:sp>
+        <p:nvSpPr>
+          <p:cNvPr id="26" name="">
+            <a:extLst xmlns:a="http://schemas.openxmlformats.org/drawingml/2006/main">
+              <a:ext uri="{FF2B5EF4-FFF2-40B4-BE49-F238E27FC236}">
+                <a16:creationId xmlns:a16="http://schemas.microsoft.com/office/drawing/2014/main" id="{10AF8480-E74B-4D9D-9085-305F8EC74554}"/>
               </a:ext>
             </a:extLst>
           </p:cNvPr>
@@ -6263,6 +6376,9 @@
                 <a:solidFill>
                   <a:srgbClr val="5A6678"/>
                 </a:solidFill>
+                <a:latin typeface="Lato"/>
+                <a:ea typeface="Lato"/>
+                <a:cs typeface="Lato"/>
               </a:defRPr>
             </a:pPr>
             <a:r>
@@ -6270,6 +6386,9 @@
                 <a:solidFill>
                   <a:srgbClr val="5A6678"/>
                 </a:solidFill>
+                <a:latin typeface="Lato"/>
+                <a:ea typeface="Lato"/>
+                <a:cs typeface="Lato"/>
               </a:rPr>
               <a:t>Applied AI &amp; Robotics Portfolio</a:t>
             </a:r>
@@ -6279,7 +6398,7 @@
     </p:spTree>
     <p:extLst>
       <p:ext uri="{BB962C8B-B14F-4D97-AF65-F5344CB8AC3E}">
-        <p14:creationId xmlns:p14="http://schemas.microsoft.com/office/powerpoint/2010/main" val="740373407"/>
+        <p14:creationId xmlns:p14="http://schemas.microsoft.com/office/powerpoint/2010/main" val="704590191"/>
       </p:ext>
     </p:extLst>
   </p:cSld>
@@ -6307,42 +6426,10 @@
       </p:grpSpPr>
       <p:sp>
         <p:nvSpPr>
-          <p:cNvPr id="1" name="Slide Number Placeholder 5">
-            <a:extLst xmlns:a="http://schemas.openxmlformats.org/drawingml/2006/main">
-              <a:ext uri="{FF2B5EF4-FFF2-40B4-BE49-F238E27FC236}">
-                <a16:creationId xmlns:a16="http://schemas.microsoft.com/office/drawing/2014/main" id="{B8270420-D236-4471-AE86-CB207C63A521}"/>
-              </a:ext>
-            </a:extLst>
-          </p:cNvPr>
-          <p:cNvSpPr>
-            <a:spLocks xmlns:a="http://schemas.openxmlformats.org/drawingml/2006/main" noGrp="1"/>
-          </p:cNvSpPr>
-          <p:nvPr>
-            <p:ph type="sldNum" idx="12"/>
-          </p:nvPr>
-        </p:nvSpPr>
-        <p:spPr>
-          <a:xfrm xmlns:a="http://schemas.openxmlformats.org/drawingml/2006/main">
-            <a:off x="1524000" y="1122363"/>
-            <a:ext cx="9144000" cy="2387600"/>
-          </a:xfrm>
-        </p:spPr>
-        <p:txBody>
-          <a:bodyPr xmlns:a="http://schemas.openxmlformats.org/drawingml/2006/main"/>
-          <a:lstStyle xmlns:a="http://schemas.openxmlformats.org/drawingml/2006/main"/>
-          <a:p xmlns:a="http://schemas.openxmlformats.org/drawingml/2006/main">
-            <a:r>
-              <a:t/>
-            </a:r>
-          </a:p>
-        </p:txBody>
-      </p:sp>
-      <p:sp>
-        <p:nvSpPr>
-          <p:cNvPr id="2" name="">
-            <a:extLst xmlns:a="http://schemas.openxmlformats.org/drawingml/2006/main">
-              <a:ext uri="{FF2B5EF4-FFF2-40B4-BE49-F238E27FC236}">
-                <a16:creationId xmlns:a16="http://schemas.microsoft.com/office/drawing/2014/main" id="{6D5123B1-4B25-4404-9B10-63BA5A3B61AB}"/>
+          <p:cNvPr id="1" name="">
+            <a:extLst xmlns:a="http://schemas.openxmlformats.org/drawingml/2006/main">
+              <a:ext uri="{FF2B5EF4-FFF2-40B4-BE49-F238E27FC236}">
+                <a16:creationId xmlns:a16="http://schemas.microsoft.com/office/drawing/2014/main" id="{42683A1B-AA31-43E9-9D72-7B1D60541B0B}"/>
               </a:ext>
             </a:extLst>
           </p:cNvPr>
@@ -6371,10 +6458,10 @@
       </p:sp>
       <p:sp>
         <p:nvSpPr>
-          <p:cNvPr id="3" name="">
-            <a:extLst xmlns:a="http://schemas.openxmlformats.org/drawingml/2006/main">
-              <a:ext uri="{FF2B5EF4-FFF2-40B4-BE49-F238E27FC236}">
-                <a16:creationId xmlns:a16="http://schemas.microsoft.com/office/drawing/2014/main" id="{1CA3CBEC-7C97-4F90-9DF4-0E4292EA217B}"/>
+          <p:cNvPr id="2" name="">
+            <a:extLst xmlns:a="http://schemas.openxmlformats.org/drawingml/2006/main">
+              <a:ext uri="{FF2B5EF4-FFF2-40B4-BE49-F238E27FC236}">
+                <a16:creationId xmlns:a16="http://schemas.microsoft.com/office/drawing/2014/main" id="{6F49F89C-E65A-4117-B2ED-65801DE7FFC4}"/>
               </a:ext>
             </a:extLst>
           </p:cNvPr>
@@ -6403,10 +6490,10 @@
       </p:sp>
       <p:sp>
         <p:nvSpPr>
-          <p:cNvPr id="4" name="">
-            <a:extLst xmlns:a="http://schemas.openxmlformats.org/drawingml/2006/main">
-              <a:ext uri="{FF2B5EF4-FFF2-40B4-BE49-F238E27FC236}">
-                <a16:creationId xmlns:a16="http://schemas.microsoft.com/office/drawing/2014/main" id="{F9144020-26FC-48CA-91A4-271E5B69CEDB}"/>
+          <p:cNvPr id="3" name="">
+            <a:extLst xmlns:a="http://schemas.openxmlformats.org/drawingml/2006/main">
+              <a:ext uri="{FF2B5EF4-FFF2-40B4-BE49-F238E27FC236}">
+                <a16:creationId xmlns:a16="http://schemas.microsoft.com/office/drawing/2014/main" id="{1B290CB8-24FD-4CA8-8D3E-5FA7B83D455A}"/>
               </a:ext>
             </a:extLst>
           </p:cNvPr>
@@ -6438,6 +6525,9 @@
                 <a:solidFill>
                   <a:srgbClr val="102033"/>
                 </a:solidFill>
+                <a:latin typeface="Poppins"/>
+                <a:ea typeface="Poppins"/>
+                <a:cs typeface="Poppins"/>
               </a:defRPr>
             </a:pPr>
             <a:r>
@@ -6445,6 +6535,9 @@
                 <a:solidFill>
                   <a:srgbClr val="102033"/>
                 </a:solidFill>
+                <a:latin typeface="Poppins"/>
+                <a:ea typeface="Poppins"/>
+                <a:cs typeface="Poppins"/>
               </a:rPr>
               <a:t>Reflection &amp; Next Steps</a:t>
             </a:r>
@@ -6453,10 +6546,10 @@
       </p:sp>
       <p:sp>
         <p:nvSpPr>
-          <p:cNvPr id="5" name="">
-            <a:extLst xmlns:a="http://schemas.openxmlformats.org/drawingml/2006/main">
-              <a:ext uri="{FF2B5EF4-FFF2-40B4-BE49-F238E27FC236}">
-                <a16:creationId xmlns:a16="http://schemas.microsoft.com/office/drawing/2014/main" id="{CEFDF3BA-0DC2-432E-BA30-BF0543D1F7F8}"/>
+          <p:cNvPr id="4" name="">
+            <a:extLst xmlns:a="http://schemas.openxmlformats.org/drawingml/2006/main">
+              <a:ext uri="{FF2B5EF4-FFF2-40B4-BE49-F238E27FC236}">
+                <a16:creationId xmlns:a16="http://schemas.microsoft.com/office/drawing/2014/main" id="{3A025B4D-8482-4630-A1B8-4EAEE6B8FB21}"/>
               </a:ext>
             </a:extLst>
           </p:cNvPr>
@@ -6490,6 +6583,9 @@
                 <a:solidFill>
                   <a:srgbClr val="5A6678"/>
                 </a:solidFill>
+                <a:latin typeface="Lato"/>
+                <a:ea typeface="Lato"/>
+                <a:cs typeface="Lato"/>
               </a:defRPr>
             </a:pPr>
             <a:r>
@@ -6497,6 +6593,9 @@
                 <a:solidFill>
                   <a:srgbClr val="5A6678"/>
                 </a:solidFill>
+                <a:latin typeface="Lato"/>
+                <a:ea typeface="Lato"/>
+                <a:cs typeface="Lato"/>
               </a:rPr>
               <a:t>The strongest lesson: useful AI needs product thinking, controls, data flow, and clear documentation.</a:t>
             </a:r>
@@ -6505,10 +6604,10 @@
       </p:sp>
       <p:sp>
         <p:nvSpPr>
-          <p:cNvPr id="6" name="">
-            <a:extLst xmlns:a="http://schemas.openxmlformats.org/drawingml/2006/main">
-              <a:ext uri="{FF2B5EF4-FFF2-40B4-BE49-F238E27FC236}">
-                <a16:creationId xmlns:a16="http://schemas.microsoft.com/office/drawing/2014/main" id="{C10CDFC4-CCB5-427F-BF1C-1DFCE9A5DB25}"/>
+          <p:cNvPr id="5" name="">
+            <a:extLst xmlns:a="http://schemas.openxmlformats.org/drawingml/2006/main">
+              <a:ext uri="{FF2B5EF4-FFF2-40B4-BE49-F238E27FC236}">
+                <a16:creationId xmlns:a16="http://schemas.microsoft.com/office/drawing/2014/main" id="{38039809-3D35-4F92-B7A4-D63B93E4DA2F}"/>
               </a:ext>
             </a:extLst>
           </p:cNvPr>
@@ -6539,10 +6638,10 @@
       </p:sp>
       <p:sp>
         <p:nvSpPr>
-          <p:cNvPr id="7" name="">
-            <a:extLst xmlns:a="http://schemas.openxmlformats.org/drawingml/2006/main">
-              <a:ext uri="{FF2B5EF4-FFF2-40B4-BE49-F238E27FC236}">
-                <a16:creationId xmlns:a16="http://schemas.microsoft.com/office/drawing/2014/main" id="{A9E3FD9B-3F9C-43FC-B626-319FCA6591DC}"/>
+          <p:cNvPr id="6" name="">
+            <a:extLst xmlns:a="http://schemas.openxmlformats.org/drawingml/2006/main">
+              <a:ext uri="{FF2B5EF4-FFF2-40B4-BE49-F238E27FC236}">
+                <a16:creationId xmlns:a16="http://schemas.microsoft.com/office/drawing/2014/main" id="{06487222-0C6A-4910-9657-80139B3BB982}"/>
               </a:ext>
             </a:extLst>
           </p:cNvPr>
@@ -6573,10 +6672,10 @@
       </p:sp>
       <p:sp>
         <p:nvSpPr>
-          <p:cNvPr id="8" name="">
-            <a:extLst xmlns:a="http://schemas.openxmlformats.org/drawingml/2006/main">
-              <a:ext uri="{FF2B5EF4-FFF2-40B4-BE49-F238E27FC236}">
-                <a16:creationId xmlns:a16="http://schemas.microsoft.com/office/drawing/2014/main" id="{21EED3F8-2CFC-4100-9219-63554DC87189}"/>
+          <p:cNvPr id="7" name="">
+            <a:extLst xmlns:a="http://schemas.openxmlformats.org/drawingml/2006/main">
+              <a:ext uri="{FF2B5EF4-FFF2-40B4-BE49-F238E27FC236}">
+                <a16:creationId xmlns:a16="http://schemas.microsoft.com/office/drawing/2014/main" id="{26842B6E-1997-4E79-92E1-538D80A3AB5F}"/>
               </a:ext>
             </a:extLst>
           </p:cNvPr>
@@ -6605,10 +6704,10 @@
       </p:sp>
       <p:sp>
         <p:nvSpPr>
-          <p:cNvPr id="9" name="">
-            <a:extLst xmlns:a="http://schemas.openxmlformats.org/drawingml/2006/main">
-              <a:ext uri="{FF2B5EF4-FFF2-40B4-BE49-F238E27FC236}">
-                <a16:creationId xmlns:a16="http://schemas.microsoft.com/office/drawing/2014/main" id="{1B044802-C2FC-41B2-A5DC-A5C3EBC38F10}"/>
+          <p:cNvPr id="8" name="">
+            <a:extLst xmlns:a="http://schemas.openxmlformats.org/drawingml/2006/main">
+              <a:ext uri="{FF2B5EF4-FFF2-40B4-BE49-F238E27FC236}">
+                <a16:creationId xmlns:a16="http://schemas.microsoft.com/office/drawing/2014/main" id="{9EA0D3D7-85A7-4EFA-85A0-8DF9648A6569}"/>
               </a:ext>
             </a:extLst>
           </p:cNvPr>
@@ -6640,6 +6739,9 @@
                 <a:solidFill>
                   <a:srgbClr val="102033"/>
                 </a:solidFill>
+                <a:latin typeface="Lato"/>
+                <a:ea typeface="Lato"/>
+                <a:cs typeface="Lato"/>
               </a:defRPr>
             </a:pPr>
             <a:r>
@@ -6647,6 +6749,9 @@
                 <a:solidFill>
                   <a:srgbClr val="102033"/>
                 </a:solidFill>
+                <a:latin typeface="Lato"/>
+                <a:ea typeface="Lato"/>
+                <a:cs typeface="Lato"/>
               </a:rPr>
               <a:t>Where I am growing</a:t>
             </a:r>
@@ -6655,10 +6760,10 @@
       </p:sp>
       <p:sp>
         <p:nvSpPr>
-          <p:cNvPr id="10" name="">
-            <a:extLst xmlns:a="http://schemas.openxmlformats.org/drawingml/2006/main">
-              <a:ext uri="{FF2B5EF4-FFF2-40B4-BE49-F238E27FC236}">
-                <a16:creationId xmlns:a16="http://schemas.microsoft.com/office/drawing/2014/main" id="{D24DC06A-FB8B-46F4-9995-6742B07CEDBF}"/>
+          <p:cNvPr id="9" name="">
+            <a:extLst xmlns:a="http://schemas.openxmlformats.org/drawingml/2006/main">
+              <a:ext uri="{FF2B5EF4-FFF2-40B4-BE49-F238E27FC236}">
+                <a16:creationId xmlns:a16="http://schemas.microsoft.com/office/drawing/2014/main" id="{3257C436-CF06-467D-A983-C9543302C9F9}"/>
               </a:ext>
             </a:extLst>
           </p:cNvPr>
@@ -6692,6 +6797,9 @@
                 <a:solidFill>
                   <a:srgbClr val="5A6678"/>
                 </a:solidFill>
+                <a:latin typeface="Lato"/>
+                <a:ea typeface="Lato"/>
+                <a:cs typeface="Lato"/>
               </a:defRPr>
             </a:pPr>
             <a:r>
@@ -6699,6 +6807,9 @@
                 <a:solidFill>
                   <a:srgbClr val="5A6678"/>
                 </a:solidFill>
+                <a:latin typeface="Lato"/>
+                <a:ea typeface="Lato"/>
+                <a:cs typeface="Lato"/>
               </a:rPr>
               <a:t>Production-grade AI services</a:t>
             </a:r>
@@ -6709,6 +6820,9 @@
                 <a:solidFill>
                   <a:srgbClr val="5A6678"/>
                 </a:solidFill>
+                <a:latin typeface="Lato"/>
+                <a:ea typeface="Lato"/>
+                <a:cs typeface="Lato"/>
               </a:defRPr>
             </a:pPr>
             <a:r>
@@ -6716,6 +6830,9 @@
                 <a:solidFill>
                   <a:srgbClr val="5A6678"/>
                 </a:solidFill>
+                <a:latin typeface="Lato"/>
+                <a:ea typeface="Lato"/>
+                <a:cs typeface="Lato"/>
               </a:rPr>
               <a:t>Responsible automation with human oversight</a:t>
             </a:r>
@@ -6726,6 +6843,9 @@
                 <a:solidFill>
                   <a:srgbClr val="5A6678"/>
                 </a:solidFill>
+                <a:latin typeface="Lato"/>
+                <a:ea typeface="Lato"/>
+                <a:cs typeface="Lato"/>
               </a:defRPr>
             </a:pPr>
             <a:r>
@@ -6733,6 +6853,9 @@
                 <a:solidFill>
                   <a:srgbClr val="5A6678"/>
                 </a:solidFill>
+                <a:latin typeface="Lato"/>
+                <a:ea typeface="Lato"/>
+                <a:cs typeface="Lato"/>
               </a:rPr>
               <a:t>Model-backed dashboards for real teams</a:t>
             </a:r>
@@ -6741,10 +6864,10 @@
       </p:sp>
       <p:sp>
         <p:nvSpPr>
-          <p:cNvPr id="11" name="">
-            <a:extLst xmlns:a="http://schemas.openxmlformats.org/drawingml/2006/main">
-              <a:ext uri="{FF2B5EF4-FFF2-40B4-BE49-F238E27FC236}">
-                <a16:creationId xmlns:a16="http://schemas.microsoft.com/office/drawing/2014/main" id="{DAE06028-5FC7-40F5-8CE0-BD3A4F350EBB}"/>
+          <p:cNvPr id="10" name="">
+            <a:extLst xmlns:a="http://schemas.openxmlformats.org/drawingml/2006/main">
+              <a:ext uri="{FF2B5EF4-FFF2-40B4-BE49-F238E27FC236}">
+                <a16:creationId xmlns:a16="http://schemas.microsoft.com/office/drawing/2014/main" id="{85649B50-AD4D-461F-A8E7-20D03676A62F}"/>
               </a:ext>
             </a:extLst>
           </p:cNvPr>
@@ -6775,10 +6898,10 @@
       </p:sp>
       <p:sp>
         <p:nvSpPr>
-          <p:cNvPr id="12" name="">
-            <a:extLst xmlns:a="http://schemas.openxmlformats.org/drawingml/2006/main">
-              <a:ext uri="{FF2B5EF4-FFF2-40B4-BE49-F238E27FC236}">
-                <a16:creationId xmlns:a16="http://schemas.microsoft.com/office/drawing/2014/main" id="{DC1EA7DC-A096-47C8-AE8B-558AF5E722F4}"/>
+          <p:cNvPr id="11" name="">
+            <a:extLst xmlns:a="http://schemas.openxmlformats.org/drawingml/2006/main">
+              <a:ext uri="{FF2B5EF4-FFF2-40B4-BE49-F238E27FC236}">
+                <a16:creationId xmlns:a16="http://schemas.microsoft.com/office/drawing/2014/main" id="{E763F09E-A713-49F6-8088-56871EEA7797}"/>
               </a:ext>
             </a:extLst>
           </p:cNvPr>
@@ -6809,10 +6932,10 @@
       </p:sp>
       <p:sp>
         <p:nvSpPr>
-          <p:cNvPr id="13" name="">
-            <a:extLst xmlns:a="http://schemas.openxmlformats.org/drawingml/2006/main">
-              <a:ext uri="{FF2B5EF4-FFF2-40B4-BE49-F238E27FC236}">
-                <a16:creationId xmlns:a16="http://schemas.microsoft.com/office/drawing/2014/main" id="{1025AD5C-662D-480E-BC8B-053F65DF8140}"/>
+          <p:cNvPr id="12" name="">
+            <a:extLst xmlns:a="http://schemas.openxmlformats.org/drawingml/2006/main">
+              <a:ext uri="{FF2B5EF4-FFF2-40B4-BE49-F238E27FC236}">
+                <a16:creationId xmlns:a16="http://schemas.microsoft.com/office/drawing/2014/main" id="{08AFCF91-D792-4974-9A9F-FA7BC25A6BBC}"/>
               </a:ext>
             </a:extLst>
           </p:cNvPr>
@@ -6841,10 +6964,10 @@
       </p:sp>
       <p:sp>
         <p:nvSpPr>
-          <p:cNvPr id="14" name="">
-            <a:extLst xmlns:a="http://schemas.openxmlformats.org/drawingml/2006/main">
-              <a:ext uri="{FF2B5EF4-FFF2-40B4-BE49-F238E27FC236}">
-                <a16:creationId xmlns:a16="http://schemas.microsoft.com/office/drawing/2014/main" id="{977CF91F-9A92-43B0-8AE5-D3DEFD538C55}"/>
+          <p:cNvPr id="13" name="">
+            <a:extLst xmlns:a="http://schemas.openxmlformats.org/drawingml/2006/main">
+              <a:ext uri="{FF2B5EF4-FFF2-40B4-BE49-F238E27FC236}">
+                <a16:creationId xmlns:a16="http://schemas.microsoft.com/office/drawing/2014/main" id="{004B704C-6663-4663-8226-A43EF56345AA}"/>
               </a:ext>
             </a:extLst>
           </p:cNvPr>
@@ -6876,6 +6999,9 @@
                 <a:solidFill>
                   <a:srgbClr val="102033"/>
                 </a:solidFill>
+                <a:latin typeface="Lato"/>
+                <a:ea typeface="Lato"/>
+                <a:cs typeface="Lato"/>
               </a:defRPr>
             </a:pPr>
             <a:r>
@@ -6883,6 +7009,9 @@
                 <a:solidFill>
                   <a:srgbClr val="102033"/>
                 </a:solidFill>
+                <a:latin typeface="Lato"/>
+                <a:ea typeface="Lato"/>
+                <a:cs typeface="Lato"/>
               </a:rPr>
               <a:t>What I am seeking</a:t>
             </a:r>
@@ -6891,10 +7020,10 @@
       </p:sp>
       <p:sp>
         <p:nvSpPr>
-          <p:cNvPr id="15" name="">
-            <a:extLst xmlns:a="http://schemas.openxmlformats.org/drawingml/2006/main">
-              <a:ext uri="{FF2B5EF4-FFF2-40B4-BE49-F238E27FC236}">
-                <a16:creationId xmlns:a16="http://schemas.microsoft.com/office/drawing/2014/main" id="{3332743F-B1BA-4CA1-B769-9E8B70B18E59}"/>
+          <p:cNvPr id="14" name="">
+            <a:extLst xmlns:a="http://schemas.openxmlformats.org/drawingml/2006/main">
+              <a:ext uri="{FF2B5EF4-FFF2-40B4-BE49-F238E27FC236}">
+                <a16:creationId xmlns:a16="http://schemas.microsoft.com/office/drawing/2014/main" id="{97A743B4-A9DA-4BAC-82E4-2243A1F4F05A}"/>
               </a:ext>
             </a:extLst>
           </p:cNvPr>
@@ -6928,6 +7057,9 @@
                 <a:solidFill>
                   <a:srgbClr val="5A6678"/>
                 </a:solidFill>
+                <a:latin typeface="Lato"/>
+                <a:ea typeface="Lato"/>
+                <a:cs typeface="Lato"/>
               </a:defRPr>
             </a:pPr>
             <a:r>
@@ -6935,6 +7067,9 @@
                 <a:solidFill>
                   <a:srgbClr val="5A6678"/>
                 </a:solidFill>
+                <a:latin typeface="Lato"/>
+                <a:ea typeface="Lato"/>
+                <a:cs typeface="Lato"/>
               </a:rPr>
               <a:t>AI engineering roles</a:t>
             </a:r>
@@ -6945,6 +7080,9 @@
                 <a:solidFill>
                   <a:srgbClr val="5A6678"/>
                 </a:solidFill>
+                <a:latin typeface="Lato"/>
+                <a:ea typeface="Lato"/>
+                <a:cs typeface="Lato"/>
               </a:defRPr>
             </a:pPr>
             <a:r>
@@ -6952,6 +7090,9 @@
                 <a:solidFill>
                   <a:srgbClr val="5A6678"/>
                 </a:solidFill>
+                <a:latin typeface="Lato"/>
+                <a:ea typeface="Lato"/>
+                <a:cs typeface="Lato"/>
               </a:rPr>
               <a:t>Applied NLP projects</a:t>
             </a:r>
@@ -6962,6 +7103,9 @@
                 <a:solidFill>
                   <a:srgbClr val="5A6678"/>
                 </a:solidFill>
+                <a:latin typeface="Lato"/>
+                <a:ea typeface="Lato"/>
+                <a:cs typeface="Lato"/>
               </a:defRPr>
             </a:pPr>
             <a:r>
@@ -6969,6 +7113,9 @@
                 <a:solidFill>
                   <a:srgbClr val="5A6678"/>
                 </a:solidFill>
+                <a:latin typeface="Lato"/>
+                <a:ea typeface="Lato"/>
+                <a:cs typeface="Lato"/>
               </a:rPr>
               <a:t>Collaborations in governance and automation</a:t>
             </a:r>
@@ -6977,10 +7124,10 @@
       </p:sp>
       <p:sp>
         <p:nvSpPr>
-          <p:cNvPr id="16" name="">
-            <a:extLst xmlns:a="http://schemas.openxmlformats.org/drawingml/2006/main">
-              <a:ext uri="{FF2B5EF4-FFF2-40B4-BE49-F238E27FC236}">
-                <a16:creationId xmlns:a16="http://schemas.microsoft.com/office/drawing/2014/main" id="{A93773D5-2401-4C2F-AE5D-0D57FFB2F468}"/>
+          <p:cNvPr id="15" name="">
+            <a:extLst xmlns:a="http://schemas.openxmlformats.org/drawingml/2006/main">
+              <a:ext uri="{FF2B5EF4-FFF2-40B4-BE49-F238E27FC236}">
+                <a16:creationId xmlns:a16="http://schemas.microsoft.com/office/drawing/2014/main" id="{667D62F5-F103-4B18-824E-FE62D026483A}"/>
               </a:ext>
             </a:extLst>
           </p:cNvPr>
@@ -7017,6 +7164,9 @@
                 <a:solidFill>
                   <a:srgbClr val="102033"/>
                 </a:solidFill>
+                <a:latin typeface="Lato"/>
+                <a:ea typeface="Lato"/>
+                <a:cs typeface="Lato"/>
               </a:defRPr>
             </a:pPr>
             <a:r>
@@ -7024,6 +7174,9 @@
                 <a:solidFill>
                   <a:srgbClr val="102033"/>
                 </a:solidFill>
+                <a:latin typeface="Lato"/>
+                <a:ea typeface="Lato"/>
+                <a:cs typeface="Lato"/>
               </a:rPr>
               <a:t>github.com/icheftech</a:t>
             </a:r>
@@ -7032,10 +7185,10 @@
       </p:sp>
       <p:sp>
         <p:nvSpPr>
-          <p:cNvPr id="17" name="">
-            <a:extLst xmlns:a="http://schemas.openxmlformats.org/drawingml/2006/main">
-              <a:ext uri="{FF2B5EF4-FFF2-40B4-BE49-F238E27FC236}">
-                <a16:creationId xmlns:a16="http://schemas.microsoft.com/office/drawing/2014/main" id="{13F3B717-EBFF-4B03-B9D9-D378323A8FBC}"/>
+          <p:cNvPr id="16" name="">
+            <a:extLst xmlns:a="http://schemas.openxmlformats.org/drawingml/2006/main">
+              <a:ext uri="{FF2B5EF4-FFF2-40B4-BE49-F238E27FC236}">
+                <a16:creationId xmlns:a16="http://schemas.microsoft.com/office/drawing/2014/main" id="{9C69A62E-E24C-40EE-BBC7-EE513F2411F6}"/>
               </a:ext>
             </a:extLst>
           </p:cNvPr>
@@ -7072,6 +7225,9 @@
                 <a:solidFill>
                   <a:srgbClr val="102033"/>
                 </a:solidFill>
+                <a:latin typeface="Lato"/>
+                <a:ea typeface="Lato"/>
+                <a:cs typeface="Lato"/>
               </a:defRPr>
             </a:pPr>
             <a:r>
@@ -7079,18 +7235,21 @@
                 <a:solidFill>
                   <a:srgbClr val="102033"/>
                 </a:solidFill>
-              </a:rPr>
-              <a:t>Portfolio: AI-Portfolio-Leroy-Brown</a:t>
-            </a:r>
-          </a:p>
-        </p:txBody>
-      </p:sp>
-      <p:sp>
-        <p:nvSpPr>
-          <p:cNvPr id="18" name="">
-            <a:extLst xmlns:a="http://schemas.openxmlformats.org/drawingml/2006/main">
-              <a:ext uri="{FF2B5EF4-FFF2-40B4-BE49-F238E27FC236}">
-                <a16:creationId xmlns:a16="http://schemas.microsoft.com/office/drawing/2014/main" id="{02CDD7FA-B675-4FD0-9404-A588B1B20FAD}"/>
+                <a:latin typeface="Lato"/>
+                <a:ea typeface="Lato"/>
+                <a:cs typeface="Lato"/>
+              </a:rPr>
+              <a:t>Portfolio: Leroy-Brown-HCC-AI-Portfolio</a:t>
+            </a:r>
+          </a:p>
+        </p:txBody>
+      </p:sp>
+      <p:sp>
+        <p:nvSpPr>
+          <p:cNvPr id="17" name="">
+            <a:extLst xmlns:a="http://schemas.openxmlformats.org/drawingml/2006/main">
+              <a:ext uri="{FF2B5EF4-FFF2-40B4-BE49-F238E27FC236}">
+                <a16:creationId xmlns:a16="http://schemas.microsoft.com/office/drawing/2014/main" id="{020F1FD1-90CB-481D-AD84-8FB8374CF21F}"/>
               </a:ext>
             </a:extLst>
           </p:cNvPr>
@@ -7127,6 +7286,9 @@
                 <a:solidFill>
                   <a:srgbClr val="102033"/>
                 </a:solidFill>
+                <a:latin typeface="Lato"/>
+                <a:ea typeface="Lato"/>
+                <a:cs typeface="Lato"/>
               </a:defRPr>
             </a:pPr>
             <a:r>
@@ -7134,6 +7296,9 @@
                 <a:solidFill>
                   <a:srgbClr val="102033"/>
                 </a:solidFill>
+                <a:latin typeface="Lato"/>
+                <a:ea typeface="Lato"/>
+                <a:cs typeface="Lato"/>
               </a:rPr>
               <a:t>LinkedIn / Email: add before final submission</a:t>
             </a:r>
@@ -7142,10 +7307,10 @@
       </p:sp>
       <p:sp>
         <p:nvSpPr>
-          <p:cNvPr id="19" name="">
-            <a:extLst xmlns:a="http://schemas.openxmlformats.org/drawingml/2006/main">
-              <a:ext uri="{FF2B5EF4-FFF2-40B4-BE49-F238E27FC236}">
-                <a16:creationId xmlns:a16="http://schemas.microsoft.com/office/drawing/2014/main" id="{8877FB81-311A-4CAC-9753-22B47157337A}"/>
+          <p:cNvPr id="18" name="">
+            <a:extLst xmlns:a="http://schemas.openxmlformats.org/drawingml/2006/main">
+              <a:ext uri="{FF2B5EF4-FFF2-40B4-BE49-F238E27FC236}">
+                <a16:creationId xmlns:a16="http://schemas.microsoft.com/office/drawing/2014/main" id="{CF35C202-A4E6-411D-950B-8944827A073C}"/>
               </a:ext>
             </a:extLst>
           </p:cNvPr>
@@ -7177,6 +7342,9 @@
                 <a:solidFill>
                   <a:srgbClr val="5A6678"/>
                 </a:solidFill>
+                <a:latin typeface="Lato"/>
+                <a:ea typeface="Lato"/>
+                <a:cs typeface="Lato"/>
               </a:defRPr>
             </a:pPr>
             <a:r>
@@ -7184,18 +7352,21 @@
                 <a:solidFill>
                   <a:srgbClr val="5A6678"/>
                 </a:solidFill>
-              </a:rPr>
-              <a:t>github.com/icheftech/AI-Portfolio-Leroy-Brown</a:t>
-            </a:r>
-          </a:p>
-        </p:txBody>
-      </p:sp>
-      <p:sp>
-        <p:nvSpPr>
-          <p:cNvPr id="20" name="">
-            <a:extLst xmlns:a="http://schemas.openxmlformats.org/drawingml/2006/main">
-              <a:ext uri="{FF2B5EF4-FFF2-40B4-BE49-F238E27FC236}">
-                <a16:creationId xmlns:a16="http://schemas.microsoft.com/office/drawing/2014/main" id="{BE2E96D9-2377-4B2A-8F63-6E64F8ED7A57}"/>
+                <a:latin typeface="Lato"/>
+                <a:ea typeface="Lato"/>
+                <a:cs typeface="Lato"/>
+              </a:rPr>
+              <a:t>github.com/icheftech/Leroy-Brown-HCC-AI-Portfolio</a:t>
+            </a:r>
+          </a:p>
+        </p:txBody>
+      </p:sp>
+      <p:sp>
+        <p:nvSpPr>
+          <p:cNvPr id="19" name="">
+            <a:extLst xmlns:a="http://schemas.openxmlformats.org/drawingml/2006/main">
+              <a:ext uri="{FF2B5EF4-FFF2-40B4-BE49-F238E27FC236}">
+                <a16:creationId xmlns:a16="http://schemas.microsoft.com/office/drawing/2014/main" id="{8F1E10AA-9055-4676-BBE1-DD0D712FB745}"/>
               </a:ext>
             </a:extLst>
           </p:cNvPr>
@@ -7227,6 +7398,9 @@
                 <a:solidFill>
                   <a:srgbClr val="5A6678"/>
                 </a:solidFill>
+                <a:latin typeface="Lato"/>
+                <a:ea typeface="Lato"/>
+                <a:cs typeface="Lato"/>
               </a:defRPr>
             </a:pPr>
             <a:r>
@@ -7234,6 +7408,9 @@
                 <a:solidFill>
                   <a:srgbClr val="5A6678"/>
                 </a:solidFill>
+                <a:latin typeface="Lato"/>
+                <a:ea typeface="Lato"/>
+                <a:cs typeface="Lato"/>
               </a:rPr>
               <a:t>Applied AI &amp; Robotics Portfolio</a:t>
             </a:r>
@@ -7243,7 +7420,7 @@
     </p:spTree>
     <p:extLst>
       <p:ext uri="{BB962C8B-B14F-4D97-AF65-F5344CB8AC3E}">
-        <p14:creationId xmlns:p14="http://schemas.microsoft.com/office/powerpoint/2010/main" val="2072429809"/>
+        <p14:creationId xmlns:p14="http://schemas.microsoft.com/office/powerpoint/2010/main" val="935790062"/>
       </p:ext>
     </p:extLst>
   </p:cSld>
@@ -7319,7 +7496,61 @@
           <a:effectLst>
             <a:outerShdw blurRad="57150" dist="19050" dir="5400000">
               <a:srgbClr val="000000">
-                <a:alpha val="63000"/>
+                <a:alpha val="16000"/>
+              </a:srgbClr>
+            </a:outerShdw>
+          </a:effectLst>
+        </a:effectStyle>
+        <a:effectStyle>
+          <a:effectLst>
+            <a:outerShdw blurRad="19050" dist="9525" dir="5400000">
+              <a:srgbClr val="000000">
+                <a:alpha val="6000"/>
+              </a:srgbClr>
+            </a:outerShdw>
+          </a:effectLst>
+        </a:effectStyle>
+        <a:effectStyle>
+          <a:effectLst>
+            <a:outerShdw blurRad="28575" dist="9525" dir="5400000">
+              <a:srgbClr val="000000">
+                <a:alpha val="8000"/>
+              </a:srgbClr>
+            </a:outerShdw>
+          </a:effectLst>
+        </a:effectStyle>
+        <a:effectStyle>
+          <a:effectLst>
+            <a:outerShdw blurRad="57150" dist="19050" dir="5400000">
+              <a:srgbClr val="000000">
+                <a:alpha val="10000"/>
+              </a:srgbClr>
+            </a:outerShdw>
+          </a:effectLst>
+        </a:effectStyle>
+        <a:effectStyle>
+          <a:effectLst>
+            <a:outerShdw blurRad="114300" dist="38100" dir="5400000">
+              <a:srgbClr val="000000">
+                <a:alpha val="12000"/>
+              </a:srgbClr>
+            </a:outerShdw>
+          </a:effectLst>
+        </a:effectStyle>
+        <a:effectStyle>
+          <a:effectLst>
+            <a:outerShdw blurRad="171450" dist="57150" dir="5400000">
+              <a:srgbClr val="000000">
+                <a:alpha val="16000"/>
+              </a:srgbClr>
+            </a:outerShdw>
+          </a:effectLst>
+        </a:effectStyle>
+        <a:effectStyle>
+          <a:effectLst>
+            <a:outerShdw blurRad="266700" dist="95250" dir="5400000">
+              <a:srgbClr val="000000">
+                <a:alpha val="24000"/>
               </a:srgbClr>
             </a:outerShdw>
           </a:effectLst>

</xml_diff>